<commit_message>
fix page numbers in the last slide
</commit_message>
<xml_diff>
--- a/docs/meeting/2026_09_23.pptx
+++ b/docs/meeting/2026_09_23.pptx
@@ -29,8 +29,8 @@
     <p:sldId id="1768" r:id="rId20"/>
     <p:sldId id="1800" r:id="rId21"/>
     <p:sldId id="1802" r:id="rId22"/>
-    <p:sldId id="262" r:id="rId23"/>
-    <p:sldId id="264" r:id="rId24"/>
+    <p:sldId id="1807" r:id="rId23"/>
+    <p:sldId id="1808" r:id="rId24"/>
     <p:sldId id="265" r:id="rId25"/>
     <p:sldId id="267" r:id="rId26"/>
     <p:sldId id="268" r:id="rId27"/>
@@ -174,8 +174,8 @@
             <p14:sldId id="1768"/>
             <p14:sldId id="1800"/>
             <p14:sldId id="1802"/>
-            <p14:sldId id="262"/>
-            <p14:sldId id="264"/>
+            <p14:sldId id="1807"/>
+            <p14:sldId id="1808"/>
             <p14:sldId id="265"/>
             <p14:sldId id="267"/>
             <p14:sldId id="268"/>
@@ -6624,9 +6624,8 @@
           <a:bodyPr/>
           <a:lstStyle/>
           <a:p>
-            <a:r>
-              <a:t>Source: I Can See U: Indicator-Based Detection of Information Operations and Topic-Aware Group Analysis. Uploaded manuscript Backbone_Graph (1).pdf. Table 1, pp. 3–4.</a:t>
-            </a:r>
+            <a:pPr lvl="0" algn="r"/>
+            <a:endParaRPr dirty="0"/>
           </a:p>
         </p:txBody>
       </p:sp>
@@ -6701,694 +6700,8 @@
           <a:bodyPr/>
           <a:lstStyle/>
           <a:p>
-            <a:pPr lvl="0" algn="r">
-              <a:buNone/>
-            </a:pPr>
-            <a:r>
-              <a:rPr b="1" dirty="0" err="1"/>
-              <a:t>האיור</a:t>
-            </a:r>
-            <a:r>
-              <a:rPr b="1" dirty="0"/>
-              <a:t> </a:t>
-            </a:r>
-            <a:r>
-              <a:rPr b="1" dirty="0" err="1"/>
-              <a:t>מציג</a:t>
-            </a:r>
-            <a:r>
-              <a:rPr b="1" dirty="0"/>
-              <a:t> </a:t>
-            </a:r>
-            <a:r>
-              <a:rPr b="1" dirty="0" err="1"/>
-              <a:t>את</a:t>
-            </a:r>
-            <a:r>
-              <a:rPr b="1" dirty="0"/>
-              <a:t> </a:t>
-            </a:r>
-            <a:r>
-              <a:rPr b="1" dirty="0" err="1"/>
-              <a:t>חשיבות</a:t>
-            </a:r>
-            <a:r>
-              <a:rPr b="1" dirty="0"/>
-              <a:t> </a:t>
-            </a:r>
-            <a:r>
-              <a:rPr b="1" dirty="0" err="1"/>
-              <a:t>המדדים</a:t>
-            </a:r>
-            <a:r>
-              <a:rPr b="1" dirty="0"/>
-              <a:t> </a:t>
-            </a:r>
-            <a:r>
-              <a:rPr b="1" dirty="0" err="1"/>
-              <a:t>בכל</a:t>
-            </a:r>
-            <a:r>
-              <a:rPr b="1" dirty="0"/>
-              <a:t> </a:t>
-            </a:r>
-            <a:r>
-              <a:rPr b="1" dirty="0" err="1"/>
-              <a:t>קמפיין</a:t>
-            </a:r>
-            <a:r>
-              <a:rPr b="1" dirty="0"/>
-              <a:t> </a:t>
-            </a:r>
-            <a:r>
-              <a:rPr b="1" dirty="0" err="1"/>
-              <a:t>עבור</a:t>
-            </a:r>
-            <a:r>
-              <a:rPr b="1" dirty="0"/>
-              <a:t> </a:t>
-            </a:r>
-            <a:r>
-              <a:rPr b="1" dirty="0" err="1"/>
-              <a:t>מסווג</a:t>
-            </a:r>
-            <a:r>
-              <a:rPr b="1" dirty="0"/>
-              <a:t> </a:t>
-            </a:r>
-            <a:r>
-              <a:rPr b="1" dirty="0" err="1"/>
-              <a:t>העצים</a:t>
-            </a:r>
-            <a:r>
-              <a:rPr b="1" dirty="0"/>
-              <a:t> </a:t>
-            </a:r>
-            <a:r>
-              <a:rPr b="1" dirty="0" err="1"/>
-              <a:t>המשופר</a:t>
-            </a:r>
-            <a:r>
-              <a:rPr b="1" dirty="0"/>
-              <a:t>, </a:t>
-            </a:r>
-            <a:r>
-              <a:rPr b="1" dirty="0" err="1"/>
-              <a:t>לפי</a:t>
-            </a:r>
-            <a:r>
-              <a:rPr b="1" dirty="0"/>
-              <a:t> </a:t>
-            </a:r>
-            <a:r>
-              <a:rPr b="1" dirty="0" err="1"/>
-              <a:t>ממוצע</a:t>
-            </a:r>
-            <a:r>
-              <a:rPr b="1" dirty="0"/>
-              <a:t> </a:t>
-            </a:r>
-            <a:r>
-              <a:rPr b="1" dirty="0" err="1"/>
-              <a:t>הערך</a:t>
-            </a:r>
-            <a:r>
-              <a:rPr b="1" dirty="0"/>
-              <a:t> </a:t>
-            </a:r>
-            <a:r>
-              <a:rPr b="1" dirty="0" err="1"/>
-              <a:t>המוחלט</a:t>
-            </a:r>
-            <a:r>
-              <a:rPr b="1" dirty="0"/>
-              <a:t> </a:t>
-            </a:r>
-            <a:r>
-              <a:rPr b="1" dirty="0" err="1"/>
-              <a:t>של</a:t>
-            </a:r>
-            <a:r>
-              <a:rPr b="1" dirty="0"/>
-              <a:t> </a:t>
-            </a:r>
-            <a:r>
-              <a:rPr b="1" dirty="0" err="1"/>
-              <a:t>תרומת</a:t>
-            </a:r>
-            <a:r>
-              <a:rPr b="1" dirty="0"/>
-              <a:t> </a:t>
-            </a:r>
-            <a:r>
-              <a:rPr b="1" dirty="0" err="1"/>
-              <a:t>כל</a:t>
-            </a:r>
-            <a:r>
-              <a:rPr b="1" dirty="0"/>
-              <a:t> </a:t>
-            </a:r>
-            <a:r>
-              <a:rPr b="1" dirty="0" err="1"/>
-              <a:t>מדד</a:t>
-            </a:r>
-            <a:r>
-              <a:rPr b="1" dirty="0"/>
-              <a:t> </a:t>
-            </a:r>
-            <a:r>
-              <a:rPr b="1" dirty="0" err="1"/>
-              <a:t>לתחזיות</a:t>
-            </a:r>
-            <a:r>
-              <a:rPr b="1" dirty="0"/>
-              <a:t>. </a:t>
-            </a:r>
-            <a:r>
-              <a:rPr b="1" dirty="0" err="1"/>
-              <a:t>עמודה</a:t>
-            </a:r>
-            <a:r>
-              <a:rPr b="1" dirty="0"/>
-              <a:t> </a:t>
-            </a:r>
-            <a:r>
-              <a:rPr b="1" dirty="0" err="1"/>
-              <a:t>ארוכה</a:t>
-            </a:r>
-            <a:r>
-              <a:rPr b="1" dirty="0"/>
-              <a:t> </a:t>
-            </a:r>
-            <a:r>
-              <a:rPr b="1" dirty="0" err="1"/>
-              <a:t>יותר</a:t>
-            </a:r>
-            <a:r>
-              <a:rPr b="1" dirty="0"/>
-              <a:t> </a:t>
-            </a:r>
-            <a:r>
-              <a:rPr b="1" dirty="0" err="1"/>
-              <a:t>משמעה</a:t>
-            </a:r>
-            <a:r>
-              <a:rPr b="1" dirty="0"/>
-              <a:t> </a:t>
-            </a:r>
-            <a:r>
-              <a:rPr b="1" dirty="0" err="1"/>
-              <a:t>השפעה</a:t>
-            </a:r>
-            <a:r>
-              <a:rPr b="1" dirty="0"/>
-              <a:t> </a:t>
-            </a:r>
-            <a:r>
-              <a:rPr b="1" dirty="0" err="1"/>
-              <a:t>גדולה</a:t>
-            </a:r>
-            <a:r>
-              <a:rPr b="1" dirty="0"/>
-              <a:t> </a:t>
-            </a:r>
-            <a:r>
-              <a:rPr b="1" dirty="0" err="1"/>
-              <a:t>יותר</a:t>
-            </a:r>
-            <a:r>
-              <a:rPr b="1" dirty="0"/>
-              <a:t> </a:t>
-            </a:r>
-            <a:r>
-              <a:rPr b="1" dirty="0" err="1"/>
-              <a:t>על</a:t>
-            </a:r>
-            <a:r>
-              <a:rPr b="1" dirty="0"/>
-              <a:t> </a:t>
-            </a:r>
-            <a:r>
-              <a:rPr b="1" dirty="0" err="1"/>
-              <a:t>פלט</a:t>
-            </a:r>
-            <a:r>
-              <a:rPr b="1" dirty="0"/>
-              <a:t> </a:t>
-            </a:r>
-            <a:r>
-              <a:rPr b="1" dirty="0" err="1"/>
-              <a:t>המודל</a:t>
-            </a:r>
-            <a:r>
-              <a:rPr b="1" dirty="0"/>
-              <a:t> </a:t>
-            </a:r>
-            <a:r>
-              <a:rPr b="1" dirty="0" err="1"/>
-              <a:t>בממוצע</a:t>
-            </a:r>
-            <a:r>
-              <a:rPr b="1" dirty="0"/>
-              <a:t>, </a:t>
-            </a:r>
-            <a:r>
-              <a:rPr b="1" dirty="0" err="1"/>
-              <a:t>ולא</a:t>
-            </a:r>
-            <a:r>
-              <a:rPr b="1" dirty="0"/>
-              <a:t> </a:t>
-            </a:r>
-            <a:r>
-              <a:rPr b="1" dirty="0" err="1"/>
-              <a:t>בהכרח</a:t>
-            </a:r>
-            <a:r>
-              <a:rPr b="1" dirty="0"/>
-              <a:t> </a:t>
-            </a:r>
-            <a:r>
-              <a:rPr b="1" dirty="0" err="1"/>
-              <a:t>השפעה</a:t>
-            </a:r>
-            <a:r>
-              <a:rPr b="1" dirty="0"/>
-              <a:t> </a:t>
-            </a:r>
-            <a:r>
-              <a:rPr b="1" dirty="0" err="1"/>
-              <a:t>חיובית</a:t>
-            </a:r>
-            <a:r>
-              <a:rPr b="1" dirty="0"/>
-              <a:t> </a:t>
-            </a:r>
-            <a:r>
-              <a:rPr b="1" dirty="0" err="1"/>
-              <a:t>או</a:t>
-            </a:r>
-            <a:r>
-              <a:rPr b="1" dirty="0"/>
-              <a:t> </a:t>
-            </a:r>
-            <a:r>
-              <a:rPr b="1" dirty="0" err="1"/>
-              <a:t>הוכחה</a:t>
-            </a:r>
-            <a:r>
-              <a:rPr b="1" dirty="0"/>
-              <a:t> </a:t>
-            </a:r>
-            <a:r>
-              <a:rPr b="1" dirty="0" err="1"/>
-              <a:t>לסיבתיות</a:t>
-            </a:r>
-            <a:r>
-              <a:rPr b="1" dirty="0"/>
-              <a:t>.</a:t>
-            </a:r>
-          </a:p>
-          <a:p>
-            <a:pPr lvl="0" algn="r">
-              <a:buNone/>
-            </a:pPr>
-            <a:r>
-              <a:rPr b="1" dirty="0" err="1"/>
-              <a:t>המדד</a:t>
-            </a:r>
-            <a:r>
-              <a:rPr b="1" dirty="0"/>
-              <a:t> </a:t>
-            </a:r>
-            <a:r>
-              <a:rPr b="1" dirty="0" err="1"/>
-              <a:t>המוביל</a:t>
-            </a:r>
-            <a:r>
-              <a:rPr b="1" dirty="0"/>
-              <a:t> </a:t>
-            </a:r>
-            <a:r>
-              <a:rPr b="1" dirty="0" err="1"/>
-              <a:t>משתנה</a:t>
-            </a:r>
-            <a:r>
-              <a:rPr b="1" dirty="0"/>
-              <a:t> </a:t>
-            </a:r>
-            <a:r>
-              <a:rPr b="1" dirty="0" err="1"/>
-              <a:t>בין</a:t>
-            </a:r>
-            <a:r>
-              <a:rPr b="1" dirty="0"/>
-              <a:t> </a:t>
-            </a:r>
-            <a:r>
-              <a:rPr b="1" dirty="0" err="1"/>
-              <a:t>קמפיינים</a:t>
-            </a:r>
-            <a:r>
-              <a:rPr b="1" dirty="0"/>
-              <a:t>. </a:t>
-            </a:r>
-            <a:r>
-              <a:rPr b="1" dirty="0" err="1"/>
-              <a:t>ברוסיה</a:t>
-            </a:r>
-            <a:r>
-              <a:rPr b="1" dirty="0"/>
-              <a:t> </a:t>
-            </a:r>
-            <a:r>
-              <a:rPr b="1" dirty="0" err="1"/>
-              <a:t>ובאיחוד</a:t>
-            </a:r>
-            <a:r>
-              <a:rPr b="1" dirty="0"/>
-              <a:t> </a:t>
-            </a:r>
-            <a:r>
-              <a:rPr b="1" dirty="0" err="1"/>
-              <a:t>האמירויות</a:t>
-            </a:r>
-            <a:r>
-              <a:rPr b="1" dirty="0"/>
-              <a:t> </a:t>
-            </a:r>
-            <a:r>
-              <a:rPr b="1" dirty="0" err="1"/>
-              <a:t>זהו</a:t>
-            </a:r>
-            <a:r>
-              <a:rPr b="1" dirty="0"/>
-              <a:t> </a:t>
-            </a:r>
-            <a:r>
-              <a:rPr b="1" dirty="0" err="1"/>
-              <a:t>שיוך</a:t>
-            </a:r>
-            <a:r>
-              <a:rPr b="1" dirty="0"/>
-              <a:t> </a:t>
-            </a:r>
-            <a:r>
-              <a:rPr b="1" dirty="0" err="1"/>
-              <a:t>הקהילה</a:t>
-            </a:r>
-            <a:r>
-              <a:rPr b="1" dirty="0"/>
-              <a:t>, </a:t>
-            </a:r>
-            <a:r>
-              <a:rPr b="1" dirty="0" err="1"/>
-              <a:t>בסין</a:t>
-            </a:r>
-            <a:r>
-              <a:rPr b="1" dirty="0"/>
-              <a:t> </a:t>
-            </a:r>
-            <a:r>
-              <a:rPr b="1" dirty="0" err="1"/>
-              <a:t>הנושא</a:t>
-            </a:r>
-            <a:r>
-              <a:rPr b="1" dirty="0"/>
-              <a:t> </a:t>
-            </a:r>
-            <a:r>
-              <a:rPr b="1" dirty="0" err="1"/>
-              <a:t>המוביל</a:t>
-            </a:r>
-            <a:r>
-              <a:rPr b="1" dirty="0"/>
-              <a:t>, </a:t>
-            </a:r>
-            <a:r>
-              <a:rPr b="1" dirty="0" err="1"/>
-              <a:t>בוונצואלה</a:t>
-            </a:r>
-            <a:r>
-              <a:rPr b="1" dirty="0"/>
-              <a:t> </a:t>
-            </a:r>
-            <a:r>
-              <a:rPr b="1" dirty="0" err="1"/>
-              <a:t>מקדם</a:t>
-            </a:r>
-            <a:r>
-              <a:rPr b="1" dirty="0"/>
-              <a:t> </a:t>
-            </a:r>
-            <a:r>
-              <a:rPr b="1" dirty="0" err="1"/>
-              <a:t>ההתקבצות</a:t>
-            </a:r>
-            <a:r>
-              <a:rPr b="1" dirty="0"/>
-              <a:t>, </a:t>
-            </a:r>
-            <a:r>
-              <a:rPr b="1" dirty="0" err="1"/>
-              <a:t>ובקובה</a:t>
-            </a:r>
-            <a:r>
-              <a:rPr b="1" dirty="0"/>
-              <a:t> </a:t>
-            </a:r>
-            <a:r>
-              <a:rPr b="1" dirty="0" err="1"/>
-              <a:t>ובאיראן</a:t>
-            </a:r>
-            <a:r>
-              <a:rPr b="1" dirty="0"/>
-              <a:t> </a:t>
-            </a:r>
-            <a:r>
-              <a:rPr b="1" dirty="0" err="1"/>
-              <a:t>דירוג</a:t>
-            </a:r>
-            <a:r>
-              <a:rPr b="1" dirty="0"/>
-              <a:t> </a:t>
-            </a:r>
-            <a:r>
-              <a:rPr b="1" dirty="0" err="1"/>
-              <a:t>הדף</a:t>
-            </a:r>
-            <a:r>
-              <a:rPr b="1" dirty="0"/>
-              <a:t>. </a:t>
-            </a:r>
-            <a:r>
-              <a:rPr b="1" dirty="0" err="1"/>
-              <a:t>מספר</a:t>
-            </a:r>
-            <a:r>
-              <a:rPr b="1" dirty="0"/>
-              <a:t> </a:t>
-            </a:r>
-            <a:r>
-              <a:rPr b="1" dirty="0" err="1"/>
-              <a:t>הליבה</a:t>
-            </a:r>
-            <a:r>
-              <a:rPr b="1" dirty="0"/>
-              <a:t> </a:t>
-            </a:r>
-            <a:r>
-              <a:rPr b="1" dirty="0" err="1"/>
-              <a:t>חשוב</a:t>
-            </a:r>
-            <a:r>
-              <a:rPr b="1" dirty="0"/>
-              <a:t> </a:t>
-            </a:r>
-            <a:r>
-              <a:rPr b="1" dirty="0" err="1"/>
-              <a:t>בכמה</a:t>
-            </a:r>
-            <a:r>
-              <a:rPr b="1" dirty="0"/>
-              <a:t> </a:t>
-            </a:r>
-            <a:r>
-              <a:rPr b="1" dirty="0" err="1"/>
-              <a:t>קמפיינים</a:t>
-            </a:r>
-            <a:r>
-              <a:rPr b="1" dirty="0"/>
-              <a:t>, </a:t>
-            </a:r>
-            <a:r>
-              <a:rPr b="1" dirty="0" err="1"/>
-              <a:t>אך</a:t>
-            </a:r>
-            <a:r>
-              <a:rPr b="1" dirty="0"/>
-              <a:t> </a:t>
-            </a:r>
-            <a:r>
-              <a:rPr b="1" dirty="0" err="1"/>
-              <a:t>הוא</a:t>
-            </a:r>
-            <a:r>
-              <a:rPr b="1" dirty="0"/>
-              <a:t> </a:t>
-            </a:r>
-            <a:r>
-              <a:rPr b="1" dirty="0" err="1"/>
-              <a:t>חלק</a:t>
-            </a:r>
-            <a:r>
-              <a:rPr b="1" dirty="0"/>
-              <a:t> </a:t>
-            </a:r>
-            <a:r>
-              <a:rPr b="1" dirty="0" err="1"/>
-              <a:t>ממכלול</a:t>
-            </a:r>
-            <a:r>
-              <a:rPr b="1" dirty="0"/>
-              <a:t> </a:t>
-            </a:r>
-            <a:r>
-              <a:rPr b="1" dirty="0" err="1"/>
-              <a:t>מדדים</a:t>
-            </a:r>
-            <a:r>
-              <a:rPr b="1" dirty="0"/>
-              <a:t> </a:t>
-            </a:r>
-            <a:r>
-              <a:rPr b="1" dirty="0" err="1"/>
-              <a:t>משלימים</a:t>
-            </a:r>
-            <a:r>
-              <a:rPr b="1" dirty="0"/>
-              <a:t>. </a:t>
-            </a:r>
-            <a:r>
-              <a:rPr b="1" dirty="0" err="1"/>
-              <a:t>המסקנה</a:t>
-            </a:r>
-            <a:r>
-              <a:rPr b="1" dirty="0"/>
-              <a:t> </a:t>
-            </a:r>
-            <a:r>
-              <a:rPr b="1" dirty="0" err="1"/>
-              <a:t>היא</a:t>
-            </a:r>
-            <a:r>
-              <a:rPr b="1" dirty="0"/>
-              <a:t> </a:t>
-            </a:r>
-            <a:r>
-              <a:rPr b="1" dirty="0" err="1"/>
-              <a:t>שיש</a:t>
-            </a:r>
-            <a:r>
-              <a:rPr b="1" dirty="0"/>
-              <a:t> </a:t>
-            </a:r>
-            <a:r>
-              <a:rPr b="1" dirty="0" err="1"/>
-              <a:t>ערך</a:t>
-            </a:r>
-            <a:r>
-              <a:rPr b="1" dirty="0"/>
-              <a:t> </a:t>
-            </a:r>
-            <a:r>
-              <a:rPr b="1" dirty="0" err="1"/>
-              <a:t>לבחינת</a:t>
-            </a:r>
-            <a:r>
-              <a:rPr b="1" dirty="0"/>
-              <a:t> </a:t>
-            </a:r>
-            <a:r>
-              <a:rPr b="1" dirty="0" err="1"/>
-              <a:t>כמה</a:t>
-            </a:r>
-            <a:r>
-              <a:rPr b="1" dirty="0"/>
-              <a:t> </a:t>
-            </a:r>
-            <a:r>
-              <a:rPr b="1" dirty="0" err="1"/>
-              <a:t>היבטים</a:t>
-            </a:r>
-            <a:r>
-              <a:rPr b="1" dirty="0"/>
-              <a:t> </a:t>
-            </a:r>
-            <a:r>
-              <a:rPr b="1" dirty="0" err="1"/>
-              <a:t>של</a:t>
-            </a:r>
-            <a:r>
-              <a:rPr b="1" dirty="0"/>
-              <a:t> </a:t>
-            </a:r>
-            <a:r>
-              <a:rPr b="1" dirty="0" err="1"/>
-              <a:t>פעילות</a:t>
-            </a:r>
-            <a:r>
-              <a:rPr b="1" dirty="0"/>
-              <a:t> </a:t>
-            </a:r>
-            <a:r>
-              <a:rPr b="1" dirty="0" err="1"/>
-              <a:t>החשבון</a:t>
-            </a:r>
-            <a:r>
-              <a:rPr b="1" dirty="0"/>
-              <a:t>. </a:t>
-            </a:r>
-            <a:r>
-              <a:rPr b="1" dirty="0" err="1"/>
-              <a:t>האיור</a:t>
-            </a:r>
-            <a:r>
-              <a:rPr b="1" dirty="0"/>
-              <a:t> </a:t>
-            </a:r>
-            <a:r>
-              <a:rPr b="1" dirty="0" err="1"/>
-              <a:t>המקורי</a:t>
-            </a:r>
-            <a:r>
-              <a:rPr b="1" dirty="0"/>
-              <a:t> </a:t>
-            </a:r>
-            <a:r>
-              <a:rPr b="1" dirty="0" err="1"/>
-              <a:t>מהמאמר</a:t>
-            </a:r>
-            <a:r>
-              <a:rPr b="1" dirty="0"/>
-              <a:t> </a:t>
-            </a:r>
-            <a:r>
-              <a:rPr b="1" dirty="0" err="1"/>
-              <a:t>נשמר</a:t>
-            </a:r>
-            <a:r>
-              <a:rPr b="1" dirty="0"/>
-              <a:t> </a:t>
-            </a:r>
-            <a:r>
-              <a:rPr b="1" dirty="0" err="1"/>
-              <a:t>בשלמותו</a:t>
-            </a:r>
-            <a:r>
-              <a:rPr b="1" dirty="0"/>
-              <a:t>.</a:t>
-            </a:r>
+            <a:pPr algn="r" rtl="1"/>
+            <a:endParaRPr dirty="0"/>
           </a:p>
         </p:txBody>
       </p:sp>
@@ -7463,1591 +6776,10 @@
           <a:bodyPr/>
           <a:lstStyle/>
           <a:p>
-            <a:pPr lvl="0" algn="r"/>
-            <a:r>
-              <a:rPr lang="en-IL" b="1" dirty="0"/>
-              <a:t>היקף הבדיקה:</a:t>
-            </a:r>
-            <a:r>
-              <a:rPr lang="en-IL" dirty="0"/>
-              <a:t> בחנו שישה קמפיינים, הכוללים כ־18.5 מיליון פרסומים של 138,247 חשבונות. </a:t>
-            </a:r>
-          </a:p>
-          <a:p>
-            <a:pPr lvl="0" algn="r"/>
-            <a:r>
-              <a:rPr lang="en-IL" b="1" dirty="0"/>
-              <a:t>בדיקה בתוך אותו קמפיין:</a:t>
-            </a:r>
-            <a:r>
-              <a:rPr lang="en-IL" dirty="0"/>
-              <a:t> אימנו את המודל על חלק מהחשבונות ובדקנו אותו על חשבונות אחרים מאותו קמפיין. מדד ההבחנה הממוצע היה </a:t>
-            </a:r>
-            <a:r>
-              <a:rPr lang="en-IL" b="1" dirty="0"/>
-              <a:t>0.990</a:t>
-            </a:r>
-            <a:r>
-              <a:rPr lang="en-IL" dirty="0"/>
-              <a:t>. </a:t>
-            </a:r>
-          </a:p>
-          <a:p>
-            <a:pPr lvl="0" algn="r"/>
-            <a:r>
-              <a:rPr lang="en-IL" b="1" dirty="0"/>
-              <a:t>בדיקה על קמפיין שלא השתתף באימון:</a:t>
-            </a:r>
-            <a:r>
-              <a:rPr lang="en-IL" dirty="0"/>
-              <a:t> אימנו על חמישה קמפיינים ובדקנו על השישי, וחזרנו על התהליך עבור כל קמפיין. מדד ההבחנה הממוצע היה </a:t>
-            </a:r>
-            <a:r>
-              <a:rPr lang="en-IL" b="1" dirty="0"/>
-              <a:t>0.933</a:t>
-            </a:r>
-            <a:r>
-              <a:rPr lang="en-IL" dirty="0"/>
-              <a:t>. </a:t>
-            </a:r>
-          </a:p>
-          <a:p>
-            <a:pPr lvl="0" algn="r"/>
-            <a:r>
-              <a:rPr lang="en-IL" b="1" dirty="0"/>
-              <a:t>המשמעות:</a:t>
-            </a:r>
-            <a:r>
-              <a:rPr lang="en-IL" dirty="0"/>
-              <a:t> המדדים מאפשרים הבחנה טובה גם בקמפיינים שלא שימשו לאימון, אך הביצועים משתנים בין הקמפיינים.</a:t>
-            </a:r>
-          </a:p>
-          <a:p>
-            <a:pPr algn="r"/>
-            <a:endParaRPr lang="he-IL" dirty="0"/>
-          </a:p>
-          <a:p>
-            <a:pPr algn="r"/>
-            <a:endParaRPr lang="he-IL" dirty="0"/>
-          </a:p>
-          <a:p>
-            <a:pPr algn="r"/>
-            <a:r>
-              <a:rPr lang="en-IL" dirty="0"/>
-              <a:t>ההערה בתחתית מוסיפה שמדד משלים, המתמקד באיכות זיהוי החשבונות החיוביים, הגיע לממוצע של </a:t>
-            </a:r>
-            <a:r>
-              <a:rPr lang="en-IL" b="1" dirty="0"/>
-              <a:t>0.723</a:t>
-            </a:r>
-            <a:r>
-              <a:rPr lang="en-IL" dirty="0"/>
-              <a:t> בבדיקה בין קמפיינים. היא מסייגת את התמונה ומבהירה שעדיין יש מקום לשיפור.</a:t>
-            </a:r>
-            <a:endParaRPr dirty="0"/>
-          </a:p>
-        </p:txBody>
-      </p:sp>
-      <p:sp>
-        <p:nvSpPr>
-          <p:cNvPr id="4" name="Slide Number Placeholder 3"/>
-          <p:cNvSpPr>
-            <a:spLocks noGrp="1"/>
-          </p:cNvSpPr>
-          <p:nvPr>
-            <p:ph type="sldNum" idx="5"/>
-          </p:nvPr>
-        </p:nvSpPr>
-        <p:spPr/>
-        <p:txBody>
-          <a:bodyPr/>
-          <a:lstStyle/>
-          <a:p>
-            <a:endParaRPr/>
-          </a:p>
-        </p:txBody>
-      </p:sp>
-    </p:spTree>
-  </p:cSld>
-  <p:clrMapOvr>
-    <a:masterClrMapping/>
-  </p:clrMapOvr>
-</p:notes>
-</file>
-
-<file path=ppt/notesSlides/notesSlide5.xml><?xml version="1.0" encoding="utf-8"?>
-<p:notes xmlns:a="http://schemas.openxmlformats.org/drawingml/2006/main" xmlns:r="http://schemas.openxmlformats.org/officeDocument/2006/relationships" xmlns:p="http://schemas.openxmlformats.org/presentationml/2006/main">
-  <p:cSld>
-    <p:spTree>
-      <p:nvGrpSpPr>
-        <p:cNvPr id="1" name=""/>
-        <p:cNvGrpSpPr/>
-        <p:nvPr/>
-      </p:nvGrpSpPr>
-      <p:grpSpPr>
-        <a:xfrm>
-          <a:off x="0" y="0"/>
-          <a:ext cx="0" cy="0"/>
-          <a:chOff x="0" y="0"/>
-          <a:chExt cx="0" cy="0"/>
-        </a:xfrm>
-      </p:grpSpPr>
-      <p:sp>
-        <p:nvSpPr>
-          <p:cNvPr id="2" name="Slide Image Placeholder 1"/>
-          <p:cNvSpPr>
-            <a:spLocks noGrp="1" noRot="1" noChangeAspect="1"/>
-          </p:cNvSpPr>
-          <p:nvPr>
-            <p:ph type="sldImg"/>
-          </p:nvPr>
-        </p:nvSpPr>
-        <p:spPr/>
-      </p:sp>
-      <p:sp>
-        <p:nvSpPr>
-          <p:cNvPr id="3" name="Notes Placeholder 2"/>
-          <p:cNvSpPr>
-            <a:spLocks noGrp="1"/>
-          </p:cNvSpPr>
-          <p:nvPr>
-            <p:ph type="body" idx="1"/>
-          </p:nvPr>
-        </p:nvSpPr>
-        <p:spPr/>
-        <p:txBody>
-          <a:bodyPr/>
-          <a:lstStyle/>
-          <a:p>
-            <a:pPr algn="r" rtl="1"/>
-            <a:r>
-              <a:rPr dirty="0" err="1"/>
-              <a:t>הסבר</a:t>
-            </a:r>
-            <a:r>
-              <a:rPr dirty="0"/>
-              <a:t> </a:t>
-            </a:r>
-            <a:r>
-              <a:rPr dirty="0" err="1"/>
-              <a:t>להצגה</a:t>
-            </a:r>
-            <a:r>
-              <a:rPr dirty="0"/>
-              <a:t>:</a:t>
-            </a:r>
-          </a:p>
-          <a:p>
-            <a:pPr algn="r" rtl="1"/>
-            <a:r>
-              <a:rPr dirty="0" err="1"/>
-              <a:t>שקופית</a:t>
-            </a:r>
-            <a:r>
-              <a:rPr dirty="0"/>
-              <a:t> 12 </a:t>
-            </a:r>
-            <a:r>
-              <a:rPr dirty="0" err="1"/>
-              <a:t>מציגה</a:t>
-            </a:r>
-            <a:r>
-              <a:rPr dirty="0"/>
-              <a:t> </a:t>
-            </a:r>
-            <a:r>
-              <a:rPr dirty="0" err="1"/>
-              <a:t>את</a:t>
-            </a:r>
-            <a:r>
-              <a:rPr dirty="0"/>
-              <a:t> </a:t>
-            </a:r>
-            <a:r>
-              <a:rPr dirty="0" err="1"/>
-              <a:t>התוצאות</a:t>
-            </a:r>
-            <a:r>
-              <a:rPr dirty="0"/>
-              <a:t> </a:t>
-            </a:r>
-            <a:r>
-              <a:rPr dirty="0" err="1"/>
-              <a:t>של</a:t>
-            </a:r>
-            <a:r>
-              <a:rPr dirty="0"/>
-              <a:t> </a:t>
-            </a:r>
-            <a:r>
-              <a:rPr dirty="0" err="1"/>
-              <a:t>ההשוואה</a:t>
-            </a:r>
-            <a:r>
-              <a:rPr dirty="0"/>
-              <a:t> </a:t>
-            </a:r>
-            <a:r>
-              <a:rPr dirty="0" err="1"/>
-              <a:t>שהסברנו</a:t>
-            </a:r>
-            <a:r>
-              <a:rPr dirty="0"/>
-              <a:t> </a:t>
-            </a:r>
-            <a:r>
-              <a:rPr dirty="0" err="1"/>
-              <a:t>בשקופית</a:t>
-            </a:r>
-            <a:r>
-              <a:rPr dirty="0"/>
-              <a:t> 11: </a:t>
-            </a:r>
-            <a:r>
-              <a:rPr dirty="0" err="1"/>
-              <a:t>מה</a:t>
-            </a:r>
-            <a:r>
-              <a:rPr dirty="0"/>
-              <a:t> </a:t>
-            </a:r>
-            <a:r>
-              <a:rPr dirty="0" err="1"/>
-              <a:t>מתקבל</a:t>
-            </a:r>
-            <a:r>
-              <a:rPr dirty="0"/>
-              <a:t> </a:t>
-            </a:r>
-            <a:r>
-              <a:rPr dirty="0" err="1"/>
-              <a:t>כשמגדירים</a:t>
-            </a:r>
-            <a:r>
-              <a:rPr dirty="0"/>
-              <a:t> </a:t>
-            </a:r>
-            <a:r>
-              <a:rPr dirty="0" err="1"/>
-              <a:t>קבוצות</a:t>
-            </a:r>
-            <a:r>
-              <a:rPr dirty="0"/>
-              <a:t> </a:t>
-            </a:r>
-            <a:r>
-              <a:rPr dirty="0" err="1"/>
-              <a:t>בדרכים</a:t>
-            </a:r>
-            <a:r>
-              <a:rPr dirty="0"/>
-              <a:t> </a:t>
-            </a:r>
-            <a:r>
-              <a:rPr dirty="0" err="1"/>
-              <a:t>שונות</a:t>
-            </a:r>
-            <a:r>
-              <a:rPr dirty="0"/>
-              <a:t>.</a:t>
-            </a:r>
-          </a:p>
-          <a:p>
-            <a:pPr algn="r" rtl="1"/>
-            <a:r>
-              <a:rPr dirty="0" err="1"/>
-              <a:t>כך</a:t>
-            </a:r>
-            <a:r>
-              <a:rPr dirty="0"/>
-              <a:t> </a:t>
-            </a:r>
-            <a:r>
-              <a:rPr dirty="0" err="1"/>
-              <a:t>קוראים</a:t>
-            </a:r>
-            <a:r>
-              <a:rPr dirty="0"/>
-              <a:t> </a:t>
-            </a:r>
-            <a:r>
-              <a:rPr dirty="0" err="1"/>
-              <a:t>את</a:t>
-            </a:r>
-            <a:r>
-              <a:rPr dirty="0"/>
-              <a:t> </a:t>
-            </a:r>
-            <a:r>
-              <a:rPr dirty="0" err="1"/>
-              <a:t>הגרף</a:t>
-            </a:r>
-            <a:r>
-              <a:rPr dirty="0"/>
-              <a:t>:</a:t>
-            </a:r>
-          </a:p>
-          <a:p>
-            <a:pPr algn="r" rtl="1"/>
-            <a:r>
-              <a:rPr dirty="0"/>
-              <a:t>• </a:t>
-            </a:r>
-            <a:r>
-              <a:rPr dirty="0" err="1"/>
-              <a:t>כל</a:t>
-            </a:r>
-            <a:r>
-              <a:rPr dirty="0"/>
-              <a:t> </a:t>
-            </a:r>
-            <a:r>
-              <a:rPr dirty="0" err="1"/>
-              <a:t>עמודה</a:t>
-            </a:r>
-            <a:r>
-              <a:rPr dirty="0"/>
-              <a:t> </a:t>
-            </a:r>
-            <a:r>
-              <a:rPr dirty="0" err="1"/>
-              <a:t>היא</a:t>
-            </a:r>
-            <a:r>
-              <a:rPr dirty="0"/>
-              <a:t> </a:t>
-            </a:r>
-            <a:r>
-              <a:rPr dirty="0" err="1"/>
-              <a:t>קמפיין</a:t>
-            </a:r>
-            <a:r>
-              <a:rPr dirty="0"/>
-              <a:t> </a:t>
-            </a:r>
-            <a:r>
-              <a:rPr dirty="0" err="1"/>
-              <a:t>אחר</a:t>
-            </a:r>
-            <a:r>
-              <a:rPr dirty="0"/>
-              <a:t>, </a:t>
-            </a:r>
-            <a:r>
-              <a:rPr dirty="0" err="1"/>
-              <a:t>וכל</a:t>
-            </a:r>
-            <a:r>
-              <a:rPr dirty="0"/>
-              <a:t> </a:t>
-            </a:r>
-            <a:r>
-              <a:rPr dirty="0" err="1"/>
-              <a:t>צבע</a:t>
-            </a:r>
-            <a:r>
-              <a:rPr dirty="0"/>
-              <a:t> </a:t>
-            </a:r>
-            <a:r>
-              <a:rPr dirty="0" err="1"/>
-              <a:t>מייצג</a:t>
-            </a:r>
-            <a:r>
-              <a:rPr dirty="0"/>
-              <a:t> </a:t>
-            </a:r>
-            <a:r>
-              <a:rPr dirty="0" err="1"/>
-              <a:t>שיטה</a:t>
-            </a:r>
-            <a:r>
-              <a:rPr dirty="0"/>
-              <a:t> </a:t>
-            </a:r>
-            <a:r>
-              <a:rPr dirty="0" err="1"/>
-              <a:t>להגדרת</a:t>
-            </a:r>
-            <a:r>
-              <a:rPr dirty="0"/>
-              <a:t> </a:t>
-            </a:r>
-            <a:r>
-              <a:rPr dirty="0" err="1"/>
-              <a:t>קבוצה</a:t>
-            </a:r>
-            <a:r>
-              <a:rPr dirty="0"/>
-              <a:t>. </a:t>
-            </a:r>
-            <a:r>
-              <a:rPr dirty="0" err="1"/>
-              <a:t>כל</a:t>
-            </a:r>
-            <a:r>
-              <a:rPr dirty="0"/>
-              <a:t> </a:t>
-            </a:r>
-            <a:r>
-              <a:rPr dirty="0" err="1"/>
-              <a:t>נקודה</a:t>
-            </a:r>
-            <a:r>
-              <a:rPr dirty="0"/>
-              <a:t> </a:t>
-            </a:r>
-            <a:r>
-              <a:rPr dirty="0" err="1"/>
-              <a:t>מציגה</a:t>
-            </a:r>
-            <a:r>
-              <a:rPr dirty="0"/>
-              <a:t> </a:t>
-            </a:r>
-            <a:r>
-              <a:rPr dirty="0" err="1"/>
-              <a:t>את</a:t>
-            </a:r>
-            <a:r>
-              <a:rPr dirty="0"/>
-              <a:t> </a:t>
-            </a:r>
-            <a:r>
-              <a:rPr dirty="0" err="1"/>
-              <a:t>הממוצע</a:t>
-            </a:r>
-            <a:r>
-              <a:rPr dirty="0"/>
-              <a:t> </a:t>
-            </a:r>
-            <a:r>
-              <a:rPr dirty="0" err="1"/>
-              <a:t>של</a:t>
-            </a:r>
-            <a:r>
-              <a:rPr dirty="0"/>
-              <a:t> </a:t>
-            </a:r>
-            <a:r>
-              <a:rPr dirty="0" err="1"/>
-              <a:t>אותה</a:t>
-            </a:r>
-            <a:r>
-              <a:rPr dirty="0"/>
-              <a:t> </a:t>
-            </a:r>
-            <a:r>
-              <a:rPr dirty="0" err="1"/>
-              <a:t>שיטה</a:t>
-            </a:r>
-            <a:r>
-              <a:rPr dirty="0"/>
-              <a:t>.</a:t>
-            </a:r>
-          </a:p>
-          <a:p>
-            <a:pPr algn="r" rtl="1"/>
-            <a:r>
-              <a:rPr dirty="0"/>
-              <a:t>• </a:t>
-            </a:r>
-            <a:r>
-              <a:rPr dirty="0" err="1"/>
-              <a:t>ככל</a:t>
-            </a:r>
-            <a:r>
-              <a:rPr dirty="0"/>
-              <a:t> </a:t>
-            </a:r>
-            <a:r>
-              <a:rPr dirty="0" err="1"/>
-              <a:t>שהנקודה</a:t>
-            </a:r>
-            <a:r>
-              <a:rPr dirty="0"/>
-              <a:t> </a:t>
-            </a:r>
-            <a:r>
-              <a:rPr dirty="0" err="1"/>
-              <a:t>ימינה</a:t>
-            </a:r>
-            <a:r>
-              <a:rPr dirty="0"/>
-              <a:t>, </a:t>
-            </a:r>
-            <a:r>
-              <a:rPr dirty="0" err="1"/>
-              <a:t>שיעור</a:t>
-            </a:r>
-            <a:r>
-              <a:rPr dirty="0"/>
-              <a:t> </a:t>
-            </a:r>
-            <a:r>
-              <a:rPr dirty="0" err="1"/>
-              <a:t>החשבונות</a:t>
-            </a:r>
-            <a:r>
-              <a:rPr dirty="0"/>
-              <a:t> </a:t>
-            </a:r>
-            <a:r>
-              <a:rPr dirty="0" err="1"/>
-              <a:t>של</a:t>
-            </a:r>
-            <a:r>
-              <a:rPr dirty="0"/>
-              <a:t> </a:t>
-            </a:r>
-            <a:r>
-              <a:rPr dirty="0" err="1"/>
-              <a:t>מבצע</a:t>
-            </a:r>
-            <a:r>
-              <a:rPr dirty="0"/>
-              <a:t> </a:t>
-            </a:r>
-            <a:r>
-              <a:rPr dirty="0" err="1"/>
-              <a:t>ההשפעה</a:t>
-            </a:r>
-            <a:r>
-              <a:rPr dirty="0"/>
-              <a:t> </a:t>
-            </a:r>
-            <a:r>
-              <a:rPr dirty="0" err="1"/>
-              <a:t>בקבוצות</a:t>
-            </a:r>
-            <a:r>
-              <a:rPr dirty="0"/>
-              <a:t> </a:t>
-            </a:r>
-            <a:r>
-              <a:rPr dirty="0" err="1"/>
-              <a:t>גבוה</a:t>
-            </a:r>
-            <a:r>
-              <a:rPr dirty="0"/>
-              <a:t> </a:t>
-            </a:r>
-            <a:r>
-              <a:rPr dirty="0" err="1"/>
-              <a:t>יותר</a:t>
-            </a:r>
-            <a:r>
-              <a:rPr dirty="0"/>
-              <a:t>.</a:t>
-            </a:r>
-          </a:p>
-          <a:p>
-            <a:pPr algn="r" rtl="1"/>
-            <a:r>
-              <a:rPr dirty="0"/>
-              <a:t>• </a:t>
-            </a:r>
-            <a:r>
-              <a:rPr dirty="0" err="1"/>
-              <a:t>ככל</a:t>
-            </a:r>
-            <a:r>
-              <a:rPr dirty="0"/>
-              <a:t> </a:t>
-            </a:r>
-            <a:r>
-              <a:rPr dirty="0" err="1"/>
-              <a:t>שהנקודה</a:t>
-            </a:r>
-            <a:r>
-              <a:rPr dirty="0"/>
-              <a:t> </a:t>
-            </a:r>
-            <a:r>
-              <a:rPr dirty="0" err="1"/>
-              <a:t>למעלה</a:t>
-            </a:r>
-            <a:r>
-              <a:rPr dirty="0"/>
-              <a:t>, </a:t>
-            </a:r>
-            <a:r>
-              <a:rPr dirty="0" err="1"/>
-              <a:t>יותר</a:t>
-            </a:r>
-            <a:r>
-              <a:rPr dirty="0"/>
-              <a:t> </a:t>
-            </a:r>
-            <a:r>
-              <a:rPr dirty="0" err="1"/>
-              <a:t>חשבונות</a:t>
-            </a:r>
-            <a:r>
-              <a:rPr dirty="0"/>
-              <a:t> </a:t>
-            </a:r>
-            <a:r>
-              <a:rPr dirty="0" err="1"/>
-              <a:t>בקבוצות</a:t>
-            </a:r>
-            <a:r>
-              <a:rPr dirty="0"/>
-              <a:t> </a:t>
-            </a:r>
-            <a:r>
-              <a:rPr dirty="0" err="1"/>
-              <a:t>חולקים</a:t>
-            </a:r>
-            <a:r>
-              <a:rPr dirty="0"/>
-              <a:t> </a:t>
-            </a:r>
-            <a:r>
-              <a:rPr dirty="0" err="1"/>
-              <a:t>את</a:t>
-            </a:r>
-            <a:r>
-              <a:rPr dirty="0"/>
-              <a:t> </a:t>
-            </a:r>
-            <a:r>
-              <a:rPr dirty="0" err="1"/>
-              <a:t>הנושא</a:t>
-            </a:r>
-            <a:r>
-              <a:rPr dirty="0"/>
-              <a:t> </a:t>
-            </a:r>
-            <a:r>
-              <a:rPr dirty="0" err="1"/>
-              <a:t>המוביל</a:t>
-            </a:r>
-            <a:r>
-              <a:rPr dirty="0"/>
-              <a:t> </a:t>
-            </a:r>
-            <a:r>
-              <a:rPr dirty="0" err="1"/>
-              <a:t>של</a:t>
-            </a:r>
-            <a:r>
-              <a:rPr dirty="0"/>
-              <a:t> </a:t>
-            </a:r>
-            <a:r>
-              <a:rPr dirty="0" err="1"/>
-              <a:t>החשבון</a:t>
-            </a:r>
-            <a:r>
-              <a:rPr dirty="0"/>
-              <a:t> </a:t>
-            </a:r>
-            <a:r>
-              <a:rPr dirty="0" err="1"/>
-              <a:t>שבוחנים</a:t>
-            </a:r>
-            <a:r>
-              <a:rPr dirty="0"/>
-              <a:t>.</a:t>
-            </a:r>
-          </a:p>
-          <a:p>
-            <a:pPr algn="r" rtl="1"/>
-            <a:r>
-              <a:rPr dirty="0"/>
-              <a:t>• </a:t>
-            </a:r>
-            <a:r>
-              <a:rPr dirty="0" err="1"/>
-              <a:t>לכן</a:t>
-            </a:r>
-            <a:r>
-              <a:rPr dirty="0"/>
-              <a:t> </a:t>
-            </a:r>
-            <a:r>
-              <a:rPr dirty="0" err="1"/>
-              <a:t>מחפשים</a:t>
-            </a:r>
-            <a:r>
-              <a:rPr dirty="0"/>
-              <a:t> </a:t>
-            </a:r>
-            <a:r>
-              <a:rPr dirty="0" err="1"/>
-              <a:t>שילוב</a:t>
-            </a:r>
-            <a:r>
-              <a:rPr dirty="0"/>
-              <a:t> </a:t>
-            </a:r>
-            <a:r>
-              <a:rPr dirty="0" err="1"/>
-              <a:t>של</a:t>
-            </a:r>
-            <a:r>
-              <a:rPr dirty="0"/>
-              <a:t> </a:t>
-            </a:r>
-            <a:r>
-              <a:rPr dirty="0" err="1"/>
-              <a:t>ימינה</a:t>
-            </a:r>
-            <a:r>
-              <a:rPr dirty="0"/>
-              <a:t> </a:t>
-            </a:r>
-            <a:r>
-              <a:rPr dirty="0" err="1"/>
-              <a:t>ולמעלה</a:t>
-            </a:r>
-            <a:r>
-              <a:rPr dirty="0"/>
-              <a:t>.</a:t>
-            </a:r>
-          </a:p>
-          <a:p>
-            <a:pPr algn="r" rtl="1"/>
-            <a:r>
-              <a:rPr dirty="0"/>
-              <a:t>• </a:t>
-            </a:r>
-            <a:r>
-              <a:rPr dirty="0" err="1"/>
-              <a:t>בשורה</a:t>
-            </a:r>
-            <a:r>
-              <a:rPr dirty="0"/>
-              <a:t> </a:t>
-            </a:r>
-            <a:r>
-              <a:rPr dirty="0" err="1"/>
-              <a:t>התחתונה</a:t>
-            </a:r>
-            <a:r>
-              <a:rPr dirty="0"/>
-              <a:t> </a:t>
-            </a:r>
-            <a:r>
-              <a:rPr dirty="0" err="1"/>
-              <a:t>הניתוח</a:t>
-            </a:r>
-            <a:r>
-              <a:rPr dirty="0"/>
-              <a:t> </a:t>
-            </a:r>
-            <a:r>
-              <a:rPr dirty="0" err="1"/>
-              <a:t>כולל</a:t>
-            </a:r>
-            <a:r>
-              <a:rPr dirty="0"/>
-              <a:t> </a:t>
-            </a:r>
-            <a:r>
-              <a:rPr dirty="0" err="1"/>
-              <a:t>את</a:t>
-            </a:r>
-            <a:r>
-              <a:rPr dirty="0"/>
-              <a:t> </a:t>
-            </a:r>
-            <a:r>
-              <a:rPr dirty="0" err="1"/>
-              <a:t>כלל</a:t>
-            </a:r>
-            <a:r>
-              <a:rPr dirty="0"/>
-              <a:t> </a:t>
-            </a:r>
-            <a:r>
-              <a:rPr dirty="0" err="1"/>
-              <a:t>החשבונות</a:t>
-            </a:r>
-            <a:r>
-              <a:rPr dirty="0"/>
-              <a:t>. </a:t>
-            </a:r>
-            <a:r>
-              <a:rPr dirty="0" err="1"/>
-              <a:t>בשורה</a:t>
-            </a:r>
-            <a:r>
-              <a:rPr dirty="0"/>
-              <a:t> </a:t>
-            </a:r>
-            <a:r>
-              <a:rPr dirty="0" err="1"/>
-              <a:t>העליונה</a:t>
-            </a:r>
-            <a:r>
-              <a:rPr dirty="0"/>
-              <a:t> </a:t>
-            </a:r>
-            <a:r>
-              <a:rPr dirty="0" err="1"/>
-              <a:t>מגבילים</a:t>
-            </a:r>
-            <a:r>
-              <a:rPr dirty="0"/>
-              <a:t> </a:t>
-            </a:r>
-            <a:r>
-              <a:rPr dirty="0" err="1"/>
-              <a:t>את</a:t>
-            </a:r>
-            <a:r>
-              <a:rPr dirty="0"/>
-              <a:t> </a:t>
-            </a:r>
-            <a:r>
-              <a:rPr dirty="0" err="1"/>
-              <a:t>בניית</a:t>
-            </a:r>
-            <a:r>
-              <a:rPr dirty="0"/>
-              <a:t> </a:t>
-            </a:r>
-            <a:r>
-              <a:rPr dirty="0" err="1"/>
-              <a:t>הקבוצות</a:t>
-            </a:r>
-            <a:r>
-              <a:rPr dirty="0"/>
-              <a:t> </a:t>
-            </a:r>
-            <a:r>
-              <a:rPr dirty="0" err="1"/>
-              <a:t>לחשבונות</a:t>
-            </a:r>
-            <a:r>
-              <a:rPr dirty="0"/>
-              <a:t> </a:t>
-            </a:r>
-            <a:r>
-              <a:rPr dirty="0" err="1"/>
-              <a:t>שהמודל</a:t>
-            </a:r>
-            <a:r>
-              <a:rPr dirty="0"/>
-              <a:t> </a:t>
-            </a:r>
-            <a:r>
-              <a:rPr dirty="0" err="1"/>
-              <a:t>סיווג</a:t>
-            </a:r>
-            <a:r>
-              <a:rPr dirty="0"/>
-              <a:t> </a:t>
-            </a:r>
-            <a:r>
-              <a:rPr dirty="0" err="1"/>
-              <a:t>כחשבונות</a:t>
-            </a:r>
-            <a:r>
-              <a:rPr dirty="0"/>
-              <a:t> </a:t>
-            </a:r>
-            <a:r>
-              <a:rPr dirty="0" err="1"/>
-              <a:t>של</a:t>
-            </a:r>
-            <a:r>
-              <a:rPr dirty="0"/>
-              <a:t> </a:t>
-            </a:r>
-            <a:r>
-              <a:rPr dirty="0" err="1"/>
-              <a:t>מבצע</a:t>
-            </a:r>
-            <a:r>
-              <a:rPr dirty="0"/>
-              <a:t> </a:t>
-            </a:r>
-            <a:r>
-              <a:rPr dirty="0" err="1"/>
-              <a:t>השפעה</a:t>
-            </a:r>
-            <a:r>
-              <a:rPr dirty="0"/>
-              <a:t>.</a:t>
-            </a:r>
-          </a:p>
-          <a:p>
-            <a:pPr algn="r" rtl="1"/>
-            <a:r>
-              <a:rPr dirty="0" err="1"/>
-              <a:t>מה</a:t>
-            </a:r>
-            <a:r>
-              <a:rPr dirty="0"/>
-              <a:t> </a:t>
-            </a:r>
-            <a:r>
-              <a:rPr dirty="0" err="1"/>
-              <a:t>לומדים</a:t>
-            </a:r>
-            <a:r>
-              <a:rPr dirty="0"/>
-              <a:t>?</a:t>
-            </a:r>
-          </a:p>
-          <a:p>
-            <a:pPr algn="r" rtl="1"/>
-            <a:r>
-              <a:rPr dirty="0"/>
-              <a:t>• </a:t>
-            </a:r>
-            <a:r>
-              <a:rPr dirty="0" err="1"/>
-              <a:t>קבוצות</a:t>
-            </a:r>
-            <a:r>
-              <a:rPr dirty="0"/>
-              <a:t> </a:t>
-            </a:r>
-            <a:r>
-              <a:rPr dirty="0" err="1"/>
-              <a:t>לפי</a:t>
-            </a:r>
-            <a:r>
-              <a:rPr dirty="0"/>
-              <a:t> </a:t>
-            </a:r>
-            <a:r>
-              <a:rPr dirty="0" err="1"/>
-              <a:t>נושא</a:t>
-            </a:r>
-            <a:r>
-              <a:rPr dirty="0"/>
-              <a:t> </a:t>
-            </a:r>
-            <a:r>
-              <a:rPr dirty="0" err="1"/>
-              <a:t>משותף</a:t>
-            </a:r>
-            <a:r>
-              <a:rPr dirty="0"/>
-              <a:t> </a:t>
-            </a:r>
-            <a:r>
-              <a:rPr dirty="0" err="1"/>
-              <a:t>נמצאות</a:t>
-            </a:r>
-            <a:r>
-              <a:rPr dirty="0"/>
-              <a:t> </a:t>
-            </a:r>
-            <a:r>
-              <a:rPr dirty="0" err="1"/>
-              <a:t>למעלה</a:t>
-            </a:r>
-            <a:r>
-              <a:rPr dirty="0"/>
-              <a:t>, </a:t>
-            </a:r>
-            <a:r>
-              <a:rPr dirty="0" err="1"/>
-              <a:t>כי</a:t>
-            </a:r>
-            <a:r>
-              <a:rPr dirty="0"/>
-              <a:t> </a:t>
-            </a:r>
-            <a:r>
-              <a:rPr dirty="0" err="1"/>
-              <a:t>זו</a:t>
-            </a:r>
-            <a:r>
-              <a:rPr dirty="0"/>
-              <a:t> </a:t>
-            </a:r>
-            <a:r>
-              <a:rPr dirty="0" err="1"/>
-              <a:t>ההגדרה</a:t>
-            </a:r>
-            <a:r>
-              <a:rPr dirty="0"/>
-              <a:t> </a:t>
-            </a:r>
-            <a:r>
-              <a:rPr dirty="0" err="1"/>
-              <a:t>שלהן</a:t>
-            </a:r>
-            <a:r>
-              <a:rPr dirty="0"/>
-              <a:t>, </a:t>
-            </a:r>
-            <a:r>
-              <a:rPr dirty="0" err="1"/>
-              <a:t>אבל</a:t>
-            </a:r>
-            <a:r>
-              <a:rPr dirty="0"/>
-              <a:t> </a:t>
-            </a:r>
-            <a:r>
-              <a:rPr dirty="0" err="1"/>
-              <a:t>הן</a:t>
-            </a:r>
-            <a:r>
-              <a:rPr dirty="0"/>
-              <a:t> </a:t>
-            </a:r>
-            <a:r>
-              <a:rPr dirty="0" err="1"/>
-              <a:t>עשויות</a:t>
-            </a:r>
-            <a:r>
-              <a:rPr dirty="0"/>
-              <a:t> </a:t>
-            </a:r>
-            <a:r>
-              <a:rPr dirty="0" err="1"/>
-              <a:t>לכלול</a:t>
-            </a:r>
-            <a:r>
-              <a:rPr dirty="0"/>
-              <a:t> </a:t>
-            </a:r>
-            <a:r>
-              <a:rPr dirty="0" err="1"/>
-              <a:t>הרבה</a:t>
-            </a:r>
-            <a:r>
-              <a:rPr dirty="0"/>
-              <a:t> </a:t>
-            </a:r>
-            <a:r>
-              <a:rPr dirty="0" err="1"/>
-              <a:t>חשבונות</a:t>
-            </a:r>
-            <a:r>
-              <a:rPr dirty="0"/>
-              <a:t> </a:t>
-            </a:r>
-            <a:r>
-              <a:rPr dirty="0" err="1"/>
-              <a:t>שאינם</a:t>
-            </a:r>
-            <a:r>
-              <a:rPr dirty="0"/>
-              <a:t> </a:t>
-            </a:r>
-            <a:r>
-              <a:rPr dirty="0" err="1"/>
-              <a:t>חלק</a:t>
-            </a:r>
-            <a:r>
-              <a:rPr dirty="0"/>
-              <a:t> </a:t>
-            </a:r>
-            <a:r>
-              <a:rPr dirty="0" err="1"/>
-              <a:t>ממבצע</a:t>
-            </a:r>
-            <a:r>
-              <a:rPr dirty="0"/>
-              <a:t> </a:t>
-            </a:r>
-            <a:r>
-              <a:rPr dirty="0" err="1"/>
-              <a:t>השפעה</a:t>
-            </a:r>
-            <a:r>
-              <a:rPr dirty="0"/>
-              <a:t>.</a:t>
-            </a:r>
-          </a:p>
-          <a:p>
-            <a:pPr algn="r" rtl="1"/>
-            <a:r>
-              <a:rPr dirty="0"/>
-              <a:t>• </a:t>
-            </a:r>
-            <a:r>
-              <a:rPr dirty="0" err="1"/>
-              <a:t>קבוצות</a:t>
-            </a:r>
-            <a:r>
-              <a:rPr dirty="0"/>
-              <a:t> </a:t>
-            </a:r>
-            <a:r>
-              <a:rPr dirty="0" err="1"/>
-              <a:t>המבוססות</a:t>
-            </a:r>
-            <a:r>
-              <a:rPr dirty="0"/>
-              <a:t> </a:t>
-            </a:r>
-            <a:r>
-              <a:rPr dirty="0" err="1"/>
-              <a:t>על</a:t>
-            </a:r>
-            <a:r>
-              <a:rPr dirty="0"/>
-              <a:t> </a:t>
-            </a:r>
-            <a:r>
-              <a:rPr dirty="0" err="1"/>
-              <a:t>ליבה</a:t>
-            </a:r>
-            <a:r>
-              <a:rPr dirty="0"/>
-              <a:t> </a:t>
-            </a:r>
-            <a:r>
-              <a:rPr dirty="0" err="1"/>
-              <a:t>ושכנים</a:t>
-            </a:r>
-            <a:r>
-              <a:rPr dirty="0"/>
-              <a:t> </a:t>
-            </a:r>
-            <a:r>
-              <a:rPr dirty="0" err="1"/>
-              <a:t>ישירים</a:t>
-            </a:r>
-            <a:r>
-              <a:rPr dirty="0"/>
-              <a:t> </a:t>
-            </a:r>
-            <a:r>
-              <a:rPr dirty="0" err="1"/>
-              <a:t>מציעות</a:t>
-            </a:r>
-            <a:r>
-              <a:rPr dirty="0"/>
-              <a:t> </a:t>
-            </a:r>
-            <a:r>
-              <a:rPr dirty="0" err="1"/>
-              <a:t>שילוב</a:t>
-            </a:r>
-            <a:r>
-              <a:rPr dirty="0"/>
-              <a:t> </a:t>
-            </a:r>
-            <a:r>
-              <a:rPr dirty="0" err="1"/>
-              <a:t>מועיל</a:t>
-            </a:r>
-            <a:r>
-              <a:rPr dirty="0"/>
-              <a:t> </a:t>
-            </a:r>
-            <a:r>
-              <a:rPr dirty="0" err="1"/>
-              <a:t>של</a:t>
-            </a:r>
-            <a:r>
-              <a:rPr dirty="0"/>
-              <a:t> </a:t>
-            </a:r>
-            <a:r>
-              <a:rPr dirty="0" err="1"/>
-              <a:t>ריכוז</a:t>
-            </a:r>
-            <a:r>
-              <a:rPr dirty="0"/>
-              <a:t> </a:t>
-            </a:r>
-            <a:r>
-              <a:rPr dirty="0" err="1"/>
-              <a:t>חשבונות</a:t>
-            </a:r>
-            <a:r>
-              <a:rPr dirty="0"/>
-              <a:t> </a:t>
-            </a:r>
-            <a:r>
-              <a:rPr dirty="0" err="1"/>
-              <a:t>מבצע</a:t>
-            </a:r>
-            <a:r>
-              <a:rPr dirty="0"/>
-              <a:t> </a:t>
-            </a:r>
-            <a:r>
-              <a:rPr dirty="0" err="1"/>
-              <a:t>השפעה</a:t>
-            </a:r>
-            <a:r>
-              <a:rPr dirty="0"/>
-              <a:t> </a:t>
-            </a:r>
-            <a:r>
-              <a:rPr dirty="0" err="1"/>
-              <a:t>והתאמה</a:t>
-            </a:r>
-            <a:r>
-              <a:rPr dirty="0"/>
-              <a:t> </a:t>
-            </a:r>
-            <a:r>
-              <a:rPr dirty="0" err="1"/>
-              <a:t>בנושא</a:t>
-            </a:r>
-            <a:r>
-              <a:rPr dirty="0"/>
-              <a:t>. </a:t>
-            </a:r>
-            <a:r>
-              <a:rPr dirty="0" err="1"/>
-              <a:t>האיזון</a:t>
-            </a:r>
-            <a:r>
-              <a:rPr dirty="0"/>
-              <a:t> </a:t>
-            </a:r>
-            <a:r>
-              <a:rPr dirty="0" err="1"/>
-              <a:t>משתנה</a:t>
-            </a:r>
-            <a:r>
-              <a:rPr dirty="0"/>
-              <a:t> </a:t>
-            </a:r>
-            <a:r>
-              <a:rPr dirty="0" err="1"/>
-              <a:t>בין</a:t>
-            </a:r>
-            <a:r>
-              <a:rPr dirty="0"/>
-              <a:t> </a:t>
-            </a:r>
-            <a:r>
-              <a:rPr dirty="0" err="1"/>
-              <a:t>הקמפיינים</a:t>
-            </a:r>
-            <a:r>
-              <a:rPr dirty="0"/>
-              <a:t>.</a:t>
-            </a:r>
-          </a:p>
-          <a:p>
-            <a:pPr algn="r" rtl="1"/>
-            <a:r>
-              <a:rPr dirty="0" err="1"/>
-              <a:t>אפשר</a:t>
-            </a:r>
-            <a:r>
-              <a:rPr dirty="0"/>
-              <a:t> </a:t>
-            </a:r>
-            <a:r>
-              <a:rPr dirty="0" err="1"/>
-              <a:t>לומר</a:t>
-            </a:r>
-            <a:r>
-              <a:rPr dirty="0"/>
-              <a:t> </a:t>
-            </a:r>
-            <a:r>
-              <a:rPr dirty="0" err="1"/>
-              <a:t>בהצגה</a:t>
-            </a:r>
-            <a:r>
-              <a:rPr dirty="0"/>
-              <a:t>: </a:t>
-            </a:r>
-            <a:r>
-              <a:rPr dirty="0" err="1"/>
-              <a:t>בדקנו</a:t>
-            </a:r>
-            <a:r>
-              <a:rPr dirty="0"/>
-              <a:t> </a:t>
-            </a:r>
-            <a:r>
-              <a:rPr dirty="0" err="1"/>
-              <a:t>אילו</a:t>
-            </a:r>
-            <a:r>
-              <a:rPr dirty="0"/>
-              <a:t> </a:t>
-            </a:r>
-            <a:r>
-              <a:rPr dirty="0" err="1"/>
-              <a:t>קבוצות</a:t>
-            </a:r>
-            <a:r>
-              <a:rPr dirty="0"/>
-              <a:t> </a:t>
-            </a:r>
-            <a:r>
-              <a:rPr dirty="0" err="1"/>
-              <a:t>מרכזות</a:t>
-            </a:r>
-            <a:r>
-              <a:rPr dirty="0"/>
-              <a:t> </a:t>
-            </a:r>
-            <a:r>
-              <a:rPr dirty="0" err="1"/>
-              <a:t>גם</a:t>
-            </a:r>
-            <a:r>
-              <a:rPr dirty="0"/>
-              <a:t> </a:t>
-            </a:r>
-            <a:r>
-              <a:rPr dirty="0" err="1"/>
-              <a:t>חשבונות</a:t>
-            </a:r>
-            <a:r>
-              <a:rPr dirty="0"/>
-              <a:t> </a:t>
-            </a:r>
-            <a:r>
-              <a:rPr dirty="0" err="1"/>
-              <a:t>של</a:t>
-            </a:r>
-            <a:r>
-              <a:rPr dirty="0"/>
-              <a:t> </a:t>
-            </a:r>
-            <a:r>
-              <a:rPr dirty="0" err="1"/>
-              <a:t>מבצע</a:t>
-            </a:r>
-            <a:r>
-              <a:rPr dirty="0"/>
-              <a:t> </a:t>
-            </a:r>
-            <a:r>
-              <a:rPr dirty="0" err="1"/>
-              <a:t>השפעה</a:t>
-            </a:r>
-            <a:r>
-              <a:rPr dirty="0"/>
-              <a:t> </a:t>
-            </a:r>
-            <a:r>
-              <a:rPr dirty="0" err="1"/>
-              <a:t>וגם</a:t>
-            </a:r>
-            <a:r>
-              <a:rPr dirty="0"/>
-              <a:t> </a:t>
-            </a:r>
-            <a:r>
-              <a:rPr dirty="0" err="1"/>
-              <a:t>פעילות</a:t>
-            </a:r>
-            <a:r>
-              <a:rPr dirty="0"/>
-              <a:t> </a:t>
-            </a:r>
-            <a:r>
-              <a:rPr dirty="0" err="1"/>
-              <a:t>בנושא</a:t>
-            </a:r>
-            <a:r>
-              <a:rPr dirty="0"/>
-              <a:t> </a:t>
-            </a:r>
-            <a:r>
-              <a:rPr dirty="0" err="1"/>
-              <a:t>משותף</a:t>
-            </a:r>
-            <a:r>
-              <a:rPr dirty="0"/>
-              <a:t>. </a:t>
-            </a:r>
-            <a:r>
-              <a:rPr dirty="0" err="1"/>
-              <a:t>קבוצות</a:t>
-            </a:r>
-            <a:r>
-              <a:rPr dirty="0"/>
-              <a:t> </a:t>
-            </a:r>
-            <a:r>
-              <a:rPr dirty="0" err="1"/>
-              <a:t>המבוססות</a:t>
-            </a:r>
-            <a:r>
-              <a:rPr dirty="0"/>
-              <a:t> </a:t>
-            </a:r>
-            <a:r>
-              <a:rPr dirty="0" err="1"/>
-              <a:t>על</a:t>
-            </a:r>
-            <a:r>
-              <a:rPr dirty="0"/>
-              <a:t> </a:t>
-            </a:r>
-            <a:r>
-              <a:rPr dirty="0" err="1"/>
-              <a:t>ליבה</a:t>
-            </a:r>
-            <a:r>
-              <a:rPr dirty="0"/>
-              <a:t> </a:t>
-            </a:r>
-            <a:r>
-              <a:rPr dirty="0" err="1"/>
-              <a:t>ושכנים</a:t>
-            </a:r>
-            <a:r>
-              <a:rPr dirty="0"/>
-              <a:t> </a:t>
-            </a:r>
-            <a:r>
-              <a:rPr dirty="0" err="1"/>
-              <a:t>ישירים</a:t>
-            </a:r>
-            <a:r>
-              <a:rPr dirty="0"/>
-              <a:t> </a:t>
-            </a:r>
-            <a:r>
-              <a:rPr dirty="0" err="1"/>
-              <a:t>סיפקו</a:t>
-            </a:r>
-            <a:r>
-              <a:rPr dirty="0"/>
-              <a:t> </a:t>
-            </a:r>
-            <a:r>
-              <a:rPr dirty="0" err="1"/>
-              <a:t>בסיס</a:t>
-            </a:r>
-            <a:r>
-              <a:rPr dirty="0"/>
-              <a:t> </a:t>
-            </a:r>
-            <a:r>
-              <a:rPr dirty="0" err="1"/>
-              <a:t>מועיל</a:t>
-            </a:r>
-            <a:r>
-              <a:rPr dirty="0"/>
-              <a:t> </a:t>
-            </a:r>
-            <a:r>
-              <a:rPr dirty="0" err="1"/>
-              <a:t>להמשך</a:t>
-            </a:r>
-            <a:r>
-              <a:rPr dirty="0"/>
-              <a:t> </a:t>
-            </a:r>
-            <a:r>
-              <a:rPr dirty="0" err="1"/>
-              <a:t>החקירה</a:t>
-            </a:r>
-            <a:r>
-              <a:rPr dirty="0"/>
-              <a:t>.</a:t>
-            </a:r>
-          </a:p>
-          <a:p>
-            <a:pPr algn="r" rtl="1"/>
-            <a:endParaRPr dirty="0"/>
-          </a:p>
-        </p:txBody>
-      </p:sp>
-      <p:sp>
-        <p:nvSpPr>
-          <p:cNvPr id="4" name="Slide Number Placeholder 3"/>
-          <p:cNvSpPr>
-            <a:spLocks noGrp="1"/>
-          </p:cNvSpPr>
-          <p:nvPr>
-            <p:ph type="sldNum" idx="5"/>
-          </p:nvPr>
-        </p:nvSpPr>
-        <p:spPr/>
-        <p:txBody>
-          <a:bodyPr/>
-          <a:lstStyle/>
-          <a:p>
-            <a:endParaRPr/>
-          </a:p>
-        </p:txBody>
-      </p:sp>
-    </p:spTree>
-  </p:cSld>
-  <p:clrMapOvr>
-    <a:masterClrMapping/>
-  </p:clrMapOvr>
-</p:notes>
-</file>
-
-<file path=ppt/notesSlides/notesSlide6.xml><?xml version="1.0" encoding="utf-8"?>
-<p:notes xmlns:a="http://schemas.openxmlformats.org/drawingml/2006/main" xmlns:r="http://schemas.openxmlformats.org/officeDocument/2006/relationships" xmlns:p="http://schemas.openxmlformats.org/presentationml/2006/main">
-  <p:cSld>
-    <p:spTree>
-      <p:nvGrpSpPr>
-        <p:cNvPr id="1" name=""/>
-        <p:cNvGrpSpPr/>
-        <p:nvPr/>
-      </p:nvGrpSpPr>
-      <p:grpSpPr>
-        <a:xfrm>
-          <a:off x="0" y="0"/>
-          <a:ext cx="0" cy="0"/>
-          <a:chOff x="0" y="0"/>
-          <a:chExt cx="0" cy="0"/>
-        </a:xfrm>
-      </p:grpSpPr>
-      <p:sp>
-        <p:nvSpPr>
-          <p:cNvPr id="2" name="Slide Image Placeholder 1"/>
-          <p:cNvSpPr>
-            <a:spLocks noGrp="1" noRot="1" noChangeAspect="1"/>
-          </p:cNvSpPr>
-          <p:nvPr>
-            <p:ph type="sldImg"/>
-          </p:nvPr>
-        </p:nvSpPr>
-        <p:spPr/>
-      </p:sp>
-      <p:sp>
-        <p:nvSpPr>
-          <p:cNvPr id="3" name="Notes Placeholder 2"/>
-          <p:cNvSpPr>
-            <a:spLocks noGrp="1"/>
-          </p:cNvSpPr>
-          <p:nvPr>
-            <p:ph type="body" idx="1"/>
-          </p:nvPr>
-        </p:nvSpPr>
-        <p:spPr/>
-        <p:txBody>
-          <a:bodyPr/>
-          <a:lstStyle/>
-          <a:p>
             <a:pPr lvl="0" algn="r">
               <a:buNone/>
             </a:pPr>
-            <a:r>
-              <a:rPr b="1"/>
-              <a:t>Source: Backbone_Graph (1).pdf, Figure 4 and Section 4.3, pp. 9–10.</a:t>
-            </a:r>
-          </a:p>
-          <a:p>
-            <a:pPr lvl="0" algn="r">
-              <a:buNone/>
-            </a:pPr>
-            <a:r>
-              <a:rPr b="1"/>
-              <a:t>בשני חלקי האיור מוצג אותו גרף, עם אותם חשבונות ובאותם מיקומים. משמאל הצבע מייצג את מספר הליבה. מימין הצבע מייצג את תיוג האמת: אדום לחשבונות של מבצע השפעה וכחול לחשבונות ביקורת. אלה אינם צבעים של תחזיות המודל.</a:t>
-            </a:r>
-          </a:p>
-          <a:p>
-            <a:pPr lvl="0" algn="r">
-              <a:buNone/>
-            </a:pPr>
-            <a:r>
-              <a:rPr b="1"/>
-              <a:t>אפשר לראות שאזורים בעלי מספר ליבה גבוה חופפים לריכוזים של חשבונות מבצע השפעה. זו המחשה מבנית לתפקיד האפשרי של המדד, לצד שאר המדדים שהוצגו. האיור אינו מסמן במפורש איזה רכיב נבחר לדוגמה, ואינו מוכיח שכל חשבון בליבה הוא חשבון של מבצע השפעה. בשקופית הבאה נסביר איך נבחר רכיב קשיר של 312 חשבונות מתוך הליבה המרבית, ולאחר מכן נבחן את התוכן שפורסם.</a:t>
-            </a:r>
+            <a:endParaRPr b="1" dirty="0"/>
           </a:p>
         </p:txBody>
       </p:sp>
@@ -15106,8 +12838,8 @@
           </a:p>
         </p:txBody>
       </p:sp>
-      <mc:AlternateContent xmlns:mc="http://schemas.openxmlformats.org/markup-compatibility/2006">
-        <mc:Choice xmlns:a14="http://schemas.microsoft.com/office/drawing/2010/main" Requires="a14">
+      <mc:AlternateContent xmlns:mc="http://schemas.openxmlformats.org/markup-compatibility/2006" xmlns:a14="http://schemas.microsoft.com/office/drawing/2010/main">
+        <mc:Choice Requires="a14">
           <p:sp>
             <p:nvSpPr>
               <p:cNvPr id="3" name="Content Placeholder 2">
@@ -15238,7 +12970,7 @@
             </p:txBody>
           </p:sp>
         </mc:Choice>
-        <mc:Fallback>
+        <mc:Fallback xmlns="">
           <p:sp>
             <p:nvSpPr>
               <p:cNvPr id="3" name="Content Placeholder 2">
@@ -17312,13 +15044,30 @@
         </p:nvSpPr>
         <p:spPr/>
         <p:txBody>
-          <a:bodyPr/>
+          <a:bodyPr>
+            <a:normAutofit/>
+          </a:bodyPr>
           <a:lstStyle/>
           <a:p>
-            <a:r>
-              <a:rPr lang="en-IL" dirty="0"/>
+            <a:pPr>
+              <a:defRPr sz="4200" b="0">
+                <a:solidFill>
+                  <a:srgbClr val="00A0BD"/>
+                </a:solidFill>
+                <a:latin typeface="Calibri"/>
+                <a:ea typeface="Calibri"/>
+                <a:cs typeface="Calibri"/>
+              </a:defRPr>
+            </a:pPr>
+            <a:r>
+              <a:rPr lang="en-IL" dirty="0">
+                <a:latin typeface="Calibri Light (Headings)"/>
+              </a:rPr>
               <a:t>Evaluation Settings</a:t>
             </a:r>
+            <a:endParaRPr lang="en-GB" dirty="0">
+              <a:latin typeface="Calibri Light (Headings)"/>
+            </a:endParaRPr>
           </a:p>
         </p:txBody>
       </p:sp>
@@ -17464,7 +15213,13 @@
   <p:cSld>
     <p:spTree>
       <p:nvGrpSpPr>
-        <p:cNvPr id="1" name=""/>
+        <p:cNvPr id="1" name="">
+          <a:extLst>
+            <a:ext uri="{FF2B5EF4-FFF2-40B4-BE49-F238E27FC236}">
+              <a16:creationId xmlns:a16="http://schemas.microsoft.com/office/drawing/2014/main" id="{70A87C98-022F-3CFA-B475-FE8E119F7538}"/>
+            </a:ext>
+          </a:extLst>
+        </p:cNvPr>
         <p:cNvGrpSpPr/>
         <p:nvPr/>
       </p:nvGrpSpPr>
@@ -17478,123 +15233,85 @@
       </p:grpSpPr>
       <p:sp>
         <p:nvSpPr>
-          <p:cNvPr id="6" name="Appendix: Evaluated Campaigns">
+          <p:cNvPr id="2" name="Title 1">
             <a:extLst>
               <a:ext uri="{FF2B5EF4-FFF2-40B4-BE49-F238E27FC236}">
-                <a16:creationId xmlns:a16="http://schemas.microsoft.com/office/drawing/2014/main" id="{7296D56E-AA29-4FBF-A2FC-7A1958B9E10A}"/>
+                <a16:creationId xmlns:a16="http://schemas.microsoft.com/office/drawing/2014/main" id="{EB31E7EB-EA44-1B2A-F83F-AE5ED6CED867}"/>
               </a:ext>
             </a:extLst>
           </p:cNvPr>
           <p:cNvSpPr>
             <a:spLocks noGrp="1"/>
           </p:cNvSpPr>
-          <p:nvPr/>
+          <p:nvPr>
+            <p:ph type="title"/>
+          </p:nvPr>
         </p:nvSpPr>
-        <p:spPr>
-          <a:xfrm>
-            <a:off x="3143250" y="619125"/>
-            <a:ext cx="8572500" cy="1047750"/>
-          </a:xfrm>
-          <a:prstGeom prst="rect">
-            <a:avLst/>
-          </a:prstGeom>
-          <a:noFill/>
-          <a:ln w="0">
-            <a:noFill/>
-          </a:ln>
-        </p:spPr>
+        <p:spPr/>
         <p:txBody>
-          <a:bodyPr lIns="0" tIns="0" rIns="0" bIns="0" anchor="t">
-            <a:noAutofit/>
-          </a:bodyPr>
+          <a:bodyPr/>
           <a:lstStyle/>
           <a:p>
-            <a:pPr>
-              <a:buNone/>
-              <a:defRPr sz="4200" b="0">
+            <a:r>
+              <a:rPr lang="en-GB" dirty="0">
                 <a:solidFill>
                   <a:srgbClr val="00A0BD"/>
                 </a:solidFill>
-                <a:latin typeface="Calibri"/>
-                <a:ea typeface="Calibri"/>
-                <a:cs typeface="Calibri"/>
-              </a:defRPr>
-            </a:pPr>
-            <a:r>
-              <a:rPr sz="4200" b="0" dirty="0">
-                <a:solidFill>
-                  <a:srgbClr val="00A0BD"/>
-                </a:solidFill>
-                <a:latin typeface="Calibri"/>
+                <a:latin typeface="Calibri Light (Headings)"/>
                 <a:ea typeface="Calibri"/>
                 <a:cs typeface="Calibri"/>
               </a:rPr>
               <a:t>Evaluated Campaigns</a:t>
             </a:r>
+            <a:endParaRPr lang="en-IL" dirty="0">
+              <a:solidFill>
+                <a:srgbClr val="00A0BD"/>
+              </a:solidFill>
+              <a:latin typeface="Calibri Light (Headings)"/>
+              <a:ea typeface="Calibri"/>
+              <a:cs typeface="Calibri"/>
+            </a:endParaRPr>
           </a:p>
         </p:txBody>
       </p:sp>
       <p:sp>
         <p:nvSpPr>
-          <p:cNvPr id="3" name="12">
+          <p:cNvPr id="4" name="Slide Number Placeholder 3">
             <a:extLst>
               <a:ext uri="{FF2B5EF4-FFF2-40B4-BE49-F238E27FC236}">
-                <a16:creationId xmlns:a16="http://schemas.microsoft.com/office/drawing/2014/main" id="{1A924256-7FDE-4C40-AD66-3EED7F4FFF21}"/>
+                <a16:creationId xmlns:a16="http://schemas.microsoft.com/office/drawing/2014/main" id="{78A16AD6-2F5E-1530-EDFB-8A6E79B79A50}"/>
               </a:ext>
             </a:extLst>
           </p:cNvPr>
           <p:cNvSpPr>
             <a:spLocks noGrp="1"/>
           </p:cNvSpPr>
-          <p:nvPr/>
+          <p:nvPr>
+            <p:ph type="sldNum" sz="quarter" idx="12"/>
+          </p:nvPr>
         </p:nvSpPr>
-        <p:spPr>
-          <a:xfrm>
-            <a:off x="11753850" y="6524625"/>
-            <a:ext cx="285750" cy="209550"/>
-          </a:xfrm>
-          <a:prstGeom prst="rect">
-            <a:avLst/>
-          </a:prstGeom>
-          <a:noFill/>
-          <a:ln w="0">
-            <a:noFill/>
-          </a:ln>
-        </p:spPr>
+        <p:spPr/>
         <p:txBody>
-          <a:bodyPr lIns="0" tIns="0" rIns="0" bIns="0" anchor="t">
-            <a:noAutofit/>
-          </a:bodyPr>
+          <a:bodyPr/>
           <a:lstStyle/>
           <a:p>
-            <a:pPr>
-              <a:buNone/>
-              <a:defRPr sz="1125" b="0">
-                <a:solidFill>
-                  <a:srgbClr val="888888"/>
-                </a:solidFill>
-                <a:latin typeface="Calibri"/>
-                <a:ea typeface="Calibri"/>
-                <a:cs typeface="Calibri"/>
-              </a:defRPr>
-            </a:pPr>
-            <a:r>
-              <a:rPr sz="1125" b="0">
-                <a:solidFill>
-                  <a:srgbClr val="888888"/>
-                </a:solidFill>
-                <a:latin typeface="Calibri"/>
-                <a:ea typeface="Calibri"/>
-                <a:cs typeface="Calibri"/>
-              </a:rPr>
-              <a:t>7</a:t>
-            </a:r>
+            <a:fld id="{E6AB8EDD-9EF2-4633-A1C2-4D908C1019B4}" type="slidenum">
+              <a:rPr lang="he-IL" smtClean="0"/>
+              <a:t>22</a:t>
+            </a:fld>
+            <a:endParaRPr lang="he-IL"/>
           </a:p>
         </p:txBody>
       </p:sp>
       <p:graphicFrame>
         <p:nvGraphicFramePr>
-          <p:cNvPr id="12" name="Table 11"/>
+          <p:cNvPr id="6" name="Table 5">
+            <a:extLst>
+              <a:ext uri="{FF2B5EF4-FFF2-40B4-BE49-F238E27FC236}">
+                <a16:creationId xmlns:a16="http://schemas.microsoft.com/office/drawing/2014/main" id="{3490C3D4-460A-A0EB-E16F-294FCD4E1D7F}"/>
+              </a:ext>
+            </a:extLst>
+          </p:cNvPr>
           <p:cNvGraphicFramePr/>
           <p:nvPr/>
         </p:nvGraphicFramePr>
@@ -17653,7 +15370,7 @@
                         <a:buNone/>
                       </a:pPr>
                       <a:r>
-                        <a:rPr sz="1950" b="1">
+                        <a:rPr sz="1950" b="1" dirty="0">
                           <a:solidFill>
                             <a:srgbClr val="FFFFFF"/>
                           </a:solidFill>
@@ -17964,7 +15681,7 @@
                         <a:buNone/>
                       </a:pPr>
                       <a:r>
-                        <a:rPr sz="1950" b="0">
+                        <a:rPr sz="1950" b="0" dirty="0">
                           <a:solidFill>
                             <a:srgbClr val="171717"/>
                           </a:solidFill>
@@ -18079,7 +15796,7 @@
                         <a:buNone/>
                       </a:pPr>
                       <a:r>
-                        <a:rPr sz="1950" b="0">
+                        <a:rPr sz="1950" b="0" dirty="0">
                           <a:solidFill>
                             <a:srgbClr val="171717"/>
                           </a:solidFill>
@@ -18613,7 +16330,7 @@
                         <a:buNone/>
                       </a:pPr>
                       <a:r>
-                        <a:rPr sz="1950" b="0">
+                        <a:rPr sz="1950" b="0" dirty="0">
                           <a:solidFill>
                             <a:srgbClr val="171717"/>
                           </a:solidFill>
@@ -18643,10 +16360,10 @@
       </p:graphicFrame>
       <p:sp>
         <p:nvSpPr>
-          <p:cNvPr id="5" name="Controls used the same hashtags on the same dates as IO acco">
+          <p:cNvPr id="8" name="Controls used the same hashtags on the same dates as IO acco">
             <a:extLst>
               <a:ext uri="{FF2B5EF4-FFF2-40B4-BE49-F238E27FC236}">
-                <a16:creationId xmlns:a16="http://schemas.microsoft.com/office/drawing/2014/main" id="{46B1D6CE-02FA-4FDF-A4CF-B2A103EDE7F9}"/>
+                <a16:creationId xmlns:a16="http://schemas.microsoft.com/office/drawing/2014/main" id="{96A88D5C-6AA2-E3A3-7847-898B42EF19A7}"/>
               </a:ext>
             </a:extLst>
           </p:cNvPr>
@@ -18726,7 +16443,7 @@
     </p:spTree>
     <p:extLst>
       <p:ext uri="{BB962C8B-B14F-4D97-AF65-F5344CB8AC3E}">
-        <p14:creationId xmlns:p14="http://schemas.microsoft.com/office/powerpoint/2010/main" val="4180236779"/>
+        <p14:creationId xmlns:p14="http://schemas.microsoft.com/office/powerpoint/2010/main" val="1746502308"/>
       </p:ext>
     </p:extLst>
   </p:cSld>
@@ -18741,7 +16458,13 @@
   <p:cSld>
     <p:spTree>
       <p:nvGrpSpPr>
-        <p:cNvPr id="1" name=""/>
+        <p:cNvPr id="1" name="">
+          <a:extLst>
+            <a:ext uri="{FF2B5EF4-FFF2-40B4-BE49-F238E27FC236}">
+              <a16:creationId xmlns:a16="http://schemas.microsoft.com/office/drawing/2014/main" id="{FC873C6E-5D04-1502-D2A7-AC32F50B2ACD}"/>
+            </a:ext>
+          </a:extLst>
+        </p:cNvPr>
         <p:cNvGrpSpPr/>
         <p:nvPr/>
       </p:nvGrpSpPr>
@@ -18755,35 +16478,23 @@
       </p:grpSpPr>
       <p:sp>
         <p:nvSpPr>
-          <p:cNvPr id="6" name="Which Indicators Matter?">
+          <p:cNvPr id="2" name="Title 1">
             <a:extLst>
               <a:ext uri="{FF2B5EF4-FFF2-40B4-BE49-F238E27FC236}">
-                <a16:creationId xmlns:a16="http://schemas.microsoft.com/office/drawing/2014/main" id="{A06507E9-A585-44D8-93CC-D08CEC382642}"/>
+                <a16:creationId xmlns:a16="http://schemas.microsoft.com/office/drawing/2014/main" id="{D139D69B-CA03-EE89-F943-1001359FEAE4}"/>
               </a:ext>
             </a:extLst>
           </p:cNvPr>
           <p:cNvSpPr>
             <a:spLocks noGrp="1"/>
           </p:cNvSpPr>
-          <p:nvPr/>
+          <p:nvPr>
+            <p:ph type="title"/>
+          </p:nvPr>
         </p:nvSpPr>
-        <p:spPr>
-          <a:xfrm>
-            <a:off x="3143250" y="619125"/>
-            <a:ext cx="8572500" cy="1047750"/>
-          </a:xfrm>
-          <a:prstGeom prst="rect">
-            <a:avLst/>
-          </a:prstGeom>
-          <a:noFill/>
-          <a:ln w="0">
-            <a:noFill/>
-          </a:ln>
-        </p:spPr>
+        <p:spPr/>
         <p:txBody>
-          <a:bodyPr lIns="0" tIns="0" rIns="0" bIns="0" anchor="t">
-            <a:noAutofit/>
-          </a:bodyPr>
+          <a:bodyPr/>
           <a:lstStyle/>
           <a:p>
             <a:pPr>
@@ -18797,13 +16508,8 @@
               </a:defRPr>
             </a:pPr>
             <a:r>
-              <a:rPr sz="4400" dirty="0">
-                <a:solidFill>
-                  <a:srgbClr val="009DBB"/>
-                </a:solidFill>
-                <a:latin typeface="+mj-lt"/>
-                <a:ea typeface="+mj-ea"/>
-                <a:cs typeface="+mj-cs"/>
+              <a:rPr lang="en-GB" sz="4000" dirty="0">
+                <a:latin typeface="Calibri Light (Headings)"/>
               </a:rPr>
               <a:t>Which Indicators Matter?</a:t>
             </a:r>
@@ -18812,72 +16518,49 @@
       </p:sp>
       <p:sp>
         <p:nvSpPr>
-          <p:cNvPr id="3" name="0">
+          <p:cNvPr id="4" name="Slide Number Placeholder 3">
             <a:extLst>
               <a:ext uri="{FF2B5EF4-FFF2-40B4-BE49-F238E27FC236}">
-                <a16:creationId xmlns:a16="http://schemas.microsoft.com/office/drawing/2014/main" id="{487BEFB4-C286-4E43-926A-7C5B834E0C6E}"/>
+                <a16:creationId xmlns:a16="http://schemas.microsoft.com/office/drawing/2014/main" id="{500ADB10-D72A-D2E9-5B5E-9246822B80A3}"/>
               </a:ext>
             </a:extLst>
           </p:cNvPr>
           <p:cNvSpPr>
             <a:spLocks noGrp="1"/>
           </p:cNvSpPr>
-          <p:nvPr/>
+          <p:nvPr>
+            <p:ph type="sldNum" sz="quarter" idx="12"/>
+          </p:nvPr>
         </p:nvSpPr>
-        <p:spPr>
-          <a:xfrm>
-            <a:off x="11753850" y="6524625"/>
-            <a:ext cx="285750" cy="209550"/>
-          </a:xfrm>
-          <a:prstGeom prst="rect">
-            <a:avLst/>
-          </a:prstGeom>
-          <a:noFill/>
-          <a:ln w="0">
-            <a:noFill/>
-          </a:ln>
-        </p:spPr>
+        <p:spPr/>
         <p:txBody>
-          <a:bodyPr lIns="0" tIns="0" rIns="0" bIns="0" anchor="t">
-            <a:noAutofit/>
-          </a:bodyPr>
+          <a:bodyPr/>
           <a:lstStyle/>
           <a:p>
-            <a:pPr>
-              <a:buNone/>
-              <a:defRPr sz="1125" b="0">
-                <a:solidFill>
-                  <a:srgbClr val="888888"/>
-                </a:solidFill>
-                <a:latin typeface="Calibri"/>
-                <a:ea typeface="Calibri"/>
-                <a:cs typeface="Calibri"/>
-              </a:defRPr>
-            </a:pPr>
-            <a:r>
-              <a:rPr sz="1125" b="0">
-                <a:solidFill>
-                  <a:srgbClr val="888888"/>
-                </a:solidFill>
-                <a:latin typeface="Calibri"/>
-                <a:ea typeface="Calibri"/>
-                <a:cs typeface="Calibri"/>
-              </a:rPr>
-              <a:t>9</a:t>
-            </a:r>
+            <a:fld id="{E6AB8EDD-9EF2-4633-A1C2-4D908C1019B4}" type="slidenum">
+              <a:rPr lang="he-IL" smtClean="0"/>
+              <a:t>23</a:t>
+            </a:fld>
+            <a:endParaRPr lang="he-IL" dirty="0"/>
           </a:p>
         </p:txBody>
       </p:sp>
       <p:pic>
         <p:nvPicPr>
-          <p:cNvPr id="12" name="Picture 11"/>
+          <p:cNvPr id="5" name="Picture 4">
+            <a:extLst>
+              <a:ext uri="{FF2B5EF4-FFF2-40B4-BE49-F238E27FC236}">
+                <a16:creationId xmlns:a16="http://schemas.microsoft.com/office/drawing/2014/main" id="{E2AFA6FE-3C68-6985-BD91-EEF3E9C2AB49}"/>
+              </a:ext>
+            </a:extLst>
+          </p:cNvPr>
           <p:cNvPicPr>
             <a:picLocks noChangeAspect="1"/>
           </p:cNvPicPr>
           <p:nvPr/>
         </p:nvPicPr>
         <p:blipFill>
-          <a:blip r:embed="rId3"/>
+          <a:blip r:embed="rId2"/>
           <a:srcRect b="2502"/>
           <a:stretch>
             <a:fillRect/>
@@ -18895,65 +16578,10 @@
       </p:pic>
       <p:sp>
         <p:nvSpPr>
-          <p:cNvPr id="5" name="XGBoost: indicator importance varies across campaigns.">
+          <p:cNvPr id="9" name="TextBox 8">
             <a:extLst>
               <a:ext uri="{FF2B5EF4-FFF2-40B4-BE49-F238E27FC236}">
-                <a16:creationId xmlns:a16="http://schemas.microsoft.com/office/drawing/2014/main" id="{05D7B769-602A-456C-9F66-E65D3F1DF3A9}"/>
-              </a:ext>
-            </a:extLst>
-          </p:cNvPr>
-          <p:cNvSpPr>
-            <a:spLocks noGrp="1"/>
-          </p:cNvSpPr>
-          <p:nvPr/>
-        </p:nvSpPr>
-        <p:spPr>
-          <a:xfrm>
-            <a:off x="1381125" y="6362700"/>
-            <a:ext cx="10096500" cy="371475"/>
-          </a:xfrm>
-          <a:prstGeom prst="rect">
-            <a:avLst/>
-          </a:prstGeom>
-          <a:noFill/>
-          <a:ln w="0">
-            <a:noFill/>
-          </a:ln>
-        </p:spPr>
-        <p:txBody>
-          <a:bodyPr lIns="0" tIns="0" rIns="0" bIns="0" anchor="t">
-            <a:noAutofit/>
-          </a:bodyPr>
-          <a:lstStyle/>
-          <a:p>
-            <a:pPr>
-              <a:buNone/>
-              <a:defRPr sz="2100" b="1">
-                <a:solidFill>
-                  <a:srgbClr val="171717"/>
-                </a:solidFill>
-                <a:latin typeface="Calibri"/>
-                <a:ea typeface="Calibri"/>
-                <a:cs typeface="Calibri"/>
-              </a:defRPr>
-            </a:pPr>
-            <a:endParaRPr sz="2100" dirty="0">
-              <a:solidFill>
-                <a:srgbClr val="171717"/>
-              </a:solidFill>
-              <a:latin typeface="Calibri"/>
-              <a:ea typeface="Calibri"/>
-              <a:cs typeface="Calibri"/>
-            </a:endParaRPr>
-          </a:p>
-        </p:txBody>
-      </p:sp>
-      <p:sp>
-        <p:nvSpPr>
-          <p:cNvPr id="4" name="TextBox 3">
-            <a:extLst>
-              <a:ext uri="{FF2B5EF4-FFF2-40B4-BE49-F238E27FC236}">
-                <a16:creationId xmlns:a16="http://schemas.microsoft.com/office/drawing/2014/main" id="{30B62C13-0E81-CC7A-CA39-E06720127667}"/>
+                <a16:creationId xmlns:a16="http://schemas.microsoft.com/office/drawing/2014/main" id="{8B959349-8F70-A874-F2C0-9EB013B156DC}"/>
               </a:ext>
             </a:extLst>
           </p:cNvPr>
@@ -18998,7 +16626,7 @@
     </p:spTree>
     <p:extLst>
       <p:ext uri="{BB962C8B-B14F-4D97-AF65-F5344CB8AC3E}">
-        <p14:creationId xmlns:p14="http://schemas.microsoft.com/office/powerpoint/2010/main" val="588618937"/>
+        <p14:creationId xmlns:p14="http://schemas.microsoft.com/office/powerpoint/2010/main" val="3065009200"/>
       </p:ext>
     </p:extLst>
   </p:cSld>
@@ -19079,86 +16707,6 @@
                 <a:cs typeface="+mj-cs"/>
               </a:rPr>
               <a:t>Detection Across Campaigns</a:t>
-            </a:r>
-          </a:p>
-        </p:txBody>
-      </p:sp>
-      <p:pic>
-        <p:nvPicPr>
-          <p:cNvPr id="16" name="Picture 15"/>
-          <p:cNvPicPr>
-            <a:picLocks noChangeAspect="1"/>
-          </p:cNvPicPr>
-          <p:nvPr/>
-        </p:nvPicPr>
-        <p:blipFill>
-          <a:blip r:embed="rId3"/>
-          <a:stretch/>
-        </p:blipFill>
-        <p:spPr>
-          <a:xfrm>
-            <a:off x="9052941" y="6048375"/>
-            <a:ext cx="2642902" cy="797909"/>
-          </a:xfrm>
-          <a:prstGeom prst="rect">
-            <a:avLst/>
-          </a:prstGeom>
-        </p:spPr>
-      </p:pic>
-      <p:sp>
-        <p:nvSpPr>
-          <p:cNvPr id="3" name="0">
-            <a:extLst>
-              <a:ext uri="{FF2B5EF4-FFF2-40B4-BE49-F238E27FC236}">
-                <a16:creationId xmlns:a16="http://schemas.microsoft.com/office/drawing/2014/main" id="{5E6A08B0-E761-4821-9FE0-23570C64CBD7}"/>
-              </a:ext>
-            </a:extLst>
-          </p:cNvPr>
-          <p:cNvSpPr>
-            <a:spLocks noGrp="1"/>
-          </p:cNvSpPr>
-          <p:nvPr/>
-        </p:nvSpPr>
-        <p:spPr>
-          <a:xfrm>
-            <a:off x="11753850" y="6524625"/>
-            <a:ext cx="285750" cy="209550"/>
-          </a:xfrm>
-          <a:prstGeom prst="rect">
-            <a:avLst/>
-          </a:prstGeom>
-          <a:noFill/>
-          <a:ln w="0">
-            <a:noFill/>
-          </a:ln>
-        </p:spPr>
-        <p:txBody>
-          <a:bodyPr lIns="0" tIns="0" rIns="0" bIns="0" anchor="t">
-            <a:noAutofit/>
-          </a:bodyPr>
-          <a:lstStyle/>
-          <a:p>
-            <a:pPr>
-              <a:buNone/>
-              <a:defRPr sz="1125" b="0">
-                <a:solidFill>
-                  <a:srgbClr val="888888"/>
-                </a:solidFill>
-                <a:latin typeface="Calibri"/>
-                <a:ea typeface="Calibri"/>
-                <a:cs typeface="Calibri"/>
-              </a:defRPr>
-            </a:pPr>
-            <a:r>
-              <a:rPr sz="1125" b="0">
-                <a:solidFill>
-                  <a:srgbClr val="888888"/>
-                </a:solidFill>
-                <a:latin typeface="Calibri"/>
-                <a:ea typeface="Calibri"/>
-                <a:cs typeface="Calibri"/>
-              </a:rPr>
-              <a:t>10</a:t>
             </a:r>
           </a:p>
         </p:txBody>
@@ -20618,6 +18166,40 @@
           </a:p>
         </p:txBody>
       </p:sp>
+      <p:sp>
+        <p:nvSpPr>
+          <p:cNvPr id="2" name="Slide Number Placeholder 3">
+            <a:extLst>
+              <a:ext uri="{FF2B5EF4-FFF2-40B4-BE49-F238E27FC236}">
+                <a16:creationId xmlns:a16="http://schemas.microsoft.com/office/drawing/2014/main" id="{CB8918E9-041D-B80C-2A81-5E64D9D9CB68}"/>
+              </a:ext>
+            </a:extLst>
+          </p:cNvPr>
+          <p:cNvSpPr>
+            <a:spLocks noGrp="1"/>
+          </p:cNvSpPr>
+          <p:nvPr>
+            <p:ph type="sldNum" sz="quarter" idx="12"/>
+          </p:nvPr>
+        </p:nvSpPr>
+        <p:spPr>
+          <a:xfrm>
+            <a:off x="11728704" y="6464649"/>
+            <a:ext cx="452233" cy="365125"/>
+          </a:xfrm>
+        </p:spPr>
+        <p:txBody>
+          <a:bodyPr/>
+          <a:lstStyle/>
+          <a:p>
+            <a:fld id="{E6AB8EDD-9EF2-4633-A1C2-4D908C1019B4}" type="slidenum">
+              <a:rPr lang="he-IL" smtClean="0"/>
+              <a:t>24</a:t>
+            </a:fld>
+            <a:endParaRPr lang="he-IL" dirty="0"/>
+          </a:p>
+        </p:txBody>
+      </p:sp>
     </p:spTree>
     <p:extLst>
       <p:ext uri="{BB962C8B-B14F-4D97-AF65-F5344CB8AC3E}">
@@ -20706,64 +18288,6 @@
           </a:p>
         </p:txBody>
       </p:sp>
-      <p:sp>
-        <p:nvSpPr>
-          <p:cNvPr id="3" name="15">
-            <a:extLst>
-              <a:ext uri="{FF2B5EF4-FFF2-40B4-BE49-F238E27FC236}">
-                <a16:creationId xmlns:a16="http://schemas.microsoft.com/office/drawing/2014/main" id="{9792A4AE-8816-49D6-BCA5-63AFC007D4F8}"/>
-              </a:ext>
-            </a:extLst>
-          </p:cNvPr>
-          <p:cNvSpPr>
-            <a:spLocks noGrp="1"/>
-          </p:cNvSpPr>
-          <p:nvPr/>
-        </p:nvSpPr>
-        <p:spPr>
-          <a:xfrm>
-            <a:off x="11753850" y="6524625"/>
-            <a:ext cx="285750" cy="209550"/>
-          </a:xfrm>
-          <a:prstGeom prst="rect">
-            <a:avLst/>
-          </a:prstGeom>
-          <a:noFill/>
-          <a:ln w="0">
-            <a:noFill/>
-          </a:ln>
-        </p:spPr>
-        <p:txBody>
-          <a:bodyPr lIns="0" tIns="0" rIns="0" bIns="0" anchor="t">
-            <a:noAutofit/>
-          </a:bodyPr>
-          <a:lstStyle/>
-          <a:p>
-            <a:pPr>
-              <a:buNone/>
-              <a:defRPr sz="1125" b="0">
-                <a:solidFill>
-                  <a:srgbClr val="888888"/>
-                </a:solidFill>
-                <a:latin typeface="Calibri"/>
-                <a:ea typeface="Calibri"/>
-                <a:cs typeface="Calibri"/>
-              </a:defRPr>
-            </a:pPr>
-            <a:r>
-              <a:rPr sz="1125" b="0">
-                <a:solidFill>
-                  <a:srgbClr val="888888"/>
-                </a:solidFill>
-                <a:latin typeface="Calibri"/>
-                <a:ea typeface="Calibri"/>
-                <a:cs typeface="Calibri"/>
-              </a:rPr>
-              <a:t>12</a:t>
-            </a:r>
-          </a:p>
-        </p:txBody>
-      </p:sp>
       <p:pic>
         <p:nvPicPr>
           <p:cNvPr id="13" name="Picture 12"/>
@@ -20953,6 +18477,40 @@
               </a:rPr>
               <a:t>-predicted IO accounts. Bottom: all accounts.</a:t>
             </a:r>
+          </a:p>
+        </p:txBody>
+      </p:sp>
+      <p:sp>
+        <p:nvSpPr>
+          <p:cNvPr id="2" name="Slide Number Placeholder 3">
+            <a:extLst>
+              <a:ext uri="{FF2B5EF4-FFF2-40B4-BE49-F238E27FC236}">
+                <a16:creationId xmlns:a16="http://schemas.microsoft.com/office/drawing/2014/main" id="{9D15F5CE-A275-71AC-34C5-914683A24ED6}"/>
+              </a:ext>
+            </a:extLst>
+          </p:cNvPr>
+          <p:cNvSpPr>
+            <a:spLocks noGrp="1"/>
+          </p:cNvSpPr>
+          <p:nvPr>
+            <p:ph type="sldNum" sz="quarter" idx="12"/>
+          </p:nvPr>
+        </p:nvSpPr>
+        <p:spPr>
+          <a:xfrm>
+            <a:off x="11728704" y="6464649"/>
+            <a:ext cx="452233" cy="365125"/>
+          </a:xfrm>
+        </p:spPr>
+        <p:txBody>
+          <a:bodyPr/>
+          <a:lstStyle/>
+          <a:p>
+            <a:fld id="{E6AB8EDD-9EF2-4633-A1C2-4D908C1019B4}" type="slidenum">
+              <a:rPr lang="he-IL" smtClean="0"/>
+              <a:t>25</a:t>
+            </a:fld>
+            <a:endParaRPr lang="he-IL" dirty="0"/>
           </a:p>
         </p:txBody>
       </p:sp>
@@ -21046,64 +18604,6 @@
       </p:sp>
       <p:sp>
         <p:nvSpPr>
-          <p:cNvPr id="3" name="0">
-            <a:extLst>
-              <a:ext uri="{FF2B5EF4-FFF2-40B4-BE49-F238E27FC236}">
-                <a16:creationId xmlns:a16="http://schemas.microsoft.com/office/drawing/2014/main" id="{93987AA9-C65E-4D6D-A85D-31A425216642}"/>
-              </a:ext>
-            </a:extLst>
-          </p:cNvPr>
-          <p:cNvSpPr>
-            <a:spLocks noGrp="1"/>
-          </p:cNvSpPr>
-          <p:nvPr/>
-        </p:nvSpPr>
-        <p:spPr>
-          <a:xfrm>
-            <a:off x="11753850" y="6524625"/>
-            <a:ext cx="285750" cy="209550"/>
-          </a:xfrm>
-          <a:prstGeom prst="rect">
-            <a:avLst/>
-          </a:prstGeom>
-          <a:noFill/>
-          <a:ln w="0">
-            <a:noFill/>
-          </a:ln>
-        </p:spPr>
-        <p:txBody>
-          <a:bodyPr lIns="0" tIns="0" rIns="0" bIns="0" anchor="t">
-            <a:noAutofit/>
-          </a:bodyPr>
-          <a:lstStyle/>
-          <a:p>
-            <a:pPr>
-              <a:buNone/>
-              <a:defRPr sz="1125" b="0">
-                <a:solidFill>
-                  <a:srgbClr val="888888"/>
-                </a:solidFill>
-                <a:latin typeface="Calibri"/>
-                <a:ea typeface="Calibri"/>
-                <a:cs typeface="Calibri"/>
-              </a:defRPr>
-            </a:pPr>
-            <a:r>
-              <a:rPr sz="1125" b="0">
-                <a:solidFill>
-                  <a:srgbClr val="888888"/>
-                </a:solidFill>
-                <a:latin typeface="Calibri"/>
-                <a:ea typeface="Calibri"/>
-                <a:cs typeface="Calibri"/>
-              </a:rPr>
-              <a:t>13</a:t>
-            </a:r>
-          </a:p>
-        </p:txBody>
-      </p:sp>
-      <p:sp>
-        <p:nvSpPr>
           <p:cNvPr id="4" name="Core number">
             <a:extLst>
               <a:ext uri="{FF2B5EF4-FFF2-40B4-BE49-F238E27FC236}">
@@ -21295,6 +18795,40 @@
               </a:rPr>
               <a:t>High-core regions overlap with concentrations of IO accounts.</a:t>
             </a:r>
+          </a:p>
+        </p:txBody>
+      </p:sp>
+      <p:sp>
+        <p:nvSpPr>
+          <p:cNvPr id="2" name="Slide Number Placeholder 3">
+            <a:extLst>
+              <a:ext uri="{FF2B5EF4-FFF2-40B4-BE49-F238E27FC236}">
+                <a16:creationId xmlns:a16="http://schemas.microsoft.com/office/drawing/2014/main" id="{68C35B99-0216-931F-036F-FF52249EB916}"/>
+              </a:ext>
+            </a:extLst>
+          </p:cNvPr>
+          <p:cNvSpPr>
+            <a:spLocks noGrp="1"/>
+          </p:cNvSpPr>
+          <p:nvPr>
+            <p:ph type="sldNum" sz="quarter" idx="12"/>
+          </p:nvPr>
+        </p:nvSpPr>
+        <p:spPr>
+          <a:xfrm>
+            <a:off x="11728704" y="6464649"/>
+            <a:ext cx="452233" cy="365125"/>
+          </a:xfrm>
+        </p:spPr>
+        <p:txBody>
+          <a:bodyPr/>
+          <a:lstStyle/>
+          <a:p>
+            <a:fld id="{E6AB8EDD-9EF2-4633-A1C2-4D908C1019B4}" type="slidenum">
+              <a:rPr lang="he-IL" smtClean="0"/>
+              <a:t>26</a:t>
+            </a:fld>
+            <a:endParaRPr lang="he-IL" dirty="0"/>
           </a:p>
         </p:txBody>
       </p:sp>

</xml_diff>

<commit_message>
fix last slide with DOron notes
</commit_message>
<xml_diff>
--- a/docs/meeting/2026_09_23.pptx
+++ b/docs/meeting/2026_09_23.pptx
@@ -15,16 +15,16 @@
     <p:sldId id="1780" r:id="rId6"/>
     <p:sldId id="1792" r:id="rId7"/>
     <p:sldId id="1793" r:id="rId8"/>
-    <p:sldId id="1795" r:id="rId9"/>
-    <p:sldId id="1591" r:id="rId10"/>
+    <p:sldId id="1591" r:id="rId9"/>
+    <p:sldId id="1795" r:id="rId10"/>
     <p:sldId id="1797" r:id="rId11"/>
-    <p:sldId id="1796" r:id="rId12"/>
-    <p:sldId id="1794" r:id="rId13"/>
+    <p:sldId id="1794" r:id="rId12"/>
+    <p:sldId id="1796" r:id="rId13"/>
     <p:sldId id="1740" r:id="rId14"/>
-    <p:sldId id="1798" r:id="rId15"/>
-    <p:sldId id="1799" r:id="rId16"/>
-    <p:sldId id="1738" r:id="rId17"/>
-    <p:sldId id="1749" r:id="rId18"/>
+    <p:sldId id="1738" r:id="rId15"/>
+    <p:sldId id="1749" r:id="rId16"/>
+    <p:sldId id="1798" r:id="rId17"/>
+    <p:sldId id="1799" r:id="rId18"/>
     <p:sldId id="1785" r:id="rId19"/>
     <p:sldId id="1768" r:id="rId20"/>
     <p:sldId id="1800" r:id="rId21"/>
@@ -152,20 +152,20 @@
           <p14:sldIdLst>
             <p14:sldId id="1792"/>
             <p14:sldId id="1793"/>
+            <p14:sldId id="1591"/>
             <p14:sldId id="1795"/>
-            <p14:sldId id="1591"/>
             <p14:sldId id="1797"/>
+            <p14:sldId id="1794"/>
             <p14:sldId id="1796"/>
-            <p14:sldId id="1794"/>
           </p14:sldIdLst>
         </p14:section>
         <p14:section name="Group analysis" id="{2F1E73D5-870F-4091-9492-A1102BE33EA1}">
           <p14:sldIdLst>
             <p14:sldId id="1740"/>
+            <p14:sldId id="1738"/>
+            <p14:sldId id="1749"/>
             <p14:sldId id="1798"/>
             <p14:sldId id="1799"/>
-            <p14:sldId id="1738"/>
-            <p14:sldId id="1749"/>
             <p14:sldId id="1785"/>
           </p14:sldIdLst>
         </p14:section>
@@ -1749,7 +1749,7 @@
         <a:p>
           <a:r>
             <a:rPr lang="en-GB" sz="2400" dirty="0"/>
-            <a:t>1) Building a co-action graph represents author similarity (see next slide).</a:t>
+            <a:t>1) Building a co-action graph represents author similarity</a:t>
           </a:r>
           <a:endParaRPr lang="en-IL" sz="2400" dirty="0"/>
         </a:p>
@@ -2947,7 +2947,7 @@
           </a:pPr>
           <a:r>
             <a:rPr lang="en-GB" sz="2400" kern="1200" dirty="0"/>
-            <a:t>1) Building a co-action graph represents author similarity (see next slide).</a:t>
+            <a:t>1) Building a co-action graph represents author similarity</a:t>
           </a:r>
           <a:endParaRPr lang="en-IL" sz="2400" kern="1200" dirty="0"/>
         </a:p>
@@ -6561,7 +6561,7 @@
           <a:p>
             <a:fld id="{7F6CD5E7-A5BE-4430-AD67-E129D63AAC5C}" type="slidenum">
               <a:rPr lang="he-IL" smtClean="0"/>
-              <a:t>9</a:t>
+              <a:t>8</a:t>
             </a:fld>
             <a:endParaRPr lang="he-IL"/>
           </a:p>
@@ -6608,6 +6608,13 @@
           </p:nvPr>
         </p:nvSpPr>
         <p:spPr/>
+        <p:txBody>
+          <a:bodyPr/>
+          <a:lstStyle/>
+          <a:p>
+            <a:endParaRPr lang="en-IL"/>
+          </a:p>
+        </p:txBody>
       </p:sp>
       <p:sp>
         <p:nvSpPr>
@@ -6684,6 +6691,13 @@
           </p:nvPr>
         </p:nvSpPr>
         <p:spPr/>
+        <p:txBody>
+          <a:bodyPr/>
+          <a:lstStyle/>
+          <a:p>
+            <a:endParaRPr lang="en-IL"/>
+          </a:p>
+        </p:txBody>
       </p:sp>
       <p:sp>
         <p:nvSpPr>
@@ -6760,6 +6774,13 @@
           </p:nvPr>
         </p:nvSpPr>
         <p:spPr/>
+        <p:txBody>
+          <a:bodyPr/>
+          <a:lstStyle/>
+          <a:p>
+            <a:endParaRPr lang="en-IL"/>
+          </a:p>
+        </p:txBody>
       </p:sp>
       <p:sp>
         <p:nvSpPr>
@@ -11512,277 +11533,6 @@
         <p:cNvPr id="1" name="">
           <a:extLst>
             <a:ext uri="{FF2B5EF4-FFF2-40B4-BE49-F238E27FC236}">
-              <a16:creationId xmlns:a16="http://schemas.microsoft.com/office/drawing/2014/main" id="{152F7BDE-8AB5-2809-CC36-E39791D3C350}"/>
-            </a:ext>
-          </a:extLst>
-        </p:cNvPr>
-        <p:cNvGrpSpPr/>
-        <p:nvPr/>
-      </p:nvGrpSpPr>
-      <p:grpSpPr>
-        <a:xfrm>
-          <a:off x="0" y="0"/>
-          <a:ext cx="0" cy="0"/>
-          <a:chOff x="0" y="0"/>
-          <a:chExt cx="0" cy="0"/>
-        </a:xfrm>
-      </p:grpSpPr>
-      <p:sp>
-        <p:nvSpPr>
-          <p:cNvPr id="2" name="Title 1">
-            <a:extLst>
-              <a:ext uri="{FF2B5EF4-FFF2-40B4-BE49-F238E27FC236}">
-                <a16:creationId xmlns:a16="http://schemas.microsoft.com/office/drawing/2014/main" id="{4636ED3E-8C9D-906E-B977-CB4C09EF76B0}"/>
-              </a:ext>
-            </a:extLst>
-          </p:cNvPr>
-          <p:cNvSpPr>
-            <a:spLocks noGrp="1"/>
-          </p:cNvSpPr>
-          <p:nvPr>
-            <p:ph type="title"/>
-          </p:nvPr>
-        </p:nvSpPr>
-        <p:spPr/>
-        <p:txBody>
-          <a:bodyPr/>
-          <a:lstStyle/>
-          <a:p>
-            <a:r>
-              <a:rPr lang="en-IL" dirty="0"/>
-              <a:t>Topic-Based Indicators</a:t>
-            </a:r>
-            <a:endParaRPr lang="en-US" dirty="0"/>
-          </a:p>
-        </p:txBody>
-      </p:sp>
-      <p:sp>
-        <p:nvSpPr>
-          <p:cNvPr id="4" name="Slide Number Placeholder 3">
-            <a:extLst>
-              <a:ext uri="{FF2B5EF4-FFF2-40B4-BE49-F238E27FC236}">
-                <a16:creationId xmlns:a16="http://schemas.microsoft.com/office/drawing/2014/main" id="{C4EEED24-25E6-99A7-BF59-44F2CC4DDB3E}"/>
-              </a:ext>
-            </a:extLst>
-          </p:cNvPr>
-          <p:cNvSpPr>
-            <a:spLocks noGrp="1"/>
-          </p:cNvSpPr>
-          <p:nvPr>
-            <p:ph type="sldNum" sz="quarter" idx="12"/>
-          </p:nvPr>
-        </p:nvSpPr>
-        <p:spPr/>
-        <p:txBody>
-          <a:bodyPr/>
-          <a:lstStyle/>
-          <a:p>
-            <a:fld id="{E6AB8EDD-9EF2-4633-A1C2-4D908C1019B4}" type="slidenum">
-              <a:rPr lang="he-IL" smtClean="0"/>
-              <a:t>11</a:t>
-            </a:fld>
-            <a:endParaRPr lang="he-IL"/>
-          </a:p>
-        </p:txBody>
-      </p:sp>
-      <p:sp>
-        <p:nvSpPr>
-          <p:cNvPr id="7" name="Content Placeholder 5">
-            <a:extLst>
-              <a:ext uri="{FF2B5EF4-FFF2-40B4-BE49-F238E27FC236}">
-                <a16:creationId xmlns:a16="http://schemas.microsoft.com/office/drawing/2014/main" id="{B5A312C1-6DEB-B571-F05F-5AB1221CED14}"/>
-              </a:ext>
-            </a:extLst>
-          </p:cNvPr>
-          <p:cNvSpPr>
-            <a:spLocks noGrp="1"/>
-          </p:cNvSpPr>
-          <p:nvPr>
-            <p:ph idx="1"/>
-          </p:nvPr>
-        </p:nvSpPr>
-        <p:spPr>
-          <a:xfrm>
-            <a:off x="1243087" y="1825624"/>
-            <a:ext cx="10582656" cy="4546601"/>
-          </a:xfrm>
-        </p:spPr>
-        <p:txBody>
-          <a:bodyPr>
-            <a:normAutofit fontScale="92500" lnSpcReduction="10000"/>
-          </a:bodyPr>
-          <a:lstStyle/>
-          <a:p>
-            <a:r>
-              <a:rPr lang="en-IL" dirty="0"/>
-              <a:t>Calculated from each </a:t>
-            </a:r>
-            <a:r>
-              <a:rPr lang="en-IL" b="1" dirty="0"/>
-              <a:t>author’s posts and hashtags</a:t>
-            </a:r>
-            <a:r>
-              <a:rPr lang="en-IL" dirty="0"/>
-              <a:t> to capture their thematic activity.</a:t>
-            </a:r>
-          </a:p>
-          <a:p>
-            <a:r>
-              <a:rPr lang="en-IL" dirty="0"/>
-              <a:t>Activity-Based Indicators</a:t>
-            </a:r>
-          </a:p>
-          <a:p>
-            <a:pPr lvl="1"/>
-            <a:r>
-              <a:rPr lang="en-IL" sz="2400" b="1" dirty="0"/>
-              <a:t>Posting Dominance </a:t>
-            </a:r>
-            <a:r>
-              <a:rPr lang="en-US" sz="2400" dirty="0"/>
-              <a:t>-</a:t>
-            </a:r>
-            <a:r>
-              <a:rPr lang="en-IL" sz="2400" dirty="0"/>
-              <a:t> proportion of an author’s posts assigned to their most frequent topic. </a:t>
-            </a:r>
-          </a:p>
-          <a:p>
-            <a:pPr lvl="1"/>
-            <a:r>
-              <a:rPr lang="en-IL" sz="2400" b="1" dirty="0"/>
-              <a:t>Top Topic</a:t>
-            </a:r>
-            <a:r>
-              <a:rPr lang="en-IL" sz="2400" dirty="0"/>
-              <a:t> </a:t>
-            </a:r>
-            <a:r>
-              <a:rPr lang="en-US" sz="2400" dirty="0"/>
-              <a:t>-</a:t>
-            </a:r>
-            <a:r>
-              <a:rPr lang="en-IL" sz="2400" dirty="0"/>
-              <a:t> the author’s dominant topic. </a:t>
-            </a:r>
-          </a:p>
-          <a:p>
-            <a:r>
-              <a:rPr lang="en-IL" dirty="0"/>
-              <a:t>TF</a:t>
-            </a:r>
-            <a:r>
-              <a:rPr lang="en-US" dirty="0"/>
-              <a:t>-</a:t>
-            </a:r>
-            <a:r>
-              <a:rPr lang="en-IL" dirty="0"/>
-              <a:t>IDF-Based Indicators</a:t>
-            </a:r>
-            <a:r>
-              <a:rPr lang="en-US" dirty="0"/>
-              <a:t> </a:t>
-            </a:r>
-            <a:r>
-              <a:rPr lang="en-US" sz="1900" dirty="0"/>
-              <a:t>(see next slide)</a:t>
-            </a:r>
-            <a:endParaRPr lang="en-IL" sz="1900" dirty="0"/>
-          </a:p>
-          <a:p>
-            <a:pPr lvl="1"/>
-            <a:r>
-              <a:rPr lang="en-IL" sz="2400" b="1" dirty="0"/>
-              <a:t>Key Score (Topic)</a:t>
-            </a:r>
-            <a:r>
-              <a:rPr lang="en-IL" sz="2400" dirty="0"/>
-              <a:t> </a:t>
-            </a:r>
-            <a:r>
-              <a:rPr lang="en-US" sz="2400" dirty="0"/>
-              <a:t>-</a:t>
-            </a:r>
-            <a:r>
-              <a:rPr lang="en-IL" sz="2400" dirty="0"/>
-              <a:t> author’s relevance to a specific topic, calculated by aggregating the TF</a:t>
-            </a:r>
-            <a:r>
-              <a:rPr lang="en-US" sz="2400" dirty="0"/>
-              <a:t>-</a:t>
-            </a:r>
-            <a:r>
-              <a:rPr lang="en-IL" sz="2400" dirty="0"/>
-              <a:t>IDF scores of the entities used by the author in that topic, with a penalty for activity across multiple topics. </a:t>
-            </a:r>
-          </a:p>
-          <a:p>
-            <a:pPr lvl="1"/>
-            <a:r>
-              <a:rPr lang="en-IL" sz="2400" b="1" dirty="0"/>
-              <a:t>Key Score Sum </a:t>
-            </a:r>
-            <a:r>
-              <a:rPr lang="en-US" sz="2400" dirty="0"/>
-              <a:t>-</a:t>
-            </a:r>
-            <a:r>
-              <a:rPr lang="en-IL" sz="2400" dirty="0"/>
-              <a:t> sum of the author’s key scores across all topics. </a:t>
-            </a:r>
-          </a:p>
-          <a:p>
-            <a:pPr lvl="1"/>
-            <a:r>
-              <a:rPr lang="en-IL" sz="2400" b="1" dirty="0"/>
-              <a:t>Key Score Dominance </a:t>
-            </a:r>
-            <a:r>
-              <a:rPr lang="en-US" sz="2400" dirty="0"/>
-              <a:t>-</a:t>
-            </a:r>
-            <a:r>
-              <a:rPr lang="en-IL" sz="2400" dirty="0"/>
-              <a:t> proportion of the total key score concentrated in the author’s strongest topic.</a:t>
-            </a:r>
-          </a:p>
-          <a:p>
-            <a:r>
-              <a:rPr lang="en-IL" dirty="0"/>
-              <a:t>Together, these indicators capture the </a:t>
-            </a:r>
-            <a:r>
-              <a:rPr lang="en-IL" b="1" dirty="0"/>
-              <a:t>author’s narrative focus and thematic behaviour</a:t>
-            </a:r>
-            <a:r>
-              <a:rPr lang="en-IL" dirty="0"/>
-              <a:t>.</a:t>
-            </a:r>
-          </a:p>
-        </p:txBody>
-      </p:sp>
-    </p:spTree>
-    <p:extLst>
-      <p:ext uri="{BB962C8B-B14F-4D97-AF65-F5344CB8AC3E}">
-        <p14:creationId xmlns:p14="http://schemas.microsoft.com/office/powerpoint/2010/main" val="2192234439"/>
-      </p:ext>
-    </p:extLst>
-  </p:cSld>
-  <p:clrMapOvr>
-    <a:masterClrMapping/>
-  </p:clrMapOvr>
-</p:sld>
-</file>
-
-<file path=ppt/slides/slide12.xml><?xml version="1.0" encoding="utf-8"?>
-<p:sld xmlns:a="http://schemas.openxmlformats.org/drawingml/2006/main" xmlns:r="http://schemas.openxmlformats.org/officeDocument/2006/relationships" xmlns:p="http://schemas.openxmlformats.org/presentationml/2006/main">
-  <p:cSld>
-    <p:spTree>
-      <p:nvGrpSpPr>
-        <p:cNvPr id="1" name="">
-          <a:extLst>
-            <a:ext uri="{FF2B5EF4-FFF2-40B4-BE49-F238E27FC236}">
               <a16:creationId xmlns:a16="http://schemas.microsoft.com/office/drawing/2014/main" id="{7F81954D-5A4C-0857-EC07-B5A26F069B56}"/>
             </a:ext>
           </a:extLst>
@@ -11819,6 +11569,14 @@
           <a:bodyPr/>
           <a:lstStyle/>
           <a:p>
+            <a:r>
+              <a:rPr lang="en-IL" dirty="0"/>
+              <a:t>Topic-Based Indicators</a:t>
+            </a:r>
+            <a:r>
+              <a:rPr lang="en-GB" dirty="0"/>
+              <a:t> - </a:t>
+            </a:r>
             <a:r>
               <a:rPr lang="en-US" dirty="0"/>
               <a:t>TF-IDF</a:t>
@@ -11973,7 +11731,7 @@
           <a:p>
             <a:fld id="{E6AB8EDD-9EF2-4633-A1C2-4D908C1019B4}" type="slidenum">
               <a:rPr lang="he-IL" smtClean="0"/>
-              <a:t>12</a:t>
+              <a:t>11</a:t>
             </a:fld>
             <a:endParaRPr lang="he-IL"/>
           </a:p>
@@ -12108,6 +11866,272 @@
     <p:extLst>
       <p:ext uri="{BB962C8B-B14F-4D97-AF65-F5344CB8AC3E}">
         <p14:creationId xmlns:p14="http://schemas.microsoft.com/office/powerpoint/2010/main" val="2163896998"/>
+      </p:ext>
+    </p:extLst>
+  </p:cSld>
+  <p:clrMapOvr>
+    <a:masterClrMapping/>
+  </p:clrMapOvr>
+</p:sld>
+</file>
+
+<file path=ppt/slides/slide12.xml><?xml version="1.0" encoding="utf-8"?>
+<p:sld xmlns:a="http://schemas.openxmlformats.org/drawingml/2006/main" xmlns:r="http://schemas.openxmlformats.org/officeDocument/2006/relationships" xmlns:p="http://schemas.openxmlformats.org/presentationml/2006/main">
+  <p:cSld>
+    <p:spTree>
+      <p:nvGrpSpPr>
+        <p:cNvPr id="1" name="">
+          <a:extLst>
+            <a:ext uri="{FF2B5EF4-FFF2-40B4-BE49-F238E27FC236}">
+              <a16:creationId xmlns:a16="http://schemas.microsoft.com/office/drawing/2014/main" id="{152F7BDE-8AB5-2809-CC36-E39791D3C350}"/>
+            </a:ext>
+          </a:extLst>
+        </p:cNvPr>
+        <p:cNvGrpSpPr/>
+        <p:nvPr/>
+      </p:nvGrpSpPr>
+      <p:grpSpPr>
+        <a:xfrm>
+          <a:off x="0" y="0"/>
+          <a:ext cx="0" cy="0"/>
+          <a:chOff x="0" y="0"/>
+          <a:chExt cx="0" cy="0"/>
+        </a:xfrm>
+      </p:grpSpPr>
+      <p:sp>
+        <p:nvSpPr>
+          <p:cNvPr id="2" name="Title 1">
+            <a:extLst>
+              <a:ext uri="{FF2B5EF4-FFF2-40B4-BE49-F238E27FC236}">
+                <a16:creationId xmlns:a16="http://schemas.microsoft.com/office/drawing/2014/main" id="{4636ED3E-8C9D-906E-B977-CB4C09EF76B0}"/>
+              </a:ext>
+            </a:extLst>
+          </p:cNvPr>
+          <p:cNvSpPr>
+            <a:spLocks noGrp="1"/>
+          </p:cNvSpPr>
+          <p:nvPr>
+            <p:ph type="title"/>
+          </p:nvPr>
+        </p:nvSpPr>
+        <p:spPr/>
+        <p:txBody>
+          <a:bodyPr/>
+          <a:lstStyle/>
+          <a:p>
+            <a:r>
+              <a:rPr lang="en-IL" dirty="0"/>
+              <a:t>Topic-Based Indicators</a:t>
+            </a:r>
+            <a:endParaRPr lang="en-US" dirty="0"/>
+          </a:p>
+        </p:txBody>
+      </p:sp>
+      <p:sp>
+        <p:nvSpPr>
+          <p:cNvPr id="4" name="Slide Number Placeholder 3">
+            <a:extLst>
+              <a:ext uri="{FF2B5EF4-FFF2-40B4-BE49-F238E27FC236}">
+                <a16:creationId xmlns:a16="http://schemas.microsoft.com/office/drawing/2014/main" id="{C4EEED24-25E6-99A7-BF59-44F2CC4DDB3E}"/>
+              </a:ext>
+            </a:extLst>
+          </p:cNvPr>
+          <p:cNvSpPr>
+            <a:spLocks noGrp="1"/>
+          </p:cNvSpPr>
+          <p:nvPr>
+            <p:ph type="sldNum" sz="quarter" idx="12"/>
+          </p:nvPr>
+        </p:nvSpPr>
+        <p:spPr/>
+        <p:txBody>
+          <a:bodyPr/>
+          <a:lstStyle/>
+          <a:p>
+            <a:fld id="{E6AB8EDD-9EF2-4633-A1C2-4D908C1019B4}" type="slidenum">
+              <a:rPr lang="he-IL" smtClean="0"/>
+              <a:t>12</a:t>
+            </a:fld>
+            <a:endParaRPr lang="he-IL"/>
+          </a:p>
+        </p:txBody>
+      </p:sp>
+      <p:sp>
+        <p:nvSpPr>
+          <p:cNvPr id="7" name="Content Placeholder 5">
+            <a:extLst>
+              <a:ext uri="{FF2B5EF4-FFF2-40B4-BE49-F238E27FC236}">
+                <a16:creationId xmlns:a16="http://schemas.microsoft.com/office/drawing/2014/main" id="{B5A312C1-6DEB-B571-F05F-5AB1221CED14}"/>
+              </a:ext>
+            </a:extLst>
+          </p:cNvPr>
+          <p:cNvSpPr>
+            <a:spLocks noGrp="1"/>
+          </p:cNvSpPr>
+          <p:nvPr>
+            <p:ph idx="1"/>
+          </p:nvPr>
+        </p:nvSpPr>
+        <p:spPr>
+          <a:xfrm>
+            <a:off x="1243087" y="1825624"/>
+            <a:ext cx="10582656" cy="4546601"/>
+          </a:xfrm>
+        </p:spPr>
+        <p:txBody>
+          <a:bodyPr>
+            <a:normAutofit fontScale="92500" lnSpcReduction="10000"/>
+          </a:bodyPr>
+          <a:lstStyle/>
+          <a:p>
+            <a:r>
+              <a:rPr lang="en-IL" dirty="0"/>
+              <a:t>Calculated from each </a:t>
+            </a:r>
+            <a:r>
+              <a:rPr lang="en-IL" b="1" dirty="0"/>
+              <a:t>author’s posts and hashtags</a:t>
+            </a:r>
+            <a:r>
+              <a:rPr lang="en-IL" dirty="0"/>
+              <a:t> to capture their thematic activity.</a:t>
+            </a:r>
+          </a:p>
+          <a:p>
+            <a:r>
+              <a:rPr lang="en-IL" dirty="0"/>
+              <a:t>Activity-Based Indicators</a:t>
+            </a:r>
+          </a:p>
+          <a:p>
+            <a:pPr lvl="1"/>
+            <a:r>
+              <a:rPr lang="en-IL" sz="2400" b="1" dirty="0"/>
+              <a:t>Posting Dominance </a:t>
+            </a:r>
+            <a:r>
+              <a:rPr lang="en-US" sz="2400" dirty="0"/>
+              <a:t>-</a:t>
+            </a:r>
+            <a:r>
+              <a:rPr lang="en-IL" sz="2400" dirty="0"/>
+              <a:t> proportion of an author’s posts assigned to their most frequent topic. </a:t>
+            </a:r>
+          </a:p>
+          <a:p>
+            <a:pPr lvl="1"/>
+            <a:r>
+              <a:rPr lang="en-IL" sz="2400" b="1" dirty="0"/>
+              <a:t>Top Topic</a:t>
+            </a:r>
+            <a:r>
+              <a:rPr lang="en-IL" sz="2400" dirty="0"/>
+              <a:t> </a:t>
+            </a:r>
+            <a:r>
+              <a:rPr lang="en-US" sz="2400" dirty="0"/>
+              <a:t>-</a:t>
+            </a:r>
+            <a:r>
+              <a:rPr lang="en-IL" sz="2400" dirty="0"/>
+              <a:t> the author’s dominant topic. </a:t>
+            </a:r>
+          </a:p>
+          <a:p>
+            <a:r>
+              <a:rPr lang="en-IL" dirty="0"/>
+              <a:t>TF</a:t>
+            </a:r>
+            <a:r>
+              <a:rPr lang="en-US" dirty="0"/>
+              <a:t>-</a:t>
+            </a:r>
+            <a:r>
+              <a:rPr lang="en-IL" dirty="0"/>
+              <a:t>IDF-Based Indicators</a:t>
+            </a:r>
+            <a:r>
+              <a:rPr lang="en-US" dirty="0"/>
+              <a:t> </a:t>
+            </a:r>
+          </a:p>
+          <a:p>
+            <a:pPr lvl="1"/>
+            <a:r>
+              <a:rPr lang="en-IL" b="1" dirty="0"/>
+              <a:t>Key Score (Topic)</a:t>
+            </a:r>
+            <a:r>
+              <a:rPr lang="en-IL" dirty="0"/>
+              <a:t> </a:t>
+            </a:r>
+            <a:r>
+              <a:rPr lang="en-US" dirty="0"/>
+              <a:t>-</a:t>
+            </a:r>
+            <a:r>
+              <a:rPr lang="en-IL" dirty="0"/>
+              <a:t> author’s relevance to a specific topic, calculated by aggregating the TF</a:t>
+            </a:r>
+            <a:r>
+              <a:rPr lang="en-US" dirty="0"/>
+              <a:t>-</a:t>
+            </a:r>
+            <a:r>
+              <a:rPr lang="en-IL" dirty="0"/>
+              <a:t>IDF scores of the entities used by the author in that topic, with a penalty for activity across multiple topics. </a:t>
+            </a:r>
+          </a:p>
+          <a:p>
+            <a:pPr lvl="1"/>
+            <a:r>
+              <a:rPr lang="en-IL" sz="2400" b="1" dirty="0"/>
+              <a:t>Key Score Sum </a:t>
+            </a:r>
+            <a:r>
+              <a:rPr lang="en-US" sz="2400" dirty="0"/>
+              <a:t>-</a:t>
+            </a:r>
+            <a:r>
+              <a:rPr lang="en-IL" sz="2400" dirty="0"/>
+              <a:t> sum of the author’s key scores across all topics. </a:t>
+            </a:r>
+          </a:p>
+          <a:p>
+            <a:pPr lvl="1"/>
+            <a:r>
+              <a:rPr lang="en-IL" sz="2400" b="1" dirty="0"/>
+              <a:t>Key Score Dominance </a:t>
+            </a:r>
+            <a:r>
+              <a:rPr lang="en-US" sz="2400" dirty="0"/>
+              <a:t>-</a:t>
+            </a:r>
+            <a:r>
+              <a:rPr lang="en-IL" sz="2400" dirty="0"/>
+              <a:t> proportion of the total key score concentrated in the author’s strongest topic.</a:t>
+            </a:r>
+          </a:p>
+          <a:p>
+            <a:r>
+              <a:rPr lang="en-IL" dirty="0"/>
+              <a:t>Together, these indicators capture the </a:t>
+            </a:r>
+            <a:r>
+              <a:rPr lang="en-IL" b="1" dirty="0"/>
+              <a:t>author’s narrative focus and thematic behaviour</a:t>
+            </a:r>
+            <a:r>
+              <a:rPr lang="en-IL" dirty="0"/>
+              <a:t>.</a:t>
+            </a:r>
+          </a:p>
+        </p:txBody>
+      </p:sp>
+    </p:spTree>
+    <p:extLst>
+      <p:ext uri="{BB962C8B-B14F-4D97-AF65-F5344CB8AC3E}">
+        <p14:creationId xmlns:p14="http://schemas.microsoft.com/office/powerpoint/2010/main" val="2192234439"/>
       </p:ext>
     </p:extLst>
   </p:cSld>
@@ -12171,9 +12195,10 @@
               <a:t>Group </a:t>
             </a:r>
             <a:r>
-              <a:rPr lang="en-IL" dirty="0"/>
-              <a:t>analysis</a:t>
-            </a:r>
+              <a:rPr lang="en-GB" dirty="0" err="1"/>
+              <a:t>Analisys</a:t>
+            </a:r>
+            <a:endParaRPr lang="en-IL" dirty="0"/>
           </a:p>
         </p:txBody>
       </p:sp>
@@ -12245,541 +12270,6 @@
 </file>
 
 <file path=ppt/slides/slide14.xml><?xml version="1.0" encoding="utf-8"?>
-<p:sld xmlns:a="http://schemas.openxmlformats.org/drawingml/2006/main" xmlns:r="http://schemas.openxmlformats.org/officeDocument/2006/relationships" xmlns:p="http://schemas.openxmlformats.org/presentationml/2006/main">
-  <p:cSld>
-    <p:spTree>
-      <p:nvGrpSpPr>
-        <p:cNvPr id="1" name="">
-          <a:extLst>
-            <a:ext uri="{FF2B5EF4-FFF2-40B4-BE49-F238E27FC236}">
-              <a16:creationId xmlns:a16="http://schemas.microsoft.com/office/drawing/2014/main" id="{6120DA63-958D-B3CC-0304-27F08C2C0397}"/>
-            </a:ext>
-          </a:extLst>
-        </p:cNvPr>
-        <p:cNvGrpSpPr/>
-        <p:nvPr/>
-      </p:nvGrpSpPr>
-      <p:grpSpPr>
-        <a:xfrm>
-          <a:off x="0" y="0"/>
-          <a:ext cx="0" cy="0"/>
-          <a:chOff x="0" y="0"/>
-          <a:chExt cx="0" cy="0"/>
-        </a:xfrm>
-      </p:grpSpPr>
-      <p:sp>
-        <p:nvSpPr>
-          <p:cNvPr id="2" name="Title 1">
-            <a:extLst>
-              <a:ext uri="{FF2B5EF4-FFF2-40B4-BE49-F238E27FC236}">
-                <a16:creationId xmlns:a16="http://schemas.microsoft.com/office/drawing/2014/main" id="{561F98E7-B718-85B7-ECA7-94DCCDA29B93}"/>
-              </a:ext>
-            </a:extLst>
-          </p:cNvPr>
-          <p:cNvSpPr>
-            <a:spLocks noGrp="1"/>
-          </p:cNvSpPr>
-          <p:nvPr>
-            <p:ph type="title"/>
-          </p:nvPr>
-        </p:nvSpPr>
-        <p:spPr/>
-        <p:txBody>
-          <a:bodyPr/>
-          <a:lstStyle/>
-          <a:p>
-            <a:r>
-              <a:rPr lang="en-US" dirty="0"/>
-              <a:t>Overview</a:t>
-            </a:r>
-            <a:endParaRPr lang="en-IL" dirty="0"/>
-          </a:p>
-        </p:txBody>
-      </p:sp>
-      <p:sp>
-        <p:nvSpPr>
-          <p:cNvPr id="3" name="Content Placeholder 2">
-            <a:extLst>
-              <a:ext uri="{FF2B5EF4-FFF2-40B4-BE49-F238E27FC236}">
-                <a16:creationId xmlns:a16="http://schemas.microsoft.com/office/drawing/2014/main" id="{85363424-899C-2A1D-4421-3E966B76389B}"/>
-              </a:ext>
-            </a:extLst>
-          </p:cNvPr>
-          <p:cNvSpPr>
-            <a:spLocks noGrp="1"/>
-          </p:cNvSpPr>
-          <p:nvPr>
-            <p:ph idx="1"/>
-          </p:nvPr>
-        </p:nvSpPr>
-        <p:spPr>
-          <a:xfrm>
-            <a:off x="1243087" y="1825625"/>
-            <a:ext cx="10582656" cy="4769728"/>
-          </a:xfrm>
-        </p:spPr>
-        <p:txBody>
-          <a:bodyPr>
-            <a:normAutofit/>
-          </a:bodyPr>
-          <a:lstStyle/>
-          <a:p>
-            <a:pPr lvl="0"/>
-            <a:r>
-              <a:rPr lang="en-IL" sz="3200" dirty="0"/>
-              <a:t>At the </a:t>
-            </a:r>
-            <a:r>
-              <a:rPr lang="en-IL" sz="3200" b="1" dirty="0"/>
-              <a:t>group level</a:t>
-            </a:r>
-            <a:r>
-              <a:rPr lang="en-IL" sz="3200" dirty="0"/>
-              <a:t>, we can reveal </a:t>
-            </a:r>
-            <a:r>
-              <a:rPr lang="en-IL" sz="3200" b="1" dirty="0"/>
-              <a:t>shared narratives and thematic patterns</a:t>
-            </a:r>
-            <a:r>
-              <a:rPr lang="en-IL" sz="3200" dirty="0"/>
-              <a:t> that may not be visible when analysing individual accounts. </a:t>
-            </a:r>
-          </a:p>
-          <a:p>
-            <a:pPr lvl="0"/>
-            <a:r>
-              <a:rPr lang="en-IL" sz="3200" b="1" dirty="0"/>
-              <a:t>Goal:</a:t>
-            </a:r>
-            <a:r>
-              <a:rPr lang="en-IL" sz="3200" dirty="0"/>
-              <a:t> Move from </a:t>
-            </a:r>
-            <a:r>
-              <a:rPr lang="en-IL" sz="3200" i="1" dirty="0"/>
-              <a:t>“Who participates in an IO?”</a:t>
-            </a:r>
-            <a:r>
-              <a:rPr lang="en-IL" sz="3200" dirty="0"/>
-              <a:t> to </a:t>
-            </a:r>
-            <a:r>
-              <a:rPr lang="en-IL" sz="3200" i="1" dirty="0"/>
-              <a:t>“How do coordinated groups operate, and what narratives characterize their activity?”</a:t>
-            </a:r>
-            <a:endParaRPr lang="en-IL" sz="3200" dirty="0"/>
-          </a:p>
-          <a:p>
-            <a:pPr marL="457200" lvl="1" indent="0">
-              <a:buNone/>
-            </a:pPr>
-            <a:endParaRPr lang="en-US" sz="3200" dirty="0"/>
-          </a:p>
-        </p:txBody>
-      </p:sp>
-      <p:sp>
-        <p:nvSpPr>
-          <p:cNvPr id="4" name="Slide Number Placeholder 3">
-            <a:extLst>
-              <a:ext uri="{FF2B5EF4-FFF2-40B4-BE49-F238E27FC236}">
-                <a16:creationId xmlns:a16="http://schemas.microsoft.com/office/drawing/2014/main" id="{83AF40F2-EA50-BEC5-D38F-8F6DD4350E11}"/>
-              </a:ext>
-            </a:extLst>
-          </p:cNvPr>
-          <p:cNvSpPr>
-            <a:spLocks noGrp="1"/>
-          </p:cNvSpPr>
-          <p:nvPr>
-            <p:ph type="sldNum" sz="quarter" idx="12"/>
-          </p:nvPr>
-        </p:nvSpPr>
-        <p:spPr/>
-        <p:txBody>
-          <a:bodyPr/>
-          <a:lstStyle/>
-          <a:p>
-            <a:fld id="{E6AB8EDD-9EF2-4633-A1C2-4D908C1019B4}" type="slidenum">
-              <a:rPr lang="he-IL" smtClean="0"/>
-              <a:t>14</a:t>
-            </a:fld>
-            <a:endParaRPr lang="he-IL"/>
-          </a:p>
-        </p:txBody>
-      </p:sp>
-      <p:pic>
-        <p:nvPicPr>
-          <p:cNvPr id="6" name="Picture 5">
-            <a:extLst>
-              <a:ext uri="{FF2B5EF4-FFF2-40B4-BE49-F238E27FC236}">
-                <a16:creationId xmlns:a16="http://schemas.microsoft.com/office/drawing/2014/main" id="{62027892-7F23-7560-E4A0-026837C0C856}"/>
-              </a:ext>
-            </a:extLst>
-          </p:cNvPr>
-          <p:cNvPicPr>
-            <a:picLocks noChangeAspect="1"/>
-          </p:cNvPicPr>
-          <p:nvPr/>
-        </p:nvPicPr>
-        <p:blipFill>
-          <a:blip r:embed="rId2"/>
-          <a:srcRect t="30198" b="12173"/>
-          <a:stretch>
-            <a:fillRect/>
-          </a:stretch>
-        </p:blipFill>
-        <p:spPr>
-          <a:xfrm>
-            <a:off x="2492400" y="5117509"/>
-            <a:ext cx="5987999" cy="1477844"/>
-          </a:xfrm>
-          <a:prstGeom prst="rect">
-            <a:avLst/>
-          </a:prstGeom>
-        </p:spPr>
-      </p:pic>
-    </p:spTree>
-    <p:extLst>
-      <p:ext uri="{BB962C8B-B14F-4D97-AF65-F5344CB8AC3E}">
-        <p14:creationId xmlns:p14="http://schemas.microsoft.com/office/powerpoint/2010/main" val="3803852761"/>
-      </p:ext>
-    </p:extLst>
-  </p:cSld>
-  <p:clrMapOvr>
-    <a:masterClrMapping/>
-  </p:clrMapOvr>
-</p:sld>
-</file>
-
-<file path=ppt/slides/slide15.xml><?xml version="1.0" encoding="utf-8"?>
-<p:sld xmlns:a="http://schemas.openxmlformats.org/drawingml/2006/main" xmlns:r="http://schemas.openxmlformats.org/officeDocument/2006/relationships" xmlns:p="http://schemas.openxmlformats.org/presentationml/2006/main">
-  <p:cSld>
-    <p:spTree>
-      <p:nvGrpSpPr>
-        <p:cNvPr id="1" name="">
-          <a:extLst>
-            <a:ext uri="{FF2B5EF4-FFF2-40B4-BE49-F238E27FC236}">
-              <a16:creationId xmlns:a16="http://schemas.microsoft.com/office/drawing/2014/main" id="{DE3DEE1B-0DBB-0BBE-85D3-FA360987F05B}"/>
-            </a:ext>
-          </a:extLst>
-        </p:cNvPr>
-        <p:cNvGrpSpPr/>
-        <p:nvPr/>
-      </p:nvGrpSpPr>
-      <p:grpSpPr>
-        <a:xfrm>
-          <a:off x="0" y="0"/>
-          <a:ext cx="0" cy="0"/>
-          <a:chOff x="0" y="0"/>
-          <a:chExt cx="0" cy="0"/>
-        </a:xfrm>
-      </p:grpSpPr>
-      <p:sp>
-        <p:nvSpPr>
-          <p:cNvPr id="2" name="Title 1">
-            <a:extLst>
-              <a:ext uri="{FF2B5EF4-FFF2-40B4-BE49-F238E27FC236}">
-                <a16:creationId xmlns:a16="http://schemas.microsoft.com/office/drawing/2014/main" id="{14BF77DC-4A73-3FF9-1A1F-BAD9FB219872}"/>
-              </a:ext>
-            </a:extLst>
-          </p:cNvPr>
-          <p:cNvSpPr>
-            <a:spLocks noGrp="1"/>
-          </p:cNvSpPr>
-          <p:nvPr>
-            <p:ph type="title"/>
-          </p:nvPr>
-        </p:nvSpPr>
-        <p:spPr/>
-        <p:txBody>
-          <a:bodyPr/>
-          <a:lstStyle/>
-          <a:p>
-            <a:r>
-              <a:rPr lang="en-US" dirty="0"/>
-              <a:t>Overview</a:t>
-            </a:r>
-            <a:endParaRPr lang="en-IL" dirty="0"/>
-          </a:p>
-        </p:txBody>
-      </p:sp>
-      <p:sp>
-        <p:nvSpPr>
-          <p:cNvPr id="3" name="Content Placeholder 2">
-            <a:extLst>
-              <a:ext uri="{FF2B5EF4-FFF2-40B4-BE49-F238E27FC236}">
-                <a16:creationId xmlns:a16="http://schemas.microsoft.com/office/drawing/2014/main" id="{0E6DD76D-E5BF-D922-7C5D-702EAD478930}"/>
-              </a:ext>
-            </a:extLst>
-          </p:cNvPr>
-          <p:cNvSpPr>
-            <a:spLocks noGrp="1"/>
-          </p:cNvSpPr>
-          <p:nvPr>
-            <p:ph idx="1"/>
-          </p:nvPr>
-        </p:nvSpPr>
-        <p:spPr>
-          <a:xfrm>
-            <a:off x="1243087" y="1825625"/>
-            <a:ext cx="10582656" cy="4769728"/>
-          </a:xfrm>
-        </p:spPr>
-        <p:txBody>
-          <a:bodyPr>
-            <a:normAutofit fontScale="85000" lnSpcReduction="10000"/>
-          </a:bodyPr>
-          <a:lstStyle/>
-          <a:p>
-            <a:r>
-              <a:rPr lang="en-IL" sz="3200" dirty="0"/>
-              <a:t>We </a:t>
-            </a:r>
-            <a:r>
-              <a:rPr lang="en-US" sz="3200" dirty="0"/>
-              <a:t>define</a:t>
-            </a:r>
-            <a:r>
-              <a:rPr lang="en-IL" sz="3200" dirty="0"/>
-              <a:t> several groups:</a:t>
-            </a:r>
-          </a:p>
-          <a:p>
-            <a:pPr lvl="1"/>
-            <a:r>
-              <a:rPr lang="en-IL" sz="2800" b="1" dirty="0"/>
-              <a:t>Maximal k-Core</a:t>
-            </a:r>
-            <a:r>
-              <a:rPr lang="en-US" sz="2800" b="1" dirty="0"/>
-              <a:t> Connected</a:t>
-            </a:r>
-            <a:r>
-              <a:rPr lang="en-IL" sz="2800" b="1" dirty="0"/>
-              <a:t> Component</a:t>
-            </a:r>
-            <a:r>
-              <a:rPr lang="en-IL" sz="2800" dirty="0"/>
-              <a:t> </a:t>
-            </a:r>
-            <a:r>
-              <a:rPr lang="en-US" sz="2800" dirty="0"/>
-              <a:t>-</a:t>
-            </a:r>
-            <a:r>
-              <a:rPr lang="en-IL" sz="2800" dirty="0"/>
-              <a:t> accounts belonging to the same connected component within their maximal k-core. </a:t>
-            </a:r>
-          </a:p>
-          <a:p>
-            <a:pPr lvl="1"/>
-            <a:r>
-              <a:rPr lang="en-IL" sz="2800" b="1" dirty="0"/>
-              <a:t>Direct Neighbours</a:t>
-            </a:r>
-            <a:r>
-              <a:rPr lang="en-IL" sz="2800" dirty="0"/>
-              <a:t> </a:t>
-            </a:r>
-            <a:r>
-              <a:rPr lang="en-US" sz="2800" dirty="0"/>
-              <a:t>-</a:t>
-            </a:r>
-            <a:r>
-              <a:rPr lang="en-IL" sz="2800" dirty="0"/>
-              <a:t> accounts directly connected to the focal account. </a:t>
-            </a:r>
-          </a:p>
-          <a:p>
-            <a:pPr lvl="1"/>
-            <a:r>
-              <a:rPr lang="en-IL" sz="2800" b="1" dirty="0"/>
-              <a:t>Louvain Community</a:t>
-            </a:r>
-            <a:r>
-              <a:rPr lang="en-IL" sz="2800" dirty="0"/>
-              <a:t> </a:t>
-            </a:r>
-            <a:r>
-              <a:rPr lang="en-US" sz="2800" dirty="0"/>
-              <a:t>-</a:t>
-            </a:r>
-            <a:r>
-              <a:rPr lang="en-IL" sz="2800" dirty="0"/>
-              <a:t> accounts assigned to the same graph community. </a:t>
-            </a:r>
-          </a:p>
-          <a:p>
-            <a:pPr lvl="1"/>
-            <a:r>
-              <a:rPr lang="en-IL" sz="2800" b="1" dirty="0"/>
-              <a:t>Top Topic</a:t>
-            </a:r>
-            <a:r>
-              <a:rPr lang="en-IL" sz="2800" dirty="0"/>
-              <a:t> </a:t>
-            </a:r>
-            <a:r>
-              <a:rPr lang="en-US" sz="2800" dirty="0"/>
-              <a:t>-</a:t>
-            </a:r>
-            <a:r>
-              <a:rPr lang="en-IL" sz="2800" dirty="0"/>
-              <a:t> accounts sharing the same dominant topic. </a:t>
-            </a:r>
-          </a:p>
-          <a:p>
-            <a:pPr lvl="1"/>
-            <a:r>
-              <a:rPr lang="en-IL" sz="2800" b="1" dirty="0"/>
-              <a:t>RF-Predicted IO</a:t>
-            </a:r>
-            <a:r>
-              <a:rPr lang="en-IL" sz="2800" dirty="0"/>
-              <a:t> </a:t>
-            </a:r>
-            <a:r>
-              <a:rPr lang="en-US" sz="2800" dirty="0"/>
-              <a:t>-</a:t>
-            </a:r>
-            <a:r>
-              <a:rPr lang="en-IL" sz="2800" dirty="0"/>
-              <a:t> accounts classified as IO by Random Forest. </a:t>
-            </a:r>
-          </a:p>
-          <a:p>
-            <a:pPr lvl="1"/>
-            <a:r>
-              <a:rPr lang="en-IL" sz="2800" b="1" dirty="0" err="1"/>
-              <a:t>XGBoost</a:t>
-            </a:r>
-            <a:r>
-              <a:rPr lang="en-IL" sz="2800" b="1" dirty="0"/>
-              <a:t>-Predicted IO</a:t>
-            </a:r>
-            <a:r>
-              <a:rPr lang="en-IL" sz="2800" dirty="0"/>
-              <a:t> </a:t>
-            </a:r>
-            <a:r>
-              <a:rPr lang="en-US" sz="2800" dirty="0"/>
-              <a:t>-</a:t>
-            </a:r>
-            <a:r>
-              <a:rPr lang="en-IL" sz="2800" dirty="0"/>
-              <a:t> accounts classified as IO by </a:t>
-            </a:r>
-            <a:r>
-              <a:rPr lang="en-IL" sz="2800" dirty="0" err="1"/>
-              <a:t>XGBoost</a:t>
-            </a:r>
-            <a:r>
-              <a:rPr lang="en-IL" sz="2800" dirty="0"/>
-              <a:t>. </a:t>
-            </a:r>
-          </a:p>
-          <a:p>
-            <a:r>
-              <a:rPr lang="en-IL" sz="3200" dirty="0"/>
-              <a:t>We evaluated each group based on </a:t>
-            </a:r>
-            <a:r>
-              <a:rPr lang="en-IL" sz="3200" b="1" dirty="0"/>
-              <a:t>IO concentration</a:t>
-            </a:r>
-            <a:r>
-              <a:rPr lang="en-IL" sz="3200" dirty="0"/>
-              <a:t> (the proportion of authors </a:t>
-            </a:r>
-            <a:r>
-              <a:rPr lang="en-IL" sz="3200" dirty="0" err="1"/>
-              <a:t>labeled</a:t>
-            </a:r>
-            <a:r>
-              <a:rPr lang="en-IL" sz="3200" dirty="0"/>
-              <a:t> as IO) and </a:t>
-            </a:r>
-            <a:r>
-              <a:rPr lang="en-IL" sz="3200" b="1" dirty="0"/>
-              <a:t>topic alignment</a:t>
-            </a:r>
-            <a:r>
-              <a:rPr lang="en-IL" sz="3200" dirty="0"/>
-              <a:t> among the authors.</a:t>
-            </a:r>
-            <a:endParaRPr lang="en-US" sz="3200" dirty="0"/>
-          </a:p>
-          <a:p>
-            <a:r>
-              <a:rPr lang="en-US" sz="3200" dirty="0"/>
-              <a:t>K</a:t>
-            </a:r>
-            <a:r>
-              <a:rPr lang="en-IL" sz="3200" dirty="0"/>
-              <a:t>-Core </a:t>
-            </a:r>
-            <a:r>
-              <a:rPr lang="en-US" sz="3200" dirty="0"/>
-              <a:t>CC</a:t>
-            </a:r>
-            <a:r>
-              <a:rPr lang="en-IL" sz="3200" dirty="0"/>
-              <a:t> were selected because they showed strong performance and a good </a:t>
-            </a:r>
-            <a:r>
-              <a:rPr lang="en-US" sz="3200" dirty="0"/>
-              <a:t>trade-off</a:t>
-            </a:r>
-            <a:r>
-              <a:rPr lang="en-IL" sz="3200" dirty="0"/>
-              <a:t> between IO concentration and topic alignment.</a:t>
-            </a:r>
-          </a:p>
-        </p:txBody>
-      </p:sp>
-      <p:sp>
-        <p:nvSpPr>
-          <p:cNvPr id="4" name="Slide Number Placeholder 3">
-            <a:extLst>
-              <a:ext uri="{FF2B5EF4-FFF2-40B4-BE49-F238E27FC236}">
-                <a16:creationId xmlns:a16="http://schemas.microsoft.com/office/drawing/2014/main" id="{23EAE485-9A48-4F07-B3C1-3D692449FE5B}"/>
-              </a:ext>
-            </a:extLst>
-          </p:cNvPr>
-          <p:cNvSpPr>
-            <a:spLocks noGrp="1"/>
-          </p:cNvSpPr>
-          <p:nvPr>
-            <p:ph type="sldNum" sz="quarter" idx="12"/>
-          </p:nvPr>
-        </p:nvSpPr>
-        <p:spPr/>
-        <p:txBody>
-          <a:bodyPr/>
-          <a:lstStyle/>
-          <a:p>
-            <a:fld id="{E6AB8EDD-9EF2-4633-A1C2-4D908C1019B4}" type="slidenum">
-              <a:rPr lang="he-IL" smtClean="0"/>
-              <a:t>15</a:t>
-            </a:fld>
-            <a:endParaRPr lang="he-IL"/>
-          </a:p>
-        </p:txBody>
-      </p:sp>
-    </p:spTree>
-    <p:extLst>
-      <p:ext uri="{BB962C8B-B14F-4D97-AF65-F5344CB8AC3E}">
-        <p14:creationId xmlns:p14="http://schemas.microsoft.com/office/powerpoint/2010/main" val="1545440044"/>
-      </p:ext>
-    </p:extLst>
-  </p:cSld>
-  <p:clrMapOvr>
-    <a:masterClrMapping/>
-  </p:clrMapOvr>
-</p:sld>
-</file>
-
-<file path=ppt/slides/slide16.xml><?xml version="1.0" encoding="utf-8"?>
 <p:sld xmlns:a="http://schemas.openxmlformats.org/drawingml/2006/main" xmlns:r="http://schemas.openxmlformats.org/officeDocument/2006/relationships" xmlns:p="http://schemas.openxmlformats.org/presentationml/2006/main">
   <p:cSld>
     <p:spTree>
@@ -13037,7 +12527,7 @@
           <a:p>
             <a:fld id="{E6AB8EDD-9EF2-4633-A1C2-4D908C1019B4}" type="slidenum">
               <a:rPr lang="he-IL" smtClean="0"/>
-              <a:t>16</a:t>
+              <a:t>14</a:t>
             </a:fld>
             <a:endParaRPr lang="he-IL"/>
           </a:p>
@@ -13056,7 +12546,7 @@
 </p:sld>
 </file>
 
-<file path=ppt/slides/slide17.xml><?xml version="1.0" encoding="utf-8"?>
+<file path=ppt/slides/slide15.xml><?xml version="1.0" encoding="utf-8"?>
 <p:sld xmlns:a="http://schemas.openxmlformats.org/drawingml/2006/main" xmlns:r="http://schemas.openxmlformats.org/officeDocument/2006/relationships" xmlns:p="http://schemas.openxmlformats.org/presentationml/2006/main">
   <p:cSld>
     <p:spTree>
@@ -13138,7 +12628,7 @@
           <a:p>
             <a:fld id="{E6AB8EDD-9EF2-4633-A1C2-4D908C1019B4}" type="slidenum">
               <a:rPr lang="he-IL" smtClean="0"/>
-              <a:t>17</a:t>
+              <a:t>15</a:t>
             </a:fld>
             <a:endParaRPr lang="he-IL"/>
           </a:p>
@@ -14259,6 +13749,541 @@
 </p:sld>
 </file>
 
+<file path=ppt/slides/slide16.xml><?xml version="1.0" encoding="utf-8"?>
+<p:sld xmlns:a="http://schemas.openxmlformats.org/drawingml/2006/main" xmlns:r="http://schemas.openxmlformats.org/officeDocument/2006/relationships" xmlns:p="http://schemas.openxmlformats.org/presentationml/2006/main">
+  <p:cSld>
+    <p:spTree>
+      <p:nvGrpSpPr>
+        <p:cNvPr id="1" name="">
+          <a:extLst>
+            <a:ext uri="{FF2B5EF4-FFF2-40B4-BE49-F238E27FC236}">
+              <a16:creationId xmlns:a16="http://schemas.microsoft.com/office/drawing/2014/main" id="{6120DA63-958D-B3CC-0304-27F08C2C0397}"/>
+            </a:ext>
+          </a:extLst>
+        </p:cNvPr>
+        <p:cNvGrpSpPr/>
+        <p:nvPr/>
+      </p:nvGrpSpPr>
+      <p:grpSpPr>
+        <a:xfrm>
+          <a:off x="0" y="0"/>
+          <a:ext cx="0" cy="0"/>
+          <a:chOff x="0" y="0"/>
+          <a:chExt cx="0" cy="0"/>
+        </a:xfrm>
+      </p:grpSpPr>
+      <p:sp>
+        <p:nvSpPr>
+          <p:cNvPr id="2" name="Title 1">
+            <a:extLst>
+              <a:ext uri="{FF2B5EF4-FFF2-40B4-BE49-F238E27FC236}">
+                <a16:creationId xmlns:a16="http://schemas.microsoft.com/office/drawing/2014/main" id="{561F98E7-B718-85B7-ECA7-94DCCDA29B93}"/>
+              </a:ext>
+            </a:extLst>
+          </p:cNvPr>
+          <p:cNvSpPr>
+            <a:spLocks noGrp="1"/>
+          </p:cNvSpPr>
+          <p:nvPr>
+            <p:ph type="title"/>
+          </p:nvPr>
+        </p:nvSpPr>
+        <p:spPr/>
+        <p:txBody>
+          <a:bodyPr/>
+          <a:lstStyle/>
+          <a:p>
+            <a:r>
+              <a:rPr lang="en-US" dirty="0"/>
+              <a:t>Overview</a:t>
+            </a:r>
+            <a:endParaRPr lang="en-IL" dirty="0"/>
+          </a:p>
+        </p:txBody>
+      </p:sp>
+      <p:sp>
+        <p:nvSpPr>
+          <p:cNvPr id="3" name="Content Placeholder 2">
+            <a:extLst>
+              <a:ext uri="{FF2B5EF4-FFF2-40B4-BE49-F238E27FC236}">
+                <a16:creationId xmlns:a16="http://schemas.microsoft.com/office/drawing/2014/main" id="{85363424-899C-2A1D-4421-3E966B76389B}"/>
+              </a:ext>
+            </a:extLst>
+          </p:cNvPr>
+          <p:cNvSpPr>
+            <a:spLocks noGrp="1"/>
+          </p:cNvSpPr>
+          <p:nvPr>
+            <p:ph idx="1"/>
+          </p:nvPr>
+        </p:nvSpPr>
+        <p:spPr>
+          <a:xfrm>
+            <a:off x="1243087" y="1825625"/>
+            <a:ext cx="10582656" cy="4769728"/>
+          </a:xfrm>
+        </p:spPr>
+        <p:txBody>
+          <a:bodyPr>
+            <a:normAutofit/>
+          </a:bodyPr>
+          <a:lstStyle/>
+          <a:p>
+            <a:pPr lvl="0"/>
+            <a:r>
+              <a:rPr lang="en-IL" sz="3200" dirty="0"/>
+              <a:t>At the </a:t>
+            </a:r>
+            <a:r>
+              <a:rPr lang="en-IL" sz="3200" b="1" dirty="0"/>
+              <a:t>group level</a:t>
+            </a:r>
+            <a:r>
+              <a:rPr lang="en-IL" sz="3200" dirty="0"/>
+              <a:t>, we can reveal </a:t>
+            </a:r>
+            <a:r>
+              <a:rPr lang="en-IL" sz="3200" b="1" dirty="0"/>
+              <a:t>shared narratives and thematic patterns</a:t>
+            </a:r>
+            <a:r>
+              <a:rPr lang="en-IL" sz="3200" dirty="0"/>
+              <a:t> that may not be visible when analysing individual accounts. </a:t>
+            </a:r>
+          </a:p>
+          <a:p>
+            <a:pPr lvl="0"/>
+            <a:r>
+              <a:rPr lang="en-IL" sz="3200" b="1" dirty="0"/>
+              <a:t>Goal:</a:t>
+            </a:r>
+            <a:r>
+              <a:rPr lang="en-IL" sz="3200" dirty="0"/>
+              <a:t> Move from </a:t>
+            </a:r>
+            <a:r>
+              <a:rPr lang="en-IL" sz="3200" i="1" dirty="0"/>
+              <a:t>“Who participates in an IO?”</a:t>
+            </a:r>
+            <a:r>
+              <a:rPr lang="en-IL" sz="3200" dirty="0"/>
+              <a:t> to </a:t>
+            </a:r>
+            <a:r>
+              <a:rPr lang="en-IL" sz="3200" i="1" dirty="0"/>
+              <a:t>“How do coordinated groups operate, and what narratives characterize their activity?”</a:t>
+            </a:r>
+            <a:endParaRPr lang="en-IL" sz="3200" dirty="0"/>
+          </a:p>
+          <a:p>
+            <a:pPr marL="457200" lvl="1" indent="0">
+              <a:buNone/>
+            </a:pPr>
+            <a:endParaRPr lang="en-US" sz="3200" dirty="0"/>
+          </a:p>
+        </p:txBody>
+      </p:sp>
+      <p:sp>
+        <p:nvSpPr>
+          <p:cNvPr id="4" name="Slide Number Placeholder 3">
+            <a:extLst>
+              <a:ext uri="{FF2B5EF4-FFF2-40B4-BE49-F238E27FC236}">
+                <a16:creationId xmlns:a16="http://schemas.microsoft.com/office/drawing/2014/main" id="{83AF40F2-EA50-BEC5-D38F-8F6DD4350E11}"/>
+              </a:ext>
+            </a:extLst>
+          </p:cNvPr>
+          <p:cNvSpPr>
+            <a:spLocks noGrp="1"/>
+          </p:cNvSpPr>
+          <p:nvPr>
+            <p:ph type="sldNum" sz="quarter" idx="12"/>
+          </p:nvPr>
+        </p:nvSpPr>
+        <p:spPr/>
+        <p:txBody>
+          <a:bodyPr/>
+          <a:lstStyle/>
+          <a:p>
+            <a:fld id="{E6AB8EDD-9EF2-4633-A1C2-4D908C1019B4}" type="slidenum">
+              <a:rPr lang="he-IL" smtClean="0"/>
+              <a:t>16</a:t>
+            </a:fld>
+            <a:endParaRPr lang="he-IL"/>
+          </a:p>
+        </p:txBody>
+      </p:sp>
+      <p:pic>
+        <p:nvPicPr>
+          <p:cNvPr id="6" name="Picture 5">
+            <a:extLst>
+              <a:ext uri="{FF2B5EF4-FFF2-40B4-BE49-F238E27FC236}">
+                <a16:creationId xmlns:a16="http://schemas.microsoft.com/office/drawing/2014/main" id="{62027892-7F23-7560-E4A0-026837C0C856}"/>
+              </a:ext>
+            </a:extLst>
+          </p:cNvPr>
+          <p:cNvPicPr>
+            <a:picLocks noChangeAspect="1"/>
+          </p:cNvPicPr>
+          <p:nvPr/>
+        </p:nvPicPr>
+        <p:blipFill>
+          <a:blip r:embed="rId2"/>
+          <a:srcRect t="30198" b="12173"/>
+          <a:stretch>
+            <a:fillRect/>
+          </a:stretch>
+        </p:blipFill>
+        <p:spPr>
+          <a:xfrm>
+            <a:off x="2492400" y="5117509"/>
+            <a:ext cx="5987999" cy="1477844"/>
+          </a:xfrm>
+          <a:prstGeom prst="rect">
+            <a:avLst/>
+          </a:prstGeom>
+        </p:spPr>
+      </p:pic>
+    </p:spTree>
+    <p:extLst>
+      <p:ext uri="{BB962C8B-B14F-4D97-AF65-F5344CB8AC3E}">
+        <p14:creationId xmlns:p14="http://schemas.microsoft.com/office/powerpoint/2010/main" val="3803852761"/>
+      </p:ext>
+    </p:extLst>
+  </p:cSld>
+  <p:clrMapOvr>
+    <a:masterClrMapping/>
+  </p:clrMapOvr>
+</p:sld>
+</file>
+
+<file path=ppt/slides/slide17.xml><?xml version="1.0" encoding="utf-8"?>
+<p:sld xmlns:a="http://schemas.openxmlformats.org/drawingml/2006/main" xmlns:r="http://schemas.openxmlformats.org/officeDocument/2006/relationships" xmlns:p="http://schemas.openxmlformats.org/presentationml/2006/main">
+  <p:cSld>
+    <p:spTree>
+      <p:nvGrpSpPr>
+        <p:cNvPr id="1" name="">
+          <a:extLst>
+            <a:ext uri="{FF2B5EF4-FFF2-40B4-BE49-F238E27FC236}">
+              <a16:creationId xmlns:a16="http://schemas.microsoft.com/office/drawing/2014/main" id="{DE3DEE1B-0DBB-0BBE-85D3-FA360987F05B}"/>
+            </a:ext>
+          </a:extLst>
+        </p:cNvPr>
+        <p:cNvGrpSpPr/>
+        <p:nvPr/>
+      </p:nvGrpSpPr>
+      <p:grpSpPr>
+        <a:xfrm>
+          <a:off x="0" y="0"/>
+          <a:ext cx="0" cy="0"/>
+          <a:chOff x="0" y="0"/>
+          <a:chExt cx="0" cy="0"/>
+        </a:xfrm>
+      </p:grpSpPr>
+      <p:sp>
+        <p:nvSpPr>
+          <p:cNvPr id="2" name="Title 1">
+            <a:extLst>
+              <a:ext uri="{FF2B5EF4-FFF2-40B4-BE49-F238E27FC236}">
+                <a16:creationId xmlns:a16="http://schemas.microsoft.com/office/drawing/2014/main" id="{14BF77DC-4A73-3FF9-1A1F-BAD9FB219872}"/>
+              </a:ext>
+            </a:extLst>
+          </p:cNvPr>
+          <p:cNvSpPr>
+            <a:spLocks noGrp="1"/>
+          </p:cNvSpPr>
+          <p:nvPr>
+            <p:ph type="title"/>
+          </p:nvPr>
+        </p:nvSpPr>
+        <p:spPr/>
+        <p:txBody>
+          <a:bodyPr/>
+          <a:lstStyle/>
+          <a:p>
+            <a:r>
+              <a:rPr lang="en-US" dirty="0"/>
+              <a:t>Overview</a:t>
+            </a:r>
+            <a:endParaRPr lang="en-IL" dirty="0"/>
+          </a:p>
+        </p:txBody>
+      </p:sp>
+      <p:sp>
+        <p:nvSpPr>
+          <p:cNvPr id="3" name="Content Placeholder 2">
+            <a:extLst>
+              <a:ext uri="{FF2B5EF4-FFF2-40B4-BE49-F238E27FC236}">
+                <a16:creationId xmlns:a16="http://schemas.microsoft.com/office/drawing/2014/main" id="{0E6DD76D-E5BF-D922-7C5D-702EAD478930}"/>
+              </a:ext>
+            </a:extLst>
+          </p:cNvPr>
+          <p:cNvSpPr>
+            <a:spLocks noGrp="1"/>
+          </p:cNvSpPr>
+          <p:nvPr>
+            <p:ph idx="1"/>
+          </p:nvPr>
+        </p:nvSpPr>
+        <p:spPr>
+          <a:xfrm>
+            <a:off x="1243087" y="1825625"/>
+            <a:ext cx="10582656" cy="4769728"/>
+          </a:xfrm>
+        </p:spPr>
+        <p:txBody>
+          <a:bodyPr>
+            <a:normAutofit fontScale="85000" lnSpcReduction="10000"/>
+          </a:bodyPr>
+          <a:lstStyle/>
+          <a:p>
+            <a:r>
+              <a:rPr lang="en-IL" sz="3200" dirty="0"/>
+              <a:t>We </a:t>
+            </a:r>
+            <a:r>
+              <a:rPr lang="en-US" sz="3200" dirty="0"/>
+              <a:t>define</a:t>
+            </a:r>
+            <a:r>
+              <a:rPr lang="en-IL" sz="3200" dirty="0"/>
+              <a:t> several groups:</a:t>
+            </a:r>
+          </a:p>
+          <a:p>
+            <a:pPr lvl="1"/>
+            <a:r>
+              <a:rPr lang="en-IL" sz="2800" b="1" dirty="0"/>
+              <a:t>Maximal k-Core</a:t>
+            </a:r>
+            <a:r>
+              <a:rPr lang="en-US" sz="2800" b="1" dirty="0"/>
+              <a:t> Connected</a:t>
+            </a:r>
+            <a:r>
+              <a:rPr lang="en-IL" sz="2800" b="1" dirty="0"/>
+              <a:t> Component</a:t>
+            </a:r>
+            <a:r>
+              <a:rPr lang="en-IL" sz="2800" dirty="0"/>
+              <a:t> </a:t>
+            </a:r>
+            <a:r>
+              <a:rPr lang="en-US" sz="2800" dirty="0"/>
+              <a:t>-</a:t>
+            </a:r>
+            <a:r>
+              <a:rPr lang="en-IL" sz="2800" dirty="0"/>
+              <a:t> accounts belonging to the same connected component within their maximal k-core. </a:t>
+            </a:r>
+          </a:p>
+          <a:p>
+            <a:pPr lvl="1"/>
+            <a:r>
+              <a:rPr lang="en-IL" sz="2800" b="1" dirty="0"/>
+              <a:t>Direct Neighbours</a:t>
+            </a:r>
+            <a:r>
+              <a:rPr lang="en-IL" sz="2800" dirty="0"/>
+              <a:t> </a:t>
+            </a:r>
+            <a:r>
+              <a:rPr lang="en-US" sz="2800" dirty="0"/>
+              <a:t>-</a:t>
+            </a:r>
+            <a:r>
+              <a:rPr lang="en-IL" sz="2800" dirty="0"/>
+              <a:t> accounts directly connected to the focal account. </a:t>
+            </a:r>
+          </a:p>
+          <a:p>
+            <a:pPr lvl="1"/>
+            <a:r>
+              <a:rPr lang="en-IL" sz="2800" b="1" dirty="0"/>
+              <a:t>Louvain Community</a:t>
+            </a:r>
+            <a:r>
+              <a:rPr lang="en-IL" sz="2800" dirty="0"/>
+              <a:t> </a:t>
+            </a:r>
+            <a:r>
+              <a:rPr lang="en-US" sz="2800" dirty="0"/>
+              <a:t>-</a:t>
+            </a:r>
+            <a:r>
+              <a:rPr lang="en-IL" sz="2800" dirty="0"/>
+              <a:t> accounts assigned to the same graph community. </a:t>
+            </a:r>
+          </a:p>
+          <a:p>
+            <a:pPr lvl="1"/>
+            <a:r>
+              <a:rPr lang="en-IL" sz="2800" b="1" dirty="0"/>
+              <a:t>Top Topic</a:t>
+            </a:r>
+            <a:r>
+              <a:rPr lang="en-IL" sz="2800" dirty="0"/>
+              <a:t> </a:t>
+            </a:r>
+            <a:r>
+              <a:rPr lang="en-US" sz="2800" dirty="0"/>
+              <a:t>-</a:t>
+            </a:r>
+            <a:r>
+              <a:rPr lang="en-IL" sz="2800" dirty="0"/>
+              <a:t> accounts sharing the same dominant topic. </a:t>
+            </a:r>
+          </a:p>
+          <a:p>
+            <a:pPr lvl="1"/>
+            <a:r>
+              <a:rPr lang="en-IL" sz="2800" b="1" dirty="0"/>
+              <a:t>RF-Predicted IO</a:t>
+            </a:r>
+            <a:r>
+              <a:rPr lang="en-IL" sz="2800" dirty="0"/>
+              <a:t> </a:t>
+            </a:r>
+            <a:r>
+              <a:rPr lang="en-US" sz="2800" dirty="0"/>
+              <a:t>-</a:t>
+            </a:r>
+            <a:r>
+              <a:rPr lang="en-IL" sz="2800" dirty="0"/>
+              <a:t> accounts classified as IO by Random Forest. </a:t>
+            </a:r>
+          </a:p>
+          <a:p>
+            <a:pPr lvl="1"/>
+            <a:r>
+              <a:rPr lang="en-IL" sz="2800" b="1" dirty="0" err="1"/>
+              <a:t>XGBoost</a:t>
+            </a:r>
+            <a:r>
+              <a:rPr lang="en-IL" sz="2800" b="1" dirty="0"/>
+              <a:t>-Predicted IO</a:t>
+            </a:r>
+            <a:r>
+              <a:rPr lang="en-IL" sz="2800" dirty="0"/>
+              <a:t> </a:t>
+            </a:r>
+            <a:r>
+              <a:rPr lang="en-US" sz="2800" dirty="0"/>
+              <a:t>-</a:t>
+            </a:r>
+            <a:r>
+              <a:rPr lang="en-IL" sz="2800" dirty="0"/>
+              <a:t> accounts classified as IO by </a:t>
+            </a:r>
+            <a:r>
+              <a:rPr lang="en-IL" sz="2800" dirty="0" err="1"/>
+              <a:t>XGBoost</a:t>
+            </a:r>
+            <a:r>
+              <a:rPr lang="en-IL" sz="2800" dirty="0"/>
+              <a:t>. </a:t>
+            </a:r>
+          </a:p>
+          <a:p>
+            <a:r>
+              <a:rPr lang="en-IL" sz="3200" dirty="0"/>
+              <a:t>We evaluated each group based on </a:t>
+            </a:r>
+            <a:r>
+              <a:rPr lang="en-IL" sz="3200" b="1" dirty="0"/>
+              <a:t>IO concentration</a:t>
+            </a:r>
+            <a:r>
+              <a:rPr lang="en-IL" sz="3200" dirty="0"/>
+              <a:t> (the proportion of authors </a:t>
+            </a:r>
+            <a:r>
+              <a:rPr lang="en-IL" sz="3200" dirty="0" err="1"/>
+              <a:t>labeled</a:t>
+            </a:r>
+            <a:r>
+              <a:rPr lang="en-IL" sz="3200" dirty="0"/>
+              <a:t> as IO) and </a:t>
+            </a:r>
+            <a:r>
+              <a:rPr lang="en-IL" sz="3200" b="1" dirty="0"/>
+              <a:t>topic alignment</a:t>
+            </a:r>
+            <a:r>
+              <a:rPr lang="en-IL" sz="3200" dirty="0"/>
+              <a:t> among the authors.</a:t>
+            </a:r>
+            <a:endParaRPr lang="en-US" sz="3200" dirty="0"/>
+          </a:p>
+          <a:p>
+            <a:r>
+              <a:rPr lang="en-US" sz="3200" dirty="0"/>
+              <a:t>K</a:t>
+            </a:r>
+            <a:r>
+              <a:rPr lang="en-IL" sz="3200" dirty="0"/>
+              <a:t>-Core </a:t>
+            </a:r>
+            <a:r>
+              <a:rPr lang="en-US" sz="3200" dirty="0"/>
+              <a:t>CC</a:t>
+            </a:r>
+            <a:r>
+              <a:rPr lang="en-IL" sz="3200" dirty="0"/>
+              <a:t> were selected because they showed strong performance and a good </a:t>
+            </a:r>
+            <a:r>
+              <a:rPr lang="en-US" sz="3200" dirty="0"/>
+              <a:t>trade-off</a:t>
+            </a:r>
+            <a:r>
+              <a:rPr lang="en-IL" sz="3200" dirty="0"/>
+              <a:t> between IO concentration and topic alignment.</a:t>
+            </a:r>
+          </a:p>
+        </p:txBody>
+      </p:sp>
+      <p:sp>
+        <p:nvSpPr>
+          <p:cNvPr id="4" name="Slide Number Placeholder 3">
+            <a:extLst>
+              <a:ext uri="{FF2B5EF4-FFF2-40B4-BE49-F238E27FC236}">
+                <a16:creationId xmlns:a16="http://schemas.microsoft.com/office/drawing/2014/main" id="{23EAE485-9A48-4F07-B3C1-3D692449FE5B}"/>
+              </a:ext>
+            </a:extLst>
+          </p:cNvPr>
+          <p:cNvSpPr>
+            <a:spLocks noGrp="1"/>
+          </p:cNvSpPr>
+          <p:nvPr>
+            <p:ph type="sldNum" sz="quarter" idx="12"/>
+          </p:nvPr>
+        </p:nvSpPr>
+        <p:spPr/>
+        <p:txBody>
+          <a:bodyPr/>
+          <a:lstStyle/>
+          <a:p>
+            <a:fld id="{E6AB8EDD-9EF2-4633-A1C2-4D908C1019B4}" type="slidenum">
+              <a:rPr lang="he-IL" smtClean="0"/>
+              <a:t>17</a:t>
+            </a:fld>
+            <a:endParaRPr lang="he-IL"/>
+          </a:p>
+        </p:txBody>
+      </p:sp>
+    </p:spTree>
+    <p:extLst>
+      <p:ext uri="{BB962C8B-B14F-4D97-AF65-F5344CB8AC3E}">
+        <p14:creationId xmlns:p14="http://schemas.microsoft.com/office/powerpoint/2010/main" val="1545440044"/>
+      </p:ext>
+    </p:extLst>
+  </p:cSld>
+  <p:clrMapOvr>
+    <a:masterClrMapping/>
+  </p:clrMapOvr>
+</p:sld>
+</file>
+
 <file path=ppt/slides/slide18.xml><?xml version="1.0" encoding="utf-8"?>
 <p:sld xmlns:a="http://schemas.openxmlformats.org/drawingml/2006/main" xmlns:r="http://schemas.openxmlformats.org/officeDocument/2006/relationships" xmlns:p="http://schemas.openxmlformats.org/presentationml/2006/main">
   <p:cSld>
@@ -15108,7 +15133,7 @@
               <a:t>(</a:t>
             </a:r>
             <a:r>
-              <a:rPr lang="en-IL" sz="3600" b="1" dirty="0" err="1"/>
+              <a:rPr lang="en-IL" sz="3600" b="1" dirty="0"/>
               <a:t>Transductive</a:t>
             </a:r>
             <a:r>
@@ -16568,8 +16593,8 @@
         </p:blipFill>
         <p:spPr>
           <a:xfrm>
-            <a:off x="2024099" y="1414654"/>
-            <a:ext cx="8810552" cy="4824222"/>
+            <a:off x="1814288" y="1407397"/>
+            <a:ext cx="8918765" cy="4883474"/>
           </a:xfrm>
           <a:prstGeom prst="rect">
             <a:avLst/>
@@ -18589,16 +18614,25 @@
               </a:defRPr>
             </a:pPr>
             <a:r>
-              <a:rPr sz="4400" dirty="0">
-                <a:solidFill>
-                  <a:srgbClr val="009DBB"/>
-                </a:solidFill>
-                <a:latin typeface="+mj-lt"/>
-                <a:ea typeface="+mj-ea"/>
-                <a:cs typeface="+mj-cs"/>
+              <a:rPr lang="en-GB" sz="4400" dirty="0">
+                <a:latin typeface="Calibri Light (Headings)"/>
               </a:rPr>
-              <a:t>The Iran-1 Network</a:t>
-            </a:r>
+              <a:t>Group Analysis </a:t>
+            </a:r>
+            <a:r>
+              <a:rPr lang="en-US" sz="4400" dirty="0">
+                <a:latin typeface="Calibri Light (Headings)"/>
+              </a:rPr>
+              <a:t>Case Study - Iran 1</a:t>
+            </a:r>
+            <a:endParaRPr sz="4400" dirty="0">
+              <a:solidFill>
+                <a:srgbClr val="009DBB"/>
+              </a:solidFill>
+              <a:latin typeface="Calibri Light (Headings)"/>
+              <a:ea typeface="+mj-ea"/>
+              <a:cs typeface="+mj-cs"/>
+            </a:endParaRPr>
           </a:p>
         </p:txBody>
       </p:sp>
@@ -18900,7 +18934,7 @@
             </a:r>
             <a:r>
               <a:rPr lang="en-US" dirty="0"/>
-              <a:t>Case Study – Iran 1</a:t>
+              <a:t>Case Study - Iran 1</a:t>
             </a:r>
             <a:endParaRPr lang="en-IL" dirty="0"/>
           </a:p>
@@ -19083,7 +19117,7 @@
             </a:r>
             <a:r>
               <a:rPr lang="en-US" dirty="0"/>
-              <a:t>Case Study – Iran 1</a:t>
+              <a:t>Case Study - Iran 1</a:t>
             </a:r>
             <a:endParaRPr lang="en-IL" dirty="0"/>
           </a:p>
@@ -20232,11 +20266,11 @@
             </a:r>
             <a:r>
               <a:rPr lang="en-US" sz="4000" dirty="0"/>
-              <a:t>Group </a:t>
+              <a:t>group </a:t>
             </a:r>
             <a:r>
               <a:rPr lang="en-IL" sz="4000" dirty="0"/>
-              <a:t>analysis of the detected coordinated group (k-core), revealing the campaign’s agenda.</a:t>
+              <a:t>analysis revealing the campaign’s agenda.</a:t>
             </a:r>
           </a:p>
         </p:txBody>
@@ -20585,7 +20619,7 @@
             </a:r>
             <a:r>
               <a:rPr lang="en-US" sz="3200" dirty="0"/>
-              <a:t> (TF IDF is explained in the next slide)</a:t>
+              <a:t> </a:t>
             </a:r>
           </a:p>
           <a:p>
@@ -20626,10 +20660,6 @@
               <a:rPr lang="en-IL" sz="3200" dirty="0"/>
               <a:t> </a:t>
             </a:r>
-            <a:endParaRPr lang="en-US" sz="3200" dirty="0"/>
-          </a:p>
-          <a:p>
-            <a:pPr lvl="1"/>
             <a:endParaRPr lang="en-US" sz="3200" dirty="0"/>
           </a:p>
         </p:txBody>
@@ -20677,214 +20707,6 @@
 </file>
 
 <file path=ppt/slides/slide8.xml><?xml version="1.0" encoding="utf-8"?>
-<p:sld xmlns:a="http://schemas.openxmlformats.org/drawingml/2006/main" xmlns:r="http://schemas.openxmlformats.org/officeDocument/2006/relationships" xmlns:p="http://schemas.openxmlformats.org/presentationml/2006/main">
-  <p:cSld>
-    <p:spTree>
-      <p:nvGrpSpPr>
-        <p:cNvPr id="1" name="">
-          <a:extLst>
-            <a:ext uri="{FF2B5EF4-FFF2-40B4-BE49-F238E27FC236}">
-              <a16:creationId xmlns:a16="http://schemas.microsoft.com/office/drawing/2014/main" id="{8B90C904-6A27-8E88-FF68-740AA5CCE9F9}"/>
-            </a:ext>
-          </a:extLst>
-        </p:cNvPr>
-        <p:cNvGrpSpPr/>
-        <p:nvPr/>
-      </p:nvGrpSpPr>
-      <p:grpSpPr>
-        <a:xfrm>
-          <a:off x="0" y="0"/>
-          <a:ext cx="0" cy="0"/>
-          <a:chOff x="0" y="0"/>
-          <a:chExt cx="0" cy="0"/>
-        </a:xfrm>
-      </p:grpSpPr>
-      <p:sp>
-        <p:nvSpPr>
-          <p:cNvPr id="2" name="Title 1">
-            <a:extLst>
-              <a:ext uri="{FF2B5EF4-FFF2-40B4-BE49-F238E27FC236}">
-                <a16:creationId xmlns:a16="http://schemas.microsoft.com/office/drawing/2014/main" id="{3C2011DC-22C8-9C10-CE8B-B117FA4DA52A}"/>
-              </a:ext>
-            </a:extLst>
-          </p:cNvPr>
-          <p:cNvSpPr>
-            <a:spLocks noGrp="1"/>
-          </p:cNvSpPr>
-          <p:nvPr>
-            <p:ph type="title"/>
-          </p:nvPr>
-        </p:nvSpPr>
-        <p:spPr/>
-        <p:txBody>
-          <a:bodyPr/>
-          <a:lstStyle/>
-          <a:p>
-            <a:r>
-              <a:rPr lang="en-IL" dirty="0"/>
-              <a:t>Graph Indicators</a:t>
-            </a:r>
-            <a:r>
-              <a:rPr lang="en-US" dirty="0"/>
-              <a:t> Workflow</a:t>
-            </a:r>
-            <a:endParaRPr lang="en-IL" dirty="0"/>
-          </a:p>
-        </p:txBody>
-      </p:sp>
-      <p:graphicFrame>
-        <p:nvGraphicFramePr>
-          <p:cNvPr id="10" name="Content Placeholder 9">
-            <a:extLst>
-              <a:ext uri="{FF2B5EF4-FFF2-40B4-BE49-F238E27FC236}">
-                <a16:creationId xmlns:a16="http://schemas.microsoft.com/office/drawing/2014/main" id="{583CB65E-CDB4-6CBC-AA68-A7C75896264B}"/>
-              </a:ext>
-            </a:extLst>
-          </p:cNvPr>
-          <p:cNvGraphicFramePr>
-            <a:graphicFrameLocks noGrp="1"/>
-          </p:cNvGraphicFramePr>
-          <p:nvPr>
-            <p:ph idx="1"/>
-            <p:extLst>
-              <p:ext uri="{D42A27DB-BD31-4B8C-83A1-F6EECF244321}">
-                <p14:modId xmlns:p14="http://schemas.microsoft.com/office/powerpoint/2010/main" val="2725248438"/>
-              </p:ext>
-            </p:extLst>
-          </p:nvPr>
-        </p:nvGraphicFramePr>
-        <p:xfrm>
-          <a:off x="1243087" y="1575486"/>
-          <a:ext cx="7072620" cy="5130114"/>
-        </p:xfrm>
-        <a:graphic>
-          <a:graphicData uri="http://schemas.openxmlformats.org/drawingml/2006/diagram">
-            <dgm:relIds xmlns:dgm="http://schemas.openxmlformats.org/drawingml/2006/diagram" xmlns:r="http://schemas.openxmlformats.org/officeDocument/2006/relationships" r:dm="rId2" r:lo="rId3" r:qs="rId4" r:cs="rId5"/>
-          </a:graphicData>
-        </a:graphic>
-      </p:graphicFrame>
-      <p:sp>
-        <p:nvSpPr>
-          <p:cNvPr id="4" name="Slide Number Placeholder 3">
-            <a:extLst>
-              <a:ext uri="{FF2B5EF4-FFF2-40B4-BE49-F238E27FC236}">
-                <a16:creationId xmlns:a16="http://schemas.microsoft.com/office/drawing/2014/main" id="{347AFC2A-2F88-85E7-E925-FC99791579F9}"/>
-              </a:ext>
-            </a:extLst>
-          </p:cNvPr>
-          <p:cNvSpPr>
-            <a:spLocks noGrp="1"/>
-          </p:cNvSpPr>
-          <p:nvPr>
-            <p:ph type="sldNum" sz="quarter" idx="12"/>
-          </p:nvPr>
-        </p:nvSpPr>
-        <p:spPr/>
-        <p:txBody>
-          <a:bodyPr/>
-          <a:lstStyle/>
-          <a:p>
-            <a:fld id="{E6AB8EDD-9EF2-4633-A1C2-4D908C1019B4}" type="slidenum">
-              <a:rPr lang="he-IL" smtClean="0"/>
-              <a:t>8</a:t>
-            </a:fld>
-            <a:endParaRPr lang="he-IL"/>
-          </a:p>
-        </p:txBody>
-      </p:sp>
-      <p:pic>
-        <p:nvPicPr>
-          <p:cNvPr id="6" name="Picture 5">
-            <a:extLst>
-              <a:ext uri="{FF2B5EF4-FFF2-40B4-BE49-F238E27FC236}">
-                <a16:creationId xmlns:a16="http://schemas.microsoft.com/office/drawing/2014/main" id="{3B9381F6-7806-D125-37C8-2AE3A688B383}"/>
-              </a:ext>
-            </a:extLst>
-          </p:cNvPr>
-          <p:cNvPicPr>
-            <a:picLocks noChangeAspect="1"/>
-          </p:cNvPicPr>
-          <p:nvPr/>
-        </p:nvPicPr>
-        <p:blipFill>
-          <a:blip r:embed="rId7"/>
-          <a:stretch>
-            <a:fillRect/>
-          </a:stretch>
-        </p:blipFill>
-        <p:spPr>
-          <a:xfrm>
-            <a:off x="8420740" y="2295759"/>
-            <a:ext cx="3639113" cy="3600330"/>
-          </a:xfrm>
-          <a:prstGeom prst="rect">
-            <a:avLst/>
-          </a:prstGeom>
-        </p:spPr>
-      </p:pic>
-      <p:sp>
-        <p:nvSpPr>
-          <p:cNvPr id="11" name="TextBox 10">
-            <a:extLst>
-              <a:ext uri="{FF2B5EF4-FFF2-40B4-BE49-F238E27FC236}">
-                <a16:creationId xmlns:a16="http://schemas.microsoft.com/office/drawing/2014/main" id="{FDD7B0B9-5297-2D50-C1DD-1E1487E33B0C}"/>
-              </a:ext>
-            </a:extLst>
-          </p:cNvPr>
-          <p:cNvSpPr txBox="1"/>
-          <p:nvPr/>
-        </p:nvSpPr>
-        <p:spPr>
-          <a:xfrm>
-            <a:off x="8420740" y="1952370"/>
-            <a:ext cx="3639113" cy="369332"/>
-          </a:xfrm>
-          <a:prstGeom prst="rect">
-            <a:avLst/>
-          </a:prstGeom>
-          <a:noFill/>
-        </p:spPr>
-        <p:txBody>
-          <a:bodyPr wrap="square" rtlCol="0">
-            <a:spAutoFit/>
-          </a:bodyPr>
-          <a:lstStyle/>
-          <a:p>
-            <a:pPr algn="ctr"/>
-            <a:r>
-              <a:rPr lang="en-GB" dirty="0"/>
-              <a:t>Author</a:t>
-            </a:r>
-            <a:r>
-              <a:rPr lang="en-US" dirty="0"/>
-              <a:t> </a:t>
-            </a:r>
-            <a:r>
-              <a:rPr lang="en-GB" dirty="0">
-                <a:solidFill>
-                  <a:prstClr val="black"/>
-                </a:solidFill>
-              </a:rPr>
-              <a:t>feature vector (example) </a:t>
-            </a:r>
-            <a:endParaRPr lang="en-IL" dirty="0"/>
-          </a:p>
-        </p:txBody>
-      </p:sp>
-    </p:spTree>
-    <p:extLst>
-      <p:ext uri="{BB962C8B-B14F-4D97-AF65-F5344CB8AC3E}">
-        <p14:creationId xmlns:p14="http://schemas.microsoft.com/office/powerpoint/2010/main" val="3214639037"/>
-      </p:ext>
-    </p:extLst>
-  </p:cSld>
-  <p:clrMapOvr>
-    <a:masterClrMapping/>
-  </p:clrMapOvr>
-</p:sld>
-</file>
-
-<file path=ppt/slides/slide9.xml><?xml version="1.0" encoding="utf-8"?>
 <p:sld xmlns:a="http://schemas.openxmlformats.org/drawingml/2006/main" xmlns:r="http://schemas.openxmlformats.org/officeDocument/2006/relationships" xmlns:p="http://schemas.openxmlformats.org/presentationml/2006/main">
   <p:cSld>
     <p:spTree>
@@ -21048,7 +20870,7 @@
           <a:p>
             <a:fld id="{E6AB8EDD-9EF2-4633-A1C2-4D908C1019B4}" type="slidenum">
               <a:rPr lang="he-IL" smtClean="0"/>
-              <a:t>9</a:t>
+              <a:t>8</a:t>
             </a:fld>
             <a:endParaRPr lang="he-IL"/>
           </a:p>
@@ -21105,6 +20927,214 @@
     <p:extLst>
       <p:ext uri="{BB962C8B-B14F-4D97-AF65-F5344CB8AC3E}">
         <p14:creationId xmlns:p14="http://schemas.microsoft.com/office/powerpoint/2010/main" val="3011122290"/>
+      </p:ext>
+    </p:extLst>
+  </p:cSld>
+  <p:clrMapOvr>
+    <a:masterClrMapping/>
+  </p:clrMapOvr>
+</p:sld>
+</file>
+
+<file path=ppt/slides/slide9.xml><?xml version="1.0" encoding="utf-8"?>
+<p:sld xmlns:a="http://schemas.openxmlformats.org/drawingml/2006/main" xmlns:r="http://schemas.openxmlformats.org/officeDocument/2006/relationships" xmlns:p="http://schemas.openxmlformats.org/presentationml/2006/main">
+  <p:cSld>
+    <p:spTree>
+      <p:nvGrpSpPr>
+        <p:cNvPr id="1" name="">
+          <a:extLst>
+            <a:ext uri="{FF2B5EF4-FFF2-40B4-BE49-F238E27FC236}">
+              <a16:creationId xmlns:a16="http://schemas.microsoft.com/office/drawing/2014/main" id="{8B90C904-6A27-8E88-FF68-740AA5CCE9F9}"/>
+            </a:ext>
+          </a:extLst>
+        </p:cNvPr>
+        <p:cNvGrpSpPr/>
+        <p:nvPr/>
+      </p:nvGrpSpPr>
+      <p:grpSpPr>
+        <a:xfrm>
+          <a:off x="0" y="0"/>
+          <a:ext cx="0" cy="0"/>
+          <a:chOff x="0" y="0"/>
+          <a:chExt cx="0" cy="0"/>
+        </a:xfrm>
+      </p:grpSpPr>
+      <p:sp>
+        <p:nvSpPr>
+          <p:cNvPr id="2" name="Title 1">
+            <a:extLst>
+              <a:ext uri="{FF2B5EF4-FFF2-40B4-BE49-F238E27FC236}">
+                <a16:creationId xmlns:a16="http://schemas.microsoft.com/office/drawing/2014/main" id="{3C2011DC-22C8-9C10-CE8B-B117FA4DA52A}"/>
+              </a:ext>
+            </a:extLst>
+          </p:cNvPr>
+          <p:cNvSpPr>
+            <a:spLocks noGrp="1"/>
+          </p:cNvSpPr>
+          <p:nvPr>
+            <p:ph type="title"/>
+          </p:nvPr>
+        </p:nvSpPr>
+        <p:spPr/>
+        <p:txBody>
+          <a:bodyPr/>
+          <a:lstStyle/>
+          <a:p>
+            <a:r>
+              <a:rPr lang="en-IL" dirty="0"/>
+              <a:t>Graph Indicators</a:t>
+            </a:r>
+            <a:r>
+              <a:rPr lang="en-US" dirty="0"/>
+              <a:t> Workflow</a:t>
+            </a:r>
+            <a:endParaRPr lang="en-IL" dirty="0"/>
+          </a:p>
+        </p:txBody>
+      </p:sp>
+      <p:graphicFrame>
+        <p:nvGraphicFramePr>
+          <p:cNvPr id="10" name="Content Placeholder 9">
+            <a:extLst>
+              <a:ext uri="{FF2B5EF4-FFF2-40B4-BE49-F238E27FC236}">
+                <a16:creationId xmlns:a16="http://schemas.microsoft.com/office/drawing/2014/main" id="{583CB65E-CDB4-6CBC-AA68-A7C75896264B}"/>
+              </a:ext>
+            </a:extLst>
+          </p:cNvPr>
+          <p:cNvGraphicFramePr>
+            <a:graphicFrameLocks noGrp="1"/>
+          </p:cNvGraphicFramePr>
+          <p:nvPr>
+            <p:ph idx="1"/>
+            <p:extLst>
+              <p:ext uri="{D42A27DB-BD31-4B8C-83A1-F6EECF244321}">
+                <p14:modId xmlns:p14="http://schemas.microsoft.com/office/powerpoint/2010/main" val="1357834038"/>
+              </p:ext>
+            </p:extLst>
+          </p:nvPr>
+        </p:nvGraphicFramePr>
+        <p:xfrm>
+          <a:off x="1243087" y="1575486"/>
+          <a:ext cx="7072620" cy="5130114"/>
+        </p:xfrm>
+        <a:graphic>
+          <a:graphicData uri="http://schemas.openxmlformats.org/drawingml/2006/diagram">
+            <dgm:relIds xmlns:dgm="http://schemas.openxmlformats.org/drawingml/2006/diagram" xmlns:r="http://schemas.openxmlformats.org/officeDocument/2006/relationships" r:dm="rId2" r:lo="rId3" r:qs="rId4" r:cs="rId5"/>
+          </a:graphicData>
+        </a:graphic>
+      </p:graphicFrame>
+      <p:sp>
+        <p:nvSpPr>
+          <p:cNvPr id="4" name="Slide Number Placeholder 3">
+            <a:extLst>
+              <a:ext uri="{FF2B5EF4-FFF2-40B4-BE49-F238E27FC236}">
+                <a16:creationId xmlns:a16="http://schemas.microsoft.com/office/drawing/2014/main" id="{347AFC2A-2F88-85E7-E925-FC99791579F9}"/>
+              </a:ext>
+            </a:extLst>
+          </p:cNvPr>
+          <p:cNvSpPr>
+            <a:spLocks noGrp="1"/>
+          </p:cNvSpPr>
+          <p:nvPr>
+            <p:ph type="sldNum" sz="quarter" idx="12"/>
+          </p:nvPr>
+        </p:nvSpPr>
+        <p:spPr/>
+        <p:txBody>
+          <a:bodyPr/>
+          <a:lstStyle/>
+          <a:p>
+            <a:fld id="{E6AB8EDD-9EF2-4633-A1C2-4D908C1019B4}" type="slidenum">
+              <a:rPr lang="he-IL" smtClean="0"/>
+              <a:t>9</a:t>
+            </a:fld>
+            <a:endParaRPr lang="he-IL"/>
+          </a:p>
+        </p:txBody>
+      </p:sp>
+      <p:pic>
+        <p:nvPicPr>
+          <p:cNvPr id="6" name="Picture 5">
+            <a:extLst>
+              <a:ext uri="{FF2B5EF4-FFF2-40B4-BE49-F238E27FC236}">
+                <a16:creationId xmlns:a16="http://schemas.microsoft.com/office/drawing/2014/main" id="{3B9381F6-7806-D125-37C8-2AE3A688B383}"/>
+              </a:ext>
+            </a:extLst>
+          </p:cNvPr>
+          <p:cNvPicPr>
+            <a:picLocks noChangeAspect="1"/>
+          </p:cNvPicPr>
+          <p:nvPr/>
+        </p:nvPicPr>
+        <p:blipFill>
+          <a:blip r:embed="rId7"/>
+          <a:stretch>
+            <a:fillRect/>
+          </a:stretch>
+        </p:blipFill>
+        <p:spPr>
+          <a:xfrm>
+            <a:off x="8420740" y="2295759"/>
+            <a:ext cx="3639113" cy="3600330"/>
+          </a:xfrm>
+          <a:prstGeom prst="rect">
+            <a:avLst/>
+          </a:prstGeom>
+        </p:spPr>
+      </p:pic>
+      <p:sp>
+        <p:nvSpPr>
+          <p:cNvPr id="11" name="TextBox 10">
+            <a:extLst>
+              <a:ext uri="{FF2B5EF4-FFF2-40B4-BE49-F238E27FC236}">
+                <a16:creationId xmlns:a16="http://schemas.microsoft.com/office/drawing/2014/main" id="{FDD7B0B9-5297-2D50-C1DD-1E1487E33B0C}"/>
+              </a:ext>
+            </a:extLst>
+          </p:cNvPr>
+          <p:cNvSpPr txBox="1"/>
+          <p:nvPr/>
+        </p:nvSpPr>
+        <p:spPr>
+          <a:xfrm>
+            <a:off x="8420740" y="1952370"/>
+            <a:ext cx="3639113" cy="369332"/>
+          </a:xfrm>
+          <a:prstGeom prst="rect">
+            <a:avLst/>
+          </a:prstGeom>
+          <a:noFill/>
+        </p:spPr>
+        <p:txBody>
+          <a:bodyPr wrap="square" rtlCol="0">
+            <a:spAutoFit/>
+          </a:bodyPr>
+          <a:lstStyle/>
+          <a:p>
+            <a:pPr algn="ctr"/>
+            <a:r>
+              <a:rPr lang="en-GB" dirty="0"/>
+              <a:t>Author</a:t>
+            </a:r>
+            <a:r>
+              <a:rPr lang="en-US" dirty="0"/>
+              <a:t> </a:t>
+            </a:r>
+            <a:r>
+              <a:rPr lang="en-GB" dirty="0">
+                <a:solidFill>
+                  <a:prstClr val="black"/>
+                </a:solidFill>
+              </a:rPr>
+              <a:t>feature vector (example) </a:t>
+            </a:r>
+            <a:endParaRPr lang="en-IL" dirty="0"/>
+          </a:p>
+        </p:txBody>
+      </p:sp>
+    </p:spTree>
+    <p:extLst>
+      <p:ext uri="{BB962C8B-B14F-4D97-AF65-F5344CB8AC3E}">
+        <p14:creationId xmlns:p14="http://schemas.microsoft.com/office/powerpoint/2010/main" val="3214639037"/>
       </p:ext>
     </p:extLst>
   </p:cSld>

</xml_diff>